<commit_message>
knit for class 22
</commit_message>
<xml_diff>
--- a/docs/lectures/in-class_activities/class_22.pptx
+++ b/docs/lectures/in-class_activities/class_22.pptx
@@ -5,16 +5,21 @@
     <p:sldMasterId id="2147483648" r:id="rId1"/>
   </p:sldMasterIdLst>
   <p:notesMasterIdLst>
-    <p:notesMasterId r:id="rId9"/>
+    <p:notesMasterId r:id="rId14"/>
   </p:notesMasterIdLst>
   <p:sldIdLst>
     <p:sldId id="480" r:id="rId2"/>
-    <p:sldId id="723" r:id="rId3"/>
-    <p:sldId id="1590" r:id="rId4"/>
-    <p:sldId id="1591" r:id="rId5"/>
-    <p:sldId id="1587" r:id="rId6"/>
-    <p:sldId id="1592" r:id="rId7"/>
-    <p:sldId id="1593" r:id="rId8"/>
+    <p:sldId id="1594" r:id="rId3"/>
+    <p:sldId id="1595" r:id="rId4"/>
+    <p:sldId id="1596" r:id="rId5"/>
+    <p:sldId id="1597" r:id="rId6"/>
+    <p:sldId id="1598" r:id="rId7"/>
+    <p:sldId id="723" r:id="rId8"/>
+    <p:sldId id="1590" r:id="rId9"/>
+    <p:sldId id="1591" r:id="rId10"/>
+    <p:sldId id="1587" r:id="rId11"/>
+    <p:sldId id="1592" r:id="rId12"/>
+    <p:sldId id="1593" r:id="rId13"/>
   </p:sldIdLst>
   <p:sldSz cx="12192000" cy="6858000"/>
   <p:notesSz cx="6858000" cy="9144000"/>
@@ -203,7 +208,7 @@
           <a:p>
             <a:fld id="{6AC7DB66-C6D6-B24E-B345-FA3772C924EA}" type="datetimeFigureOut">
               <a:rPr lang="en-US" smtClean="0"/>
-              <a:t>11/22/21</a:t>
+              <a:t>11/18/25</a:t>
             </a:fld>
             <a:endParaRPr lang="en-US"/>
           </a:p>
@@ -554,7 +559,7 @@
 </p:notes>
 </file>
 
-<file path=ppt/notesSlides/notesSlide2.xml><?xml version="1.0" encoding="utf-8"?>
+<file path=ppt/notesSlides/notesSlide10.xml><?xml version="1.0" encoding="utf-8"?>
 <p:notes xmlns:a="http://schemas.openxmlformats.org/drawingml/2006/main" xmlns:r="http://schemas.openxmlformats.org/officeDocument/2006/relationships" xmlns:p="http://schemas.openxmlformats.org/presentationml/2006/main">
   <p:cSld>
     <p:spTree>
@@ -619,7 +624,7 @@
           <a:p>
             <a:fld id="{4218707C-A528-5347-B512-111D9A72273A}" type="slidenum">
               <a:rPr lang="en-US" smtClean="0"/>
-              <a:t>2</a:t>
+              <a:t>10</a:t>
             </a:fld>
             <a:endParaRPr lang="en-US"/>
           </a:p>
@@ -628,7 +633,7 @@
     </p:spTree>
     <p:extLst>
       <p:ext uri="{BB962C8B-B14F-4D97-AF65-F5344CB8AC3E}">
-        <p14:creationId xmlns:p14="http://schemas.microsoft.com/office/powerpoint/2010/main" val="4229072542"/>
+        <p14:creationId xmlns:p14="http://schemas.microsoft.com/office/powerpoint/2010/main" val="1830605918"/>
       </p:ext>
     </p:extLst>
   </p:cSld>
@@ -638,7 +643,7 @@
 </p:notes>
 </file>
 
-<file path=ppt/notesSlides/notesSlide3.xml><?xml version="1.0" encoding="utf-8"?>
+<file path=ppt/notesSlides/notesSlide11.xml><?xml version="1.0" encoding="utf-8"?>
 <p:notes xmlns:a="http://schemas.openxmlformats.org/drawingml/2006/main" xmlns:r="http://schemas.openxmlformats.org/officeDocument/2006/relationships" xmlns:p="http://schemas.openxmlformats.org/presentationml/2006/main">
   <p:cSld>
     <p:spTree>
@@ -682,7 +687,16 @@
           <a:bodyPr/>
           <a:lstStyle/>
           <a:p>
-            <a:endParaRPr lang="en-US"/>
+            <a:r>
+              <a:rPr lang="en-US"/>
+              <a:t>Name all the possible approaches to malaria control that you can think of, no matter how off-beat.</a:t>
+            </a:r>
+          </a:p>
+          <a:p>
+            <a:r>
+              <a:rPr lang="en-US"/>
+              <a:t>https://www.polleverywhere.com/free_text_polls/vsf2KQkyvrM1PaFnc4kyp</a:t>
+            </a:r>
           </a:p>
         </p:txBody>
       </p:sp>
@@ -703,7 +717,7 @@
           <a:p>
             <a:fld id="{4218707C-A528-5347-B512-111D9A72273A}" type="slidenum">
               <a:rPr lang="en-US" smtClean="0"/>
-              <a:t>3</a:t>
+              <a:t>11</a:t>
             </a:fld>
             <a:endParaRPr lang="en-US"/>
           </a:p>
@@ -712,7 +726,7 @@
     </p:spTree>
     <p:extLst>
       <p:ext uri="{BB962C8B-B14F-4D97-AF65-F5344CB8AC3E}">
-        <p14:creationId xmlns:p14="http://schemas.microsoft.com/office/powerpoint/2010/main" val="1417164617"/>
+        <p14:creationId xmlns:p14="http://schemas.microsoft.com/office/powerpoint/2010/main" val="2272736400"/>
       </p:ext>
     </p:extLst>
   </p:cSld>
@@ -722,7 +736,7 @@
 </p:notes>
 </file>
 
-<file path=ppt/notesSlides/notesSlide4.xml><?xml version="1.0" encoding="utf-8"?>
+<file path=ppt/notesSlides/notesSlide12.xml><?xml version="1.0" encoding="utf-8"?>
 <p:notes xmlns:a="http://schemas.openxmlformats.org/drawingml/2006/main" xmlns:r="http://schemas.openxmlformats.org/officeDocument/2006/relationships" xmlns:p="http://schemas.openxmlformats.org/presentationml/2006/main">
   <p:cSld>
     <p:spTree>
@@ -766,24 +780,7 @@
           <a:bodyPr/>
           <a:lstStyle/>
           <a:p>
-            <a:endParaRPr lang="en-US" dirty="0"/>
-          </a:p>
-          <a:p>
-            <a:r>
-              <a:rPr lang="en-US" dirty="0"/>
-              <a:t>Changes in any attribute of a population over time. </a:t>
-            </a:r>
-          </a:p>
-          <a:p>
-            <a:r>
-              <a:rPr lang="en-US" dirty="0"/>
-              <a:t>Evolutionary</a:t>
-            </a:r>
-            <a:r>
-              <a:rPr lang="en-US" baseline="0" dirty="0"/>
-              <a:t> change leads to adaptation and must involve a change in the frequency of individual genes in a population from generation to generation.</a:t>
-            </a:r>
-            <a:endParaRPr lang="en-US" dirty="0"/>
+            <a:endParaRPr lang="en-US"/>
           </a:p>
         </p:txBody>
       </p:sp>
@@ -794,7 +791,7 @@
             <a:spLocks noGrp="1"/>
           </p:cNvSpPr>
           <p:nvPr>
-            <p:ph type="sldNum" sz="quarter" idx="10"/>
+            <p:ph type="sldNum" sz="quarter" idx="5"/>
           </p:nvPr>
         </p:nvSpPr>
         <p:spPr/>
@@ -802,14 +799,332 @@
           <a:bodyPr/>
           <a:lstStyle/>
           <a:p>
-            <a:pPr>
-              <a:defRPr/>
-            </a:pPr>
-            <a:fld id="{217FB9E2-7C0C-AB45-B0B4-06C6B1BD2B82}" type="slidenum">
+            <a:fld id="{4218707C-A528-5347-B512-111D9A72273A}" type="slidenum">
               <a:rPr lang="en-US" smtClean="0"/>
-              <a:pPr>
-                <a:defRPr/>
-              </a:pPr>
+              <a:t>12</a:t>
+            </a:fld>
+            <a:endParaRPr lang="en-US"/>
+          </a:p>
+        </p:txBody>
+      </p:sp>
+    </p:spTree>
+    <p:extLst>
+      <p:ext uri="{BB962C8B-B14F-4D97-AF65-F5344CB8AC3E}">
+        <p14:creationId xmlns:p14="http://schemas.microsoft.com/office/powerpoint/2010/main" val="951516976"/>
+      </p:ext>
+    </p:extLst>
+  </p:cSld>
+  <p:clrMapOvr>
+    <a:masterClrMapping/>
+  </p:clrMapOvr>
+</p:notes>
+</file>
+
+<file path=ppt/notesSlides/notesSlide2.xml><?xml version="1.0" encoding="utf-8"?>
+<p:notes xmlns:a="http://schemas.openxmlformats.org/drawingml/2006/main" xmlns:r="http://schemas.openxmlformats.org/officeDocument/2006/relationships" xmlns:p="http://schemas.openxmlformats.org/presentationml/2006/main">
+  <p:cSld>
+    <p:spTree>
+      <p:nvGrpSpPr>
+        <p:cNvPr id="1" name="">
+          <a:extLst>
+            <a:ext uri="{FF2B5EF4-FFF2-40B4-BE49-F238E27FC236}">
+              <a16:creationId xmlns:a16="http://schemas.microsoft.com/office/drawing/2014/main" id="{2F59CD1A-C810-49FD-1379-2D57D8DB0A65}"/>
+            </a:ext>
+          </a:extLst>
+        </p:cNvPr>
+        <p:cNvGrpSpPr/>
+        <p:nvPr/>
+      </p:nvGrpSpPr>
+      <p:grpSpPr>
+        <a:xfrm>
+          <a:off x="0" y="0"/>
+          <a:ext cx="0" cy="0"/>
+          <a:chOff x="0" y="0"/>
+          <a:chExt cx="0" cy="0"/>
+        </a:xfrm>
+      </p:grpSpPr>
+      <p:sp>
+        <p:nvSpPr>
+          <p:cNvPr id="2" name="Slide Image Placeholder 1">
+            <a:extLst>
+              <a:ext uri="{FF2B5EF4-FFF2-40B4-BE49-F238E27FC236}">
+                <a16:creationId xmlns:a16="http://schemas.microsoft.com/office/drawing/2014/main" id="{042657E7-3677-958A-F165-47E7D4FCB45A}"/>
+              </a:ext>
+            </a:extLst>
+          </p:cNvPr>
+          <p:cNvSpPr>
+            <a:spLocks noGrp="1" noRot="1" noChangeAspect="1"/>
+          </p:cNvSpPr>
+          <p:nvPr>
+            <p:ph type="sldImg"/>
+          </p:nvPr>
+        </p:nvSpPr>
+        <p:spPr/>
+      </p:sp>
+      <p:sp>
+        <p:nvSpPr>
+          <p:cNvPr id="3" name="Notes Placeholder 2">
+            <a:extLst>
+              <a:ext uri="{FF2B5EF4-FFF2-40B4-BE49-F238E27FC236}">
+                <a16:creationId xmlns:a16="http://schemas.microsoft.com/office/drawing/2014/main" id="{0396A094-12F8-BF06-098C-0D9736A9B699}"/>
+              </a:ext>
+            </a:extLst>
+          </p:cNvPr>
+          <p:cNvSpPr>
+            <a:spLocks noGrp="1"/>
+          </p:cNvSpPr>
+          <p:nvPr>
+            <p:ph type="body" idx="1"/>
+          </p:nvPr>
+        </p:nvSpPr>
+        <p:spPr/>
+        <p:txBody>
+          <a:bodyPr/>
+          <a:lstStyle/>
+          <a:p>
+            <a:endParaRPr lang="en-US"/>
+          </a:p>
+        </p:txBody>
+      </p:sp>
+      <p:sp>
+        <p:nvSpPr>
+          <p:cNvPr id="4" name="Slide Number Placeholder 3">
+            <a:extLst>
+              <a:ext uri="{FF2B5EF4-FFF2-40B4-BE49-F238E27FC236}">
+                <a16:creationId xmlns:a16="http://schemas.microsoft.com/office/drawing/2014/main" id="{BA1739EB-6D04-5E3A-AEBD-EA8E4DD52313}"/>
+              </a:ext>
+            </a:extLst>
+          </p:cNvPr>
+          <p:cNvSpPr>
+            <a:spLocks noGrp="1"/>
+          </p:cNvSpPr>
+          <p:nvPr>
+            <p:ph type="sldNum" sz="quarter" idx="5"/>
+          </p:nvPr>
+        </p:nvSpPr>
+        <p:spPr/>
+        <p:txBody>
+          <a:bodyPr/>
+          <a:lstStyle/>
+          <a:p>
+            <a:fld id="{4218707C-A528-5347-B512-111D9A72273A}" type="slidenum">
+              <a:rPr lang="en-US" smtClean="0"/>
+              <a:t>2</a:t>
+            </a:fld>
+            <a:endParaRPr lang="en-US"/>
+          </a:p>
+        </p:txBody>
+      </p:sp>
+    </p:spTree>
+    <p:extLst>
+      <p:ext uri="{BB962C8B-B14F-4D97-AF65-F5344CB8AC3E}">
+        <p14:creationId xmlns:p14="http://schemas.microsoft.com/office/powerpoint/2010/main" val="52968606"/>
+      </p:ext>
+    </p:extLst>
+  </p:cSld>
+  <p:clrMapOvr>
+    <a:masterClrMapping/>
+  </p:clrMapOvr>
+</p:notes>
+</file>
+
+<file path=ppt/notesSlides/notesSlide3.xml><?xml version="1.0" encoding="utf-8"?>
+<p:notes xmlns:a="http://schemas.openxmlformats.org/drawingml/2006/main" xmlns:r="http://schemas.openxmlformats.org/officeDocument/2006/relationships" xmlns:p="http://schemas.openxmlformats.org/presentationml/2006/main">
+  <p:cSld>
+    <p:spTree>
+      <p:nvGrpSpPr>
+        <p:cNvPr id="1" name="">
+          <a:extLst>
+            <a:ext uri="{FF2B5EF4-FFF2-40B4-BE49-F238E27FC236}">
+              <a16:creationId xmlns:a16="http://schemas.microsoft.com/office/drawing/2014/main" id="{F8900ED7-760F-F576-5E3D-B650E551959C}"/>
+            </a:ext>
+          </a:extLst>
+        </p:cNvPr>
+        <p:cNvGrpSpPr/>
+        <p:nvPr/>
+      </p:nvGrpSpPr>
+      <p:grpSpPr>
+        <a:xfrm>
+          <a:off x="0" y="0"/>
+          <a:ext cx="0" cy="0"/>
+          <a:chOff x="0" y="0"/>
+          <a:chExt cx="0" cy="0"/>
+        </a:xfrm>
+      </p:grpSpPr>
+      <p:sp>
+        <p:nvSpPr>
+          <p:cNvPr id="2" name="Slide Image Placeholder 1">
+            <a:extLst>
+              <a:ext uri="{FF2B5EF4-FFF2-40B4-BE49-F238E27FC236}">
+                <a16:creationId xmlns:a16="http://schemas.microsoft.com/office/drawing/2014/main" id="{35D845FC-6DE4-05D5-D60C-608B6D1BADA7}"/>
+              </a:ext>
+            </a:extLst>
+          </p:cNvPr>
+          <p:cNvSpPr>
+            <a:spLocks noGrp="1" noRot="1" noChangeAspect="1"/>
+          </p:cNvSpPr>
+          <p:nvPr>
+            <p:ph type="sldImg"/>
+          </p:nvPr>
+        </p:nvSpPr>
+        <p:spPr/>
+      </p:sp>
+      <p:sp>
+        <p:nvSpPr>
+          <p:cNvPr id="3" name="Notes Placeholder 2">
+            <a:extLst>
+              <a:ext uri="{FF2B5EF4-FFF2-40B4-BE49-F238E27FC236}">
+                <a16:creationId xmlns:a16="http://schemas.microsoft.com/office/drawing/2014/main" id="{877AE808-EB79-CAA5-0404-ADECA488B6CD}"/>
+              </a:ext>
+            </a:extLst>
+          </p:cNvPr>
+          <p:cNvSpPr>
+            <a:spLocks noGrp="1"/>
+          </p:cNvSpPr>
+          <p:nvPr>
+            <p:ph type="body" idx="1"/>
+          </p:nvPr>
+        </p:nvSpPr>
+        <p:spPr/>
+        <p:txBody>
+          <a:bodyPr/>
+          <a:lstStyle/>
+          <a:p>
+            <a:endParaRPr lang="en-US"/>
+          </a:p>
+        </p:txBody>
+      </p:sp>
+      <p:sp>
+        <p:nvSpPr>
+          <p:cNvPr id="4" name="Slide Number Placeholder 3">
+            <a:extLst>
+              <a:ext uri="{FF2B5EF4-FFF2-40B4-BE49-F238E27FC236}">
+                <a16:creationId xmlns:a16="http://schemas.microsoft.com/office/drawing/2014/main" id="{27EEA904-C069-B1F4-D9EF-EFA804DD3D90}"/>
+              </a:ext>
+            </a:extLst>
+          </p:cNvPr>
+          <p:cNvSpPr>
+            <a:spLocks noGrp="1"/>
+          </p:cNvSpPr>
+          <p:nvPr>
+            <p:ph type="sldNum" sz="quarter" idx="5"/>
+          </p:nvPr>
+        </p:nvSpPr>
+        <p:spPr/>
+        <p:txBody>
+          <a:bodyPr/>
+          <a:lstStyle/>
+          <a:p>
+            <a:fld id="{4218707C-A528-5347-B512-111D9A72273A}" type="slidenum">
+              <a:rPr lang="en-US" smtClean="0"/>
+              <a:t>3</a:t>
+            </a:fld>
+            <a:endParaRPr lang="en-US"/>
+          </a:p>
+        </p:txBody>
+      </p:sp>
+    </p:spTree>
+    <p:extLst>
+      <p:ext uri="{BB962C8B-B14F-4D97-AF65-F5344CB8AC3E}">
+        <p14:creationId xmlns:p14="http://schemas.microsoft.com/office/powerpoint/2010/main" val="2850239326"/>
+      </p:ext>
+    </p:extLst>
+  </p:cSld>
+  <p:clrMapOvr>
+    <a:masterClrMapping/>
+  </p:clrMapOvr>
+</p:notes>
+</file>
+
+<file path=ppt/notesSlides/notesSlide4.xml><?xml version="1.0" encoding="utf-8"?>
+<p:notes xmlns:a="http://schemas.openxmlformats.org/drawingml/2006/main" xmlns:r="http://schemas.openxmlformats.org/officeDocument/2006/relationships" xmlns:p="http://schemas.openxmlformats.org/presentationml/2006/main">
+  <p:cSld>
+    <p:spTree>
+      <p:nvGrpSpPr>
+        <p:cNvPr id="1" name="">
+          <a:extLst>
+            <a:ext uri="{FF2B5EF4-FFF2-40B4-BE49-F238E27FC236}">
+              <a16:creationId xmlns:a16="http://schemas.microsoft.com/office/drawing/2014/main" id="{E199321C-3443-E703-49F7-69CAF47D6101}"/>
+            </a:ext>
+          </a:extLst>
+        </p:cNvPr>
+        <p:cNvGrpSpPr/>
+        <p:nvPr/>
+      </p:nvGrpSpPr>
+      <p:grpSpPr>
+        <a:xfrm>
+          <a:off x="0" y="0"/>
+          <a:ext cx="0" cy="0"/>
+          <a:chOff x="0" y="0"/>
+          <a:chExt cx="0" cy="0"/>
+        </a:xfrm>
+      </p:grpSpPr>
+      <p:sp>
+        <p:nvSpPr>
+          <p:cNvPr id="2" name="Slide Image Placeholder 1">
+            <a:extLst>
+              <a:ext uri="{FF2B5EF4-FFF2-40B4-BE49-F238E27FC236}">
+                <a16:creationId xmlns:a16="http://schemas.microsoft.com/office/drawing/2014/main" id="{2A40E0C7-802F-AABF-B53E-8D01F7AE3C7E}"/>
+              </a:ext>
+            </a:extLst>
+          </p:cNvPr>
+          <p:cNvSpPr>
+            <a:spLocks noGrp="1" noRot="1" noChangeAspect="1"/>
+          </p:cNvSpPr>
+          <p:nvPr>
+            <p:ph type="sldImg"/>
+          </p:nvPr>
+        </p:nvSpPr>
+        <p:spPr/>
+      </p:sp>
+      <p:sp>
+        <p:nvSpPr>
+          <p:cNvPr id="3" name="Notes Placeholder 2">
+            <a:extLst>
+              <a:ext uri="{FF2B5EF4-FFF2-40B4-BE49-F238E27FC236}">
+                <a16:creationId xmlns:a16="http://schemas.microsoft.com/office/drawing/2014/main" id="{3CE6159E-4BE6-182A-1C8E-034F7E7F0F59}"/>
+              </a:ext>
+            </a:extLst>
+          </p:cNvPr>
+          <p:cNvSpPr>
+            <a:spLocks noGrp="1"/>
+          </p:cNvSpPr>
+          <p:nvPr>
+            <p:ph type="body" idx="1"/>
+          </p:nvPr>
+        </p:nvSpPr>
+        <p:spPr/>
+        <p:txBody>
+          <a:bodyPr/>
+          <a:lstStyle/>
+          <a:p>
+            <a:endParaRPr lang="en-US"/>
+          </a:p>
+        </p:txBody>
+      </p:sp>
+      <p:sp>
+        <p:nvSpPr>
+          <p:cNvPr id="4" name="Slide Number Placeholder 3">
+            <a:extLst>
+              <a:ext uri="{FF2B5EF4-FFF2-40B4-BE49-F238E27FC236}">
+                <a16:creationId xmlns:a16="http://schemas.microsoft.com/office/drawing/2014/main" id="{5D86F2EC-EC0B-7B16-C7D9-A92CC696B86D}"/>
+              </a:ext>
+            </a:extLst>
+          </p:cNvPr>
+          <p:cNvSpPr>
+            <a:spLocks noGrp="1"/>
+          </p:cNvSpPr>
+          <p:nvPr>
+            <p:ph type="sldNum" sz="quarter" idx="5"/>
+          </p:nvPr>
+        </p:nvSpPr>
+        <p:spPr/>
+        <p:txBody>
+          <a:bodyPr/>
+          <a:lstStyle/>
+          <a:p>
+            <a:fld id="{4218707C-A528-5347-B512-111D9A72273A}" type="slidenum">
+              <a:rPr lang="en-US" smtClean="0"/>
               <a:t>4</a:t>
             </a:fld>
             <a:endParaRPr lang="en-US"/>
@@ -819,7 +1134,7 @@
     </p:spTree>
     <p:extLst>
       <p:ext uri="{BB962C8B-B14F-4D97-AF65-F5344CB8AC3E}">
-        <p14:creationId xmlns:p14="http://schemas.microsoft.com/office/powerpoint/2010/main" val="551942649"/>
+        <p14:creationId xmlns:p14="http://schemas.microsoft.com/office/powerpoint/2010/main" val="3770379805"/>
       </p:ext>
     </p:extLst>
   </p:cSld>
@@ -834,7 +1149,13 @@
   <p:cSld>
     <p:spTree>
       <p:nvGrpSpPr>
-        <p:cNvPr id="1" name=""/>
+        <p:cNvPr id="1" name="">
+          <a:extLst>
+            <a:ext uri="{FF2B5EF4-FFF2-40B4-BE49-F238E27FC236}">
+              <a16:creationId xmlns:a16="http://schemas.microsoft.com/office/drawing/2014/main" id="{03917AE8-F338-E0C9-0E18-228CA0654BD7}"/>
+            </a:ext>
+          </a:extLst>
+        </p:cNvPr>
         <p:cNvGrpSpPr/>
         <p:nvPr/>
       </p:nvGrpSpPr>
@@ -848,7 +1169,13 @@
       </p:grpSpPr>
       <p:sp>
         <p:nvSpPr>
-          <p:cNvPr id="2" name="Slide Image Placeholder 1"/>
+          <p:cNvPr id="2" name="Slide Image Placeholder 1">
+            <a:extLst>
+              <a:ext uri="{FF2B5EF4-FFF2-40B4-BE49-F238E27FC236}">
+                <a16:creationId xmlns:a16="http://schemas.microsoft.com/office/drawing/2014/main" id="{00E86FE6-BAC5-3501-459A-83AE558E3922}"/>
+              </a:ext>
+            </a:extLst>
+          </p:cNvPr>
           <p:cNvSpPr>
             <a:spLocks noGrp="1" noRot="1" noChangeAspect="1"/>
           </p:cNvSpPr>
@@ -860,7 +1187,13 @@
       </p:sp>
       <p:sp>
         <p:nvSpPr>
-          <p:cNvPr id="3" name="Notes Placeholder 2"/>
+          <p:cNvPr id="3" name="Notes Placeholder 2">
+            <a:extLst>
+              <a:ext uri="{FF2B5EF4-FFF2-40B4-BE49-F238E27FC236}">
+                <a16:creationId xmlns:a16="http://schemas.microsoft.com/office/drawing/2014/main" id="{670E8B48-8DC2-D975-5B9C-C72DA12F1F91}"/>
+              </a:ext>
+            </a:extLst>
+          </p:cNvPr>
           <p:cNvSpPr>
             <a:spLocks noGrp="1"/>
           </p:cNvSpPr>
@@ -879,7 +1212,13 @@
       </p:sp>
       <p:sp>
         <p:nvSpPr>
-          <p:cNvPr id="4" name="Slide Number Placeholder 3"/>
+          <p:cNvPr id="4" name="Slide Number Placeholder 3">
+            <a:extLst>
+              <a:ext uri="{FF2B5EF4-FFF2-40B4-BE49-F238E27FC236}">
+                <a16:creationId xmlns:a16="http://schemas.microsoft.com/office/drawing/2014/main" id="{29029035-4079-374D-0D7B-75FCFE87AE79}"/>
+              </a:ext>
+            </a:extLst>
+          </p:cNvPr>
           <p:cNvSpPr>
             <a:spLocks noGrp="1"/>
           </p:cNvSpPr>
@@ -903,7 +1242,7 @@
     </p:spTree>
     <p:extLst>
       <p:ext uri="{BB962C8B-B14F-4D97-AF65-F5344CB8AC3E}">
-        <p14:creationId xmlns:p14="http://schemas.microsoft.com/office/powerpoint/2010/main" val="1830605918"/>
+        <p14:creationId xmlns:p14="http://schemas.microsoft.com/office/powerpoint/2010/main" val="1069863724"/>
       </p:ext>
     </p:extLst>
   </p:cSld>
@@ -918,7 +1257,13 @@
   <p:cSld>
     <p:spTree>
       <p:nvGrpSpPr>
-        <p:cNvPr id="1" name=""/>
+        <p:cNvPr id="1" name="">
+          <a:extLst>
+            <a:ext uri="{FF2B5EF4-FFF2-40B4-BE49-F238E27FC236}">
+              <a16:creationId xmlns:a16="http://schemas.microsoft.com/office/drawing/2014/main" id="{1AF94943-0A6B-2333-1918-756B9EC9734B}"/>
+            </a:ext>
+          </a:extLst>
+        </p:cNvPr>
         <p:cNvGrpSpPr/>
         <p:nvPr/>
       </p:nvGrpSpPr>
@@ -932,7 +1277,13 @@
       </p:grpSpPr>
       <p:sp>
         <p:nvSpPr>
-          <p:cNvPr id="2" name="Slide Image Placeholder 1"/>
+          <p:cNvPr id="2" name="Slide Image Placeholder 1">
+            <a:extLst>
+              <a:ext uri="{FF2B5EF4-FFF2-40B4-BE49-F238E27FC236}">
+                <a16:creationId xmlns:a16="http://schemas.microsoft.com/office/drawing/2014/main" id="{2C1A22EE-09FA-DB7C-3B8E-CC8E30252BBB}"/>
+              </a:ext>
+            </a:extLst>
+          </p:cNvPr>
           <p:cNvSpPr>
             <a:spLocks noGrp="1" noRot="1" noChangeAspect="1"/>
           </p:cNvSpPr>
@@ -944,7 +1295,13 @@
       </p:sp>
       <p:sp>
         <p:nvSpPr>
-          <p:cNvPr id="3" name="Notes Placeholder 2"/>
+          <p:cNvPr id="3" name="Notes Placeholder 2">
+            <a:extLst>
+              <a:ext uri="{FF2B5EF4-FFF2-40B4-BE49-F238E27FC236}">
+                <a16:creationId xmlns:a16="http://schemas.microsoft.com/office/drawing/2014/main" id="{6B4DCF34-79D1-859D-5441-71A6B274702E}"/>
+              </a:ext>
+            </a:extLst>
+          </p:cNvPr>
           <p:cNvSpPr>
             <a:spLocks noGrp="1"/>
           </p:cNvSpPr>
@@ -957,22 +1314,19 @@
           <a:bodyPr/>
           <a:lstStyle/>
           <a:p>
-            <a:r>
-              <a:rPr lang="en-US"/>
-              <a:t>Name all the possible approaches to malaria control that you can think of, no matter how off-beat.</a:t>
-            </a:r>
-          </a:p>
-          <a:p>
-            <a:r>
-              <a:rPr lang="en-US"/>
-              <a:t>https://www.polleverywhere.com/free_text_polls/vsf2KQkyvrM1PaFnc4kyp</a:t>
-            </a:r>
-          </a:p>
-        </p:txBody>
-      </p:sp>
-      <p:sp>
-        <p:nvSpPr>
-          <p:cNvPr id="4" name="Slide Number Placeholder 3"/>
+            <a:endParaRPr lang="en-US"/>
+          </a:p>
+        </p:txBody>
+      </p:sp>
+      <p:sp>
+        <p:nvSpPr>
+          <p:cNvPr id="4" name="Slide Number Placeholder 3">
+            <a:extLst>
+              <a:ext uri="{FF2B5EF4-FFF2-40B4-BE49-F238E27FC236}">
+                <a16:creationId xmlns:a16="http://schemas.microsoft.com/office/drawing/2014/main" id="{ED0873B5-CAE9-270D-F7D2-F555F6449780}"/>
+              </a:ext>
+            </a:extLst>
+          </p:cNvPr>
           <p:cNvSpPr>
             <a:spLocks noGrp="1"/>
           </p:cNvSpPr>
@@ -996,7 +1350,7 @@
     </p:spTree>
     <p:extLst>
       <p:ext uri="{BB962C8B-B14F-4D97-AF65-F5344CB8AC3E}">
-        <p14:creationId xmlns:p14="http://schemas.microsoft.com/office/powerpoint/2010/main" val="2272736400"/>
+        <p14:creationId xmlns:p14="http://schemas.microsoft.com/office/powerpoint/2010/main" val="3475602434"/>
       </p:ext>
     </p:extLst>
   </p:cSld>
@@ -1080,7 +1434,198 @@
     </p:spTree>
     <p:extLst>
       <p:ext uri="{BB962C8B-B14F-4D97-AF65-F5344CB8AC3E}">
-        <p14:creationId xmlns:p14="http://schemas.microsoft.com/office/powerpoint/2010/main" val="951516976"/>
+        <p14:creationId xmlns:p14="http://schemas.microsoft.com/office/powerpoint/2010/main" val="4229072542"/>
+      </p:ext>
+    </p:extLst>
+  </p:cSld>
+  <p:clrMapOvr>
+    <a:masterClrMapping/>
+  </p:clrMapOvr>
+</p:notes>
+</file>
+
+<file path=ppt/notesSlides/notesSlide8.xml><?xml version="1.0" encoding="utf-8"?>
+<p:notes xmlns:a="http://schemas.openxmlformats.org/drawingml/2006/main" xmlns:r="http://schemas.openxmlformats.org/officeDocument/2006/relationships" xmlns:p="http://schemas.openxmlformats.org/presentationml/2006/main">
+  <p:cSld>
+    <p:spTree>
+      <p:nvGrpSpPr>
+        <p:cNvPr id="1" name=""/>
+        <p:cNvGrpSpPr/>
+        <p:nvPr/>
+      </p:nvGrpSpPr>
+      <p:grpSpPr>
+        <a:xfrm>
+          <a:off x="0" y="0"/>
+          <a:ext cx="0" cy="0"/>
+          <a:chOff x="0" y="0"/>
+          <a:chExt cx="0" cy="0"/>
+        </a:xfrm>
+      </p:grpSpPr>
+      <p:sp>
+        <p:nvSpPr>
+          <p:cNvPr id="2" name="Slide Image Placeholder 1"/>
+          <p:cNvSpPr>
+            <a:spLocks noGrp="1" noRot="1" noChangeAspect="1"/>
+          </p:cNvSpPr>
+          <p:nvPr>
+            <p:ph type="sldImg"/>
+          </p:nvPr>
+        </p:nvSpPr>
+        <p:spPr/>
+      </p:sp>
+      <p:sp>
+        <p:nvSpPr>
+          <p:cNvPr id="3" name="Notes Placeholder 2"/>
+          <p:cNvSpPr>
+            <a:spLocks noGrp="1"/>
+          </p:cNvSpPr>
+          <p:nvPr>
+            <p:ph type="body" idx="1"/>
+          </p:nvPr>
+        </p:nvSpPr>
+        <p:spPr/>
+        <p:txBody>
+          <a:bodyPr/>
+          <a:lstStyle/>
+          <a:p>
+            <a:endParaRPr lang="en-US"/>
+          </a:p>
+        </p:txBody>
+      </p:sp>
+      <p:sp>
+        <p:nvSpPr>
+          <p:cNvPr id="4" name="Slide Number Placeholder 3"/>
+          <p:cNvSpPr>
+            <a:spLocks noGrp="1"/>
+          </p:cNvSpPr>
+          <p:nvPr>
+            <p:ph type="sldNum" sz="quarter" idx="5"/>
+          </p:nvPr>
+        </p:nvSpPr>
+        <p:spPr/>
+        <p:txBody>
+          <a:bodyPr/>
+          <a:lstStyle/>
+          <a:p>
+            <a:fld id="{4218707C-A528-5347-B512-111D9A72273A}" type="slidenum">
+              <a:rPr lang="en-US" smtClean="0"/>
+              <a:t>8</a:t>
+            </a:fld>
+            <a:endParaRPr lang="en-US"/>
+          </a:p>
+        </p:txBody>
+      </p:sp>
+    </p:spTree>
+    <p:extLst>
+      <p:ext uri="{BB962C8B-B14F-4D97-AF65-F5344CB8AC3E}">
+        <p14:creationId xmlns:p14="http://schemas.microsoft.com/office/powerpoint/2010/main" val="1417164617"/>
+      </p:ext>
+    </p:extLst>
+  </p:cSld>
+  <p:clrMapOvr>
+    <a:masterClrMapping/>
+  </p:clrMapOvr>
+</p:notes>
+</file>
+
+<file path=ppt/notesSlides/notesSlide9.xml><?xml version="1.0" encoding="utf-8"?>
+<p:notes xmlns:a="http://schemas.openxmlformats.org/drawingml/2006/main" xmlns:r="http://schemas.openxmlformats.org/officeDocument/2006/relationships" xmlns:p="http://schemas.openxmlformats.org/presentationml/2006/main">
+  <p:cSld>
+    <p:spTree>
+      <p:nvGrpSpPr>
+        <p:cNvPr id="1" name=""/>
+        <p:cNvGrpSpPr/>
+        <p:nvPr/>
+      </p:nvGrpSpPr>
+      <p:grpSpPr>
+        <a:xfrm>
+          <a:off x="0" y="0"/>
+          <a:ext cx="0" cy="0"/>
+          <a:chOff x="0" y="0"/>
+          <a:chExt cx="0" cy="0"/>
+        </a:xfrm>
+      </p:grpSpPr>
+      <p:sp>
+        <p:nvSpPr>
+          <p:cNvPr id="2" name="Slide Image Placeholder 1"/>
+          <p:cNvSpPr>
+            <a:spLocks noGrp="1" noRot="1" noChangeAspect="1"/>
+          </p:cNvSpPr>
+          <p:nvPr>
+            <p:ph type="sldImg"/>
+          </p:nvPr>
+        </p:nvSpPr>
+        <p:spPr/>
+      </p:sp>
+      <p:sp>
+        <p:nvSpPr>
+          <p:cNvPr id="3" name="Notes Placeholder 2"/>
+          <p:cNvSpPr>
+            <a:spLocks noGrp="1"/>
+          </p:cNvSpPr>
+          <p:nvPr>
+            <p:ph type="body" idx="1"/>
+          </p:nvPr>
+        </p:nvSpPr>
+        <p:spPr/>
+        <p:txBody>
+          <a:bodyPr/>
+          <a:lstStyle/>
+          <a:p>
+            <a:endParaRPr lang="en-US" dirty="0"/>
+          </a:p>
+          <a:p>
+            <a:r>
+              <a:rPr lang="en-US" dirty="0"/>
+              <a:t>Changes in any attribute of a population over time. </a:t>
+            </a:r>
+          </a:p>
+          <a:p>
+            <a:r>
+              <a:rPr lang="en-US" dirty="0"/>
+              <a:t>Evolutionary</a:t>
+            </a:r>
+            <a:r>
+              <a:rPr lang="en-US" baseline="0" dirty="0"/>
+              <a:t> change leads to adaptation and must involve a change in the frequency of individual genes in a population from generation to generation.</a:t>
+            </a:r>
+            <a:endParaRPr lang="en-US" dirty="0"/>
+          </a:p>
+        </p:txBody>
+      </p:sp>
+      <p:sp>
+        <p:nvSpPr>
+          <p:cNvPr id="4" name="Slide Number Placeholder 3"/>
+          <p:cNvSpPr>
+            <a:spLocks noGrp="1"/>
+          </p:cNvSpPr>
+          <p:nvPr>
+            <p:ph type="sldNum" sz="quarter" idx="10"/>
+          </p:nvPr>
+        </p:nvSpPr>
+        <p:spPr/>
+        <p:txBody>
+          <a:bodyPr/>
+          <a:lstStyle/>
+          <a:p>
+            <a:pPr>
+              <a:defRPr/>
+            </a:pPr>
+            <a:fld id="{217FB9E2-7C0C-AB45-B0B4-06C6B1BD2B82}" type="slidenum">
+              <a:rPr lang="en-US" smtClean="0"/>
+              <a:pPr>
+                <a:defRPr/>
+              </a:pPr>
+              <a:t>9</a:t>
+            </a:fld>
+            <a:endParaRPr lang="en-US"/>
+          </a:p>
+        </p:txBody>
+      </p:sp>
+    </p:spTree>
+    <p:extLst>
+      <p:ext uri="{BB962C8B-B14F-4D97-AF65-F5344CB8AC3E}">
+        <p14:creationId xmlns:p14="http://schemas.microsoft.com/office/powerpoint/2010/main" val="551942649"/>
       </p:ext>
     </p:extLst>
   </p:cSld>
@@ -1237,7 +1782,7 @@
           <a:p>
             <a:fld id="{21DDE3A9-9D48-7D40-AF95-520AE186EA5D}" type="datetimeFigureOut">
               <a:rPr lang="en-US" smtClean="0"/>
-              <a:t>11/22/21</a:t>
+              <a:t>11/18/25</a:t>
             </a:fld>
             <a:endParaRPr lang="en-US"/>
           </a:p>
@@ -1435,7 +1980,7 @@
           <a:p>
             <a:fld id="{21DDE3A9-9D48-7D40-AF95-520AE186EA5D}" type="datetimeFigureOut">
               <a:rPr lang="en-US" smtClean="0"/>
-              <a:t>11/22/21</a:t>
+              <a:t>11/18/25</a:t>
             </a:fld>
             <a:endParaRPr lang="en-US"/>
           </a:p>
@@ -1643,7 +2188,7 @@
           <a:p>
             <a:fld id="{21DDE3A9-9D48-7D40-AF95-520AE186EA5D}" type="datetimeFigureOut">
               <a:rPr lang="en-US" smtClean="0"/>
-              <a:t>11/22/21</a:t>
+              <a:t>11/18/25</a:t>
             </a:fld>
             <a:endParaRPr lang="en-US"/>
           </a:p>
@@ -1841,7 +2386,7 @@
           <a:p>
             <a:fld id="{21DDE3A9-9D48-7D40-AF95-520AE186EA5D}" type="datetimeFigureOut">
               <a:rPr lang="en-US" smtClean="0"/>
-              <a:t>11/22/21</a:t>
+              <a:t>11/18/25</a:t>
             </a:fld>
             <a:endParaRPr lang="en-US"/>
           </a:p>
@@ -2116,7 +2661,7 @@
           <a:p>
             <a:fld id="{21DDE3A9-9D48-7D40-AF95-520AE186EA5D}" type="datetimeFigureOut">
               <a:rPr lang="en-US" smtClean="0"/>
-              <a:t>11/22/21</a:t>
+              <a:t>11/18/25</a:t>
             </a:fld>
             <a:endParaRPr lang="en-US"/>
           </a:p>
@@ -2381,7 +2926,7 @@
           <a:p>
             <a:fld id="{21DDE3A9-9D48-7D40-AF95-520AE186EA5D}" type="datetimeFigureOut">
               <a:rPr lang="en-US" smtClean="0"/>
-              <a:t>11/22/21</a:t>
+              <a:t>11/18/25</a:t>
             </a:fld>
             <a:endParaRPr lang="en-US"/>
           </a:p>
@@ -2793,7 +3338,7 @@
           <a:p>
             <a:fld id="{21DDE3A9-9D48-7D40-AF95-520AE186EA5D}" type="datetimeFigureOut">
               <a:rPr lang="en-US" smtClean="0"/>
-              <a:t>11/22/21</a:t>
+              <a:t>11/18/25</a:t>
             </a:fld>
             <a:endParaRPr lang="en-US"/>
           </a:p>
@@ -2934,7 +3479,7 @@
           <a:p>
             <a:fld id="{21DDE3A9-9D48-7D40-AF95-520AE186EA5D}" type="datetimeFigureOut">
               <a:rPr lang="en-US" smtClean="0"/>
-              <a:t>11/22/21</a:t>
+              <a:t>11/18/25</a:t>
             </a:fld>
             <a:endParaRPr lang="en-US"/>
           </a:p>
@@ -3047,7 +3592,7 @@
           <a:p>
             <a:fld id="{21DDE3A9-9D48-7D40-AF95-520AE186EA5D}" type="datetimeFigureOut">
               <a:rPr lang="en-US" smtClean="0"/>
-              <a:t>11/22/21</a:t>
+              <a:t>11/18/25</a:t>
             </a:fld>
             <a:endParaRPr lang="en-US"/>
           </a:p>
@@ -3358,7 +3903,7 @@
           <a:p>
             <a:fld id="{21DDE3A9-9D48-7D40-AF95-520AE186EA5D}" type="datetimeFigureOut">
               <a:rPr lang="en-US" smtClean="0"/>
-              <a:t>11/22/21</a:t>
+              <a:t>11/18/25</a:t>
             </a:fld>
             <a:endParaRPr lang="en-US"/>
           </a:p>
@@ -3646,7 +4191,7 @@
           <a:p>
             <a:fld id="{21DDE3A9-9D48-7D40-AF95-520AE186EA5D}" type="datetimeFigureOut">
               <a:rPr lang="en-US" smtClean="0"/>
-              <a:t>11/22/21</a:t>
+              <a:t>11/18/25</a:t>
             </a:fld>
             <a:endParaRPr lang="en-US"/>
           </a:p>
@@ -3887,7 +4432,7 @@
           <a:p>
             <a:fld id="{21DDE3A9-9D48-7D40-AF95-520AE186EA5D}" type="datetimeFigureOut">
               <a:rPr lang="en-US" smtClean="0"/>
-              <a:t>11/22/21</a:t>
+              <a:t>11/18/25</a:t>
             </a:fld>
             <a:endParaRPr lang="en-US"/>
           </a:p>
@@ -4406,7 +4951,2247 @@
 </p:sld>
 </file>
 
+<file path=ppt/slides/slide10.xml><?xml version="1.0" encoding="utf-8"?>
+<p:sld xmlns:a="http://schemas.openxmlformats.org/drawingml/2006/main" xmlns:r="http://schemas.openxmlformats.org/officeDocument/2006/relationships" xmlns:p="http://schemas.openxmlformats.org/presentationml/2006/main">
+  <p:cSld>
+    <p:spTree>
+      <p:nvGrpSpPr>
+        <p:cNvPr id="1" name=""/>
+        <p:cNvGrpSpPr/>
+        <p:nvPr/>
+      </p:nvGrpSpPr>
+      <p:grpSpPr>
+        <a:xfrm>
+          <a:off x="0" y="0"/>
+          <a:ext cx="0" cy="0"/>
+          <a:chOff x="0" y="0"/>
+          <a:chExt cx="0" cy="0"/>
+        </a:xfrm>
+      </p:grpSpPr>
+      <p:sp>
+        <p:nvSpPr>
+          <p:cNvPr id="3" name="Rectangle 2"/>
+          <p:cNvSpPr>
+            <a:spLocks noChangeArrowheads="1"/>
+          </p:cNvSpPr>
+          <p:nvPr/>
+        </p:nvSpPr>
+        <p:spPr bwMode="auto">
+          <a:xfrm>
+            <a:off x="1290725" y="2132881"/>
+            <a:ext cx="9610544" cy="1938992"/>
+          </a:xfrm>
+          <a:prstGeom prst="rect">
+            <a:avLst/>
+          </a:prstGeom>
+          <a:noFill/>
+          <a:ln w="9525">
+            <a:noFill/>
+            <a:miter lim="800000"/>
+            <a:headEnd/>
+            <a:tailEnd/>
+          </a:ln>
+          <a:effectLst/>
+        </p:spPr>
+        <p:txBody>
+          <a:bodyPr wrap="square">
+            <a:spAutoFit/>
+          </a:bodyPr>
+          <a:lstStyle/>
+          <a:p>
+            <a:pPr>
+              <a:defRPr/>
+            </a:pPr>
+            <a:r>
+              <a:rPr lang="en-US" sz="4000" b="1" dirty="0">
+                <a:latin typeface="Avenir"/>
+                <a:cs typeface="Avenir"/>
+              </a:rPr>
+              <a:t>Q3. Name all the possible approaches to malaria control that you can think of, no matter how off-beat.</a:t>
+            </a:r>
+          </a:p>
+        </p:txBody>
+      </p:sp>
+      <p:pic>
+        <p:nvPicPr>
+          <p:cNvPr id="2" name="Picture 1">
+            <a:extLst>
+              <a:ext uri="{FF2B5EF4-FFF2-40B4-BE49-F238E27FC236}">
+                <a16:creationId xmlns:a16="http://schemas.microsoft.com/office/drawing/2014/main" id="{9FACBA41-11B5-F54D-A1B8-5709EE3A2B76}"/>
+              </a:ext>
+            </a:extLst>
+          </p:cNvPr>
+          <p:cNvPicPr>
+            <a:picLocks noChangeAspect="1"/>
+          </p:cNvPicPr>
+          <p:nvPr/>
+        </p:nvPicPr>
+        <p:blipFill>
+          <a:blip r:embed="rId3"/>
+          <a:stretch>
+            <a:fillRect/>
+          </a:stretch>
+        </p:blipFill>
+        <p:spPr>
+          <a:xfrm>
+            <a:off x="4423137" y="4526619"/>
+            <a:ext cx="3345721" cy="541574"/>
+          </a:xfrm>
+          <a:prstGeom prst="rect">
+            <a:avLst/>
+          </a:prstGeom>
+        </p:spPr>
+      </p:pic>
+    </p:spTree>
+    <p:extLst>
+      <p:ext uri="{BB962C8B-B14F-4D97-AF65-F5344CB8AC3E}">
+        <p14:creationId xmlns:p14="http://schemas.microsoft.com/office/powerpoint/2010/main" val="2235385179"/>
+      </p:ext>
+    </p:extLst>
+  </p:cSld>
+  <p:clrMapOvr>
+    <a:masterClrMapping/>
+  </p:clrMapOvr>
+</p:sld>
+</file>
+
+<file path=ppt/slides/slide11.xml><?xml version="1.0" encoding="utf-8"?>
+<p:sld xmlns:a="http://schemas.openxmlformats.org/drawingml/2006/main" xmlns:r="http://schemas.openxmlformats.org/officeDocument/2006/relationships" xmlns:p="http://schemas.openxmlformats.org/presentationml/2006/main">
+  <p:cSld>
+    <p:spTree>
+      <p:nvGrpSpPr>
+        <p:cNvPr id="1" name=""/>
+        <p:cNvGrpSpPr/>
+        <p:nvPr/>
+      </p:nvGrpSpPr>
+      <p:grpSpPr>
+        <a:xfrm>
+          <a:off x="0" y="0"/>
+          <a:ext cx="0" cy="0"/>
+          <a:chOff x="0" y="0"/>
+          <a:chExt cx="0" cy="0"/>
+        </a:xfrm>
+      </p:grpSpPr>
+      <p:sp>
+        <p:nvSpPr>
+          <p:cNvPr id="2" name="Title 1">
+            <a:extLst>
+              <a:ext uri="{FF2B5EF4-FFF2-40B4-BE49-F238E27FC236}">
+                <a16:creationId xmlns:a16="http://schemas.microsoft.com/office/drawing/2014/main" id="{F26535DE-EFFA-4743-9340-27C8F7D02E15}"/>
+              </a:ext>
+            </a:extLst>
+          </p:cNvPr>
+          <p:cNvSpPr>
+            <a:spLocks noGrp="1"/>
+          </p:cNvSpPr>
+          <p:nvPr>
+            <p:ph type="ctrTitle"/>
+          </p:nvPr>
+        </p:nvSpPr>
+        <p:spPr/>
+        <p:txBody>
+          <a:bodyPr/>
+          <a:lstStyle/>
+          <a:p>
+            <a:endParaRPr lang="en-US"/>
+          </a:p>
+        </p:txBody>
+      </p:sp>
+      <p:sp>
+        <p:nvSpPr>
+          <p:cNvPr id="3" name="Subtitle 2">
+            <a:extLst>
+              <a:ext uri="{FF2B5EF4-FFF2-40B4-BE49-F238E27FC236}">
+                <a16:creationId xmlns:a16="http://schemas.microsoft.com/office/drawing/2014/main" id="{9737E0AA-F0EF-2345-B4E0-3ADC4009057C}"/>
+              </a:ext>
+            </a:extLst>
+          </p:cNvPr>
+          <p:cNvSpPr>
+            <a:spLocks noGrp="1"/>
+          </p:cNvSpPr>
+          <p:nvPr>
+            <p:ph type="subTitle" idx="1"/>
+          </p:nvPr>
+        </p:nvSpPr>
+        <p:spPr/>
+        <p:txBody>
+          <a:bodyPr/>
+          <a:lstStyle/>
+          <a:p>
+            <a:endParaRPr lang="en-US"/>
+          </a:p>
+        </p:txBody>
+      </p:sp>
+      <p:pic>
+        <p:nvPicPr>
+          <p:cNvPr id="5" name="slide.url=https://www.polleverywhere.com/free_text_polls/vsf2KQkyvrM1PaFnc4kyp">
+            <a:extLst>
+              <a:ext uri="{FF2B5EF4-FFF2-40B4-BE49-F238E27FC236}">
+                <a16:creationId xmlns:a16="http://schemas.microsoft.com/office/drawing/2014/main" id="{19A4FBBD-9D12-D945-8345-AF9553165F66}"/>
+              </a:ext>
+            </a:extLst>
+          </p:cNvPr>
+          <p:cNvPicPr>
+            <a:picLocks/>
+          </p:cNvPicPr>
+          <p:nvPr/>
+        </p:nvPicPr>
+        <p:blipFill>
+          <a:blip r:embed="rId3"/>
+          <a:stretch>
+            <a:fillRect/>
+          </a:stretch>
+        </p:blipFill>
+        <p:spPr>
+          <a:xfrm>
+            <a:off x="63500" y="63500"/>
+            <a:ext cx="12065000" cy="6731000"/>
+          </a:xfrm>
+          <a:prstGeom prst="rect">
+            <a:avLst/>
+          </a:prstGeom>
+        </p:spPr>
+      </p:pic>
+    </p:spTree>
+    <p:extLst>
+      <p:ext uri="{BB962C8B-B14F-4D97-AF65-F5344CB8AC3E}">
+        <p14:creationId xmlns:p14="http://schemas.microsoft.com/office/powerpoint/2010/main" val="1148876153"/>
+      </p:ext>
+    </p:extLst>
+  </p:cSld>
+  <p:clrMapOvr>
+    <a:masterClrMapping/>
+  </p:clrMapOvr>
+</p:sld>
+</file>
+
+<file path=ppt/slides/slide12.xml><?xml version="1.0" encoding="utf-8"?>
+<p:sld xmlns:a="http://schemas.openxmlformats.org/drawingml/2006/main" xmlns:r="http://schemas.openxmlformats.org/officeDocument/2006/relationships" xmlns:p="http://schemas.openxmlformats.org/presentationml/2006/main">
+  <p:cSld>
+    <p:bg>
+      <p:bgPr>
+        <a:solidFill>
+          <a:schemeClr val="tx1"/>
+        </a:solidFill>
+        <a:effectLst/>
+      </p:bgPr>
+    </p:bg>
+    <p:spTree>
+      <p:nvGrpSpPr>
+        <p:cNvPr id="1" name=""/>
+        <p:cNvGrpSpPr/>
+        <p:nvPr/>
+      </p:nvGrpSpPr>
+      <p:grpSpPr>
+        <a:xfrm>
+          <a:off x="0" y="0"/>
+          <a:ext cx="0" cy="0"/>
+          <a:chOff x="0" y="0"/>
+          <a:chExt cx="0" cy="0"/>
+        </a:xfrm>
+      </p:grpSpPr>
+      <p:sp>
+        <p:nvSpPr>
+          <p:cNvPr id="2" name="Rectangle 2"/>
+          <p:cNvSpPr>
+            <a:spLocks noChangeArrowheads="1"/>
+          </p:cNvSpPr>
+          <p:nvPr/>
+        </p:nvSpPr>
+        <p:spPr bwMode="auto">
+          <a:xfrm>
+            <a:off x="352524" y="2644170"/>
+            <a:ext cx="10896600" cy="1569660"/>
+          </a:xfrm>
+          <a:prstGeom prst="rect">
+            <a:avLst/>
+          </a:prstGeom>
+          <a:noFill/>
+          <a:ln w="9525">
+            <a:noFill/>
+            <a:miter lim="800000"/>
+            <a:headEnd/>
+            <a:tailEnd/>
+          </a:ln>
+          <a:effectLst/>
+        </p:spPr>
+        <p:txBody>
+          <a:bodyPr wrap="square">
+            <a:spAutoFit/>
+          </a:bodyPr>
+          <a:lstStyle/>
+          <a:p>
+            <a:pPr>
+              <a:defRPr/>
+            </a:pPr>
+            <a:r>
+              <a:rPr lang="en-US" sz="4800" b="1" dirty="0">
+                <a:solidFill>
+                  <a:schemeClr val="bg1">
+                    <a:lumMod val="65000"/>
+                  </a:schemeClr>
+                </a:solidFill>
+                <a:latin typeface="Avenir Book" panose="02000503020000020003" pitchFamily="2" charset="0"/>
+                <a:cs typeface="Avenir"/>
+              </a:rPr>
+              <a:t>Practical session 22</a:t>
+            </a:r>
+            <a:r>
+              <a:rPr lang="en-US" sz="4800" dirty="0">
+                <a:solidFill>
+                  <a:schemeClr val="bg1">
+                    <a:lumMod val="65000"/>
+                  </a:schemeClr>
+                </a:solidFill>
+                <a:latin typeface="Avenir Book" panose="02000503020000020003" pitchFamily="2" charset="0"/>
+                <a:cs typeface="Avenir"/>
+              </a:rPr>
+              <a:t>: </a:t>
+            </a:r>
+            <a:r>
+              <a:rPr lang="en-US" sz="4800" dirty="0">
+                <a:solidFill>
+                  <a:srgbClr val="FFFFFF"/>
+                </a:solidFill>
+                <a:latin typeface="Avenir Book" panose="02000503020000020003" pitchFamily="2" charset="0"/>
+                <a:cs typeface="Avenir"/>
+              </a:rPr>
+              <a:t>The apicomplexan </a:t>
+            </a:r>
+            <a:r>
+              <a:rPr lang="en-US" sz="4800" i="1" dirty="0">
+                <a:solidFill>
+                  <a:srgbClr val="FFFFFF"/>
+                </a:solidFill>
+                <a:latin typeface="Avenir Book" panose="02000503020000020003" pitchFamily="2" charset="0"/>
+                <a:cs typeface="Avenir"/>
+              </a:rPr>
+              <a:t>Plasmodium</a:t>
+            </a:r>
+          </a:p>
+        </p:txBody>
+      </p:sp>
+    </p:spTree>
+    <p:extLst>
+      <p:ext uri="{BB962C8B-B14F-4D97-AF65-F5344CB8AC3E}">
+        <p14:creationId xmlns:p14="http://schemas.microsoft.com/office/powerpoint/2010/main" val="2371518768"/>
+      </p:ext>
+    </p:extLst>
+  </p:cSld>
+  <p:clrMapOvr>
+    <a:masterClrMapping/>
+  </p:clrMapOvr>
+</p:sld>
+</file>
+
 <file path=ppt/slides/slide2.xml><?xml version="1.0" encoding="utf-8"?>
+<p:sld xmlns:a="http://schemas.openxmlformats.org/drawingml/2006/main" xmlns:r="http://schemas.openxmlformats.org/officeDocument/2006/relationships" xmlns:p="http://schemas.openxmlformats.org/presentationml/2006/main">
+  <p:cSld>
+    <p:spTree>
+      <p:nvGrpSpPr>
+        <p:cNvPr id="1" name="">
+          <a:extLst>
+            <a:ext uri="{FF2B5EF4-FFF2-40B4-BE49-F238E27FC236}">
+              <a16:creationId xmlns:a16="http://schemas.microsoft.com/office/drawing/2014/main" id="{970FB9AE-0CE9-A608-8D2B-7DA957E3919D}"/>
+            </a:ext>
+          </a:extLst>
+        </p:cNvPr>
+        <p:cNvGrpSpPr/>
+        <p:nvPr/>
+      </p:nvGrpSpPr>
+      <p:grpSpPr>
+        <a:xfrm>
+          <a:off x="0" y="0"/>
+          <a:ext cx="0" cy="0"/>
+          <a:chOff x="0" y="0"/>
+          <a:chExt cx="0" cy="0"/>
+        </a:xfrm>
+      </p:grpSpPr>
+      <p:sp>
+        <p:nvSpPr>
+          <p:cNvPr id="3" name="Rectangle 2">
+            <a:extLst>
+              <a:ext uri="{FF2B5EF4-FFF2-40B4-BE49-F238E27FC236}">
+                <a16:creationId xmlns:a16="http://schemas.microsoft.com/office/drawing/2014/main" id="{22581A73-A10D-DA55-E986-78B392375BD4}"/>
+              </a:ext>
+            </a:extLst>
+          </p:cNvPr>
+          <p:cNvSpPr>
+            <a:spLocks noChangeArrowheads="1"/>
+          </p:cNvSpPr>
+          <p:nvPr/>
+        </p:nvSpPr>
+        <p:spPr bwMode="auto">
+          <a:xfrm>
+            <a:off x="688454" y="470060"/>
+            <a:ext cx="10815091" cy="630942"/>
+          </a:xfrm>
+          <a:prstGeom prst="rect">
+            <a:avLst/>
+          </a:prstGeom>
+          <a:noFill/>
+          <a:ln w="9525">
+            <a:noFill/>
+            <a:miter lim="800000"/>
+            <a:headEnd/>
+            <a:tailEnd/>
+          </a:ln>
+          <a:effectLst/>
+        </p:spPr>
+        <p:txBody>
+          <a:bodyPr wrap="square">
+            <a:spAutoFit/>
+          </a:bodyPr>
+          <a:lstStyle/>
+          <a:p>
+            <a:pPr algn="ctr">
+              <a:defRPr/>
+            </a:pPr>
+            <a:r>
+              <a:rPr lang="en-US" sz="3500" b="1" dirty="0">
+                <a:latin typeface="Avenir"/>
+                <a:cs typeface="Avenir"/>
+              </a:rPr>
+              <a:t>The Situation</a:t>
+            </a:r>
+            <a:endParaRPr lang="en-US" sz="3500" b="1" i="1" dirty="0">
+              <a:latin typeface="Avenir"/>
+              <a:cs typeface="Avenir"/>
+            </a:endParaRPr>
+          </a:p>
+        </p:txBody>
+      </p:sp>
+      <p:sp>
+        <p:nvSpPr>
+          <p:cNvPr id="4" name="Rectangle 3">
+            <a:extLst>
+              <a:ext uri="{FF2B5EF4-FFF2-40B4-BE49-F238E27FC236}">
+                <a16:creationId xmlns:a16="http://schemas.microsoft.com/office/drawing/2014/main" id="{EA52E57D-9DED-BC72-2786-6FE07CE6CBB2}"/>
+              </a:ext>
+            </a:extLst>
+          </p:cNvPr>
+          <p:cNvSpPr>
+            <a:spLocks noChangeArrowheads="1"/>
+          </p:cNvSpPr>
+          <p:nvPr/>
+        </p:nvSpPr>
+        <p:spPr bwMode="auto">
+          <a:xfrm>
+            <a:off x="4871544" y="1808892"/>
+            <a:ext cx="6819581" cy="2862322"/>
+          </a:xfrm>
+          <a:prstGeom prst="rect">
+            <a:avLst/>
+          </a:prstGeom>
+          <a:noFill/>
+          <a:ln w="9525">
+            <a:noFill/>
+            <a:miter lim="800000"/>
+            <a:headEnd/>
+            <a:tailEnd/>
+          </a:ln>
+          <a:effectLst/>
+        </p:spPr>
+        <p:txBody>
+          <a:bodyPr wrap="square">
+            <a:spAutoFit/>
+          </a:bodyPr>
+          <a:lstStyle/>
+          <a:p>
+            <a:pPr>
+              <a:defRPr/>
+            </a:pPr>
+            <a:r>
+              <a:rPr lang="en-US" sz="3000" dirty="0">
+                <a:latin typeface="Avenir"/>
+                <a:cs typeface="Avenir"/>
+              </a:rPr>
+              <a:t>Imagine for a moment that you are a </a:t>
+            </a:r>
+            <a:r>
+              <a:rPr lang="en-US" sz="3000" i="1" dirty="0">
+                <a:latin typeface="Avenir"/>
+                <a:cs typeface="Avenir"/>
+              </a:rPr>
+              <a:t>Plasmodium</a:t>
+            </a:r>
+            <a:r>
+              <a:rPr lang="en-US" sz="3000" dirty="0">
+                <a:latin typeface="Avenir"/>
+                <a:cs typeface="Avenir"/>
+              </a:rPr>
+              <a:t> parasite, working your way through a host. Every aspect of the </a:t>
+            </a:r>
+            <a:r>
+              <a:rPr lang="en-US" sz="3000" i="1" dirty="0">
+                <a:latin typeface="Avenir"/>
+                <a:cs typeface="Avenir"/>
+              </a:rPr>
+              <a:t>Plasmodium </a:t>
+            </a:r>
+            <a:r>
+              <a:rPr lang="en-US" sz="3000" dirty="0">
+                <a:latin typeface="Avenir"/>
+                <a:cs typeface="Avenir"/>
+              </a:rPr>
+              <a:t>life cycle plays a critical role in the proliferation of malaria in a host…</a:t>
+            </a:r>
+          </a:p>
+        </p:txBody>
+      </p:sp>
+      <p:pic>
+        <p:nvPicPr>
+          <p:cNvPr id="10" name="Picture 9">
+            <a:extLst>
+              <a:ext uri="{FF2B5EF4-FFF2-40B4-BE49-F238E27FC236}">
+                <a16:creationId xmlns:a16="http://schemas.microsoft.com/office/drawing/2014/main" id="{7D4C2863-35C3-0021-734D-EA7D4FF194C9}"/>
+              </a:ext>
+            </a:extLst>
+          </p:cNvPr>
+          <p:cNvPicPr>
+            <a:picLocks noChangeAspect="1"/>
+          </p:cNvPicPr>
+          <p:nvPr/>
+        </p:nvPicPr>
+        <p:blipFill>
+          <a:blip r:embed="rId3"/>
+          <a:stretch>
+            <a:fillRect/>
+          </a:stretch>
+        </p:blipFill>
+        <p:spPr>
+          <a:xfrm>
+            <a:off x="866224" y="1385665"/>
+            <a:ext cx="3753070" cy="3700853"/>
+          </a:xfrm>
+          <a:prstGeom prst="rect">
+            <a:avLst/>
+          </a:prstGeom>
+        </p:spPr>
+      </p:pic>
+    </p:spTree>
+    <p:extLst>
+      <p:ext uri="{BB962C8B-B14F-4D97-AF65-F5344CB8AC3E}">
+        <p14:creationId xmlns:p14="http://schemas.microsoft.com/office/powerpoint/2010/main" val="1817397958"/>
+      </p:ext>
+    </p:extLst>
+  </p:cSld>
+  <p:clrMapOvr>
+    <a:masterClrMapping/>
+  </p:clrMapOvr>
+  <p:timing>
+    <p:tnLst>
+      <p:par>
+        <p:cTn id="1" dur="indefinite" restart="never" nodeType="tmRoot">
+          <p:childTnLst>
+            <p:seq concurrent="1" nextAc="seek">
+              <p:cTn id="2" dur="indefinite" nodeType="mainSeq">
+                <p:childTnLst>
+                  <p:par>
+                    <p:cTn id="3" fill="hold">
+                      <p:stCondLst>
+                        <p:cond delay="indefinite"/>
+                      </p:stCondLst>
+                      <p:childTnLst>
+                        <p:par>
+                          <p:cTn id="4" fill="hold">
+                            <p:stCondLst>
+                              <p:cond delay="0"/>
+                            </p:stCondLst>
+                            <p:childTnLst>
+                              <p:par>
+                                <p:cTn id="5" presetID="1" presetClass="entr" presetSubtype="0" fill="hold" grpId="0" nodeType="clickEffect">
+                                  <p:stCondLst>
+                                    <p:cond delay="0"/>
+                                  </p:stCondLst>
+                                  <p:childTnLst>
+                                    <p:set>
+                                      <p:cBhvr>
+                                        <p:cTn id="6" dur="1" fill="hold">
+                                          <p:stCondLst>
+                                            <p:cond delay="0"/>
+                                          </p:stCondLst>
+                                        </p:cTn>
+                                        <p:tgtEl>
+                                          <p:spTgt spid="4">
+                                            <p:txEl>
+                                              <p:pRg st="0" end="0"/>
+                                            </p:txEl>
+                                          </p:spTgt>
+                                        </p:tgtEl>
+                                        <p:attrNameLst>
+                                          <p:attrName>style.visibility</p:attrName>
+                                        </p:attrNameLst>
+                                      </p:cBhvr>
+                                      <p:to>
+                                        <p:strVal val="visible"/>
+                                      </p:to>
+                                    </p:set>
+                                  </p:childTnLst>
+                                </p:cTn>
+                              </p:par>
+                            </p:childTnLst>
+                          </p:cTn>
+                        </p:par>
+                      </p:childTnLst>
+                    </p:cTn>
+                  </p:par>
+                </p:childTnLst>
+              </p:cTn>
+              <p:prevCondLst>
+                <p:cond evt="onPrev" delay="0">
+                  <p:tgtEl>
+                    <p:sldTgt/>
+                  </p:tgtEl>
+                </p:cond>
+              </p:prevCondLst>
+              <p:nextCondLst>
+                <p:cond evt="onNext" delay="0">
+                  <p:tgtEl>
+                    <p:sldTgt/>
+                  </p:tgtEl>
+                </p:cond>
+              </p:nextCondLst>
+            </p:seq>
+          </p:childTnLst>
+        </p:cTn>
+      </p:par>
+    </p:tnLst>
+    <p:bldLst>
+      <p:bldP spid="4" grpId="0" uiExpand="1" build="p" bldLvl="5"/>
+    </p:bldLst>
+  </p:timing>
+</p:sld>
+</file>
+
+<file path=ppt/slides/slide3.xml><?xml version="1.0" encoding="utf-8"?>
+<p:sld xmlns:a="http://schemas.openxmlformats.org/drawingml/2006/main" xmlns:r="http://schemas.openxmlformats.org/officeDocument/2006/relationships" xmlns:p="http://schemas.openxmlformats.org/presentationml/2006/main">
+  <p:cSld>
+    <p:spTree>
+      <p:nvGrpSpPr>
+        <p:cNvPr id="1" name="">
+          <a:extLst>
+            <a:ext uri="{FF2B5EF4-FFF2-40B4-BE49-F238E27FC236}">
+              <a16:creationId xmlns:a16="http://schemas.microsoft.com/office/drawing/2014/main" id="{4AF73669-847E-B77B-D62F-8C721296A743}"/>
+            </a:ext>
+          </a:extLst>
+        </p:cNvPr>
+        <p:cNvGrpSpPr/>
+        <p:nvPr/>
+      </p:nvGrpSpPr>
+      <p:grpSpPr>
+        <a:xfrm>
+          <a:off x="0" y="0"/>
+          <a:ext cx="0" cy="0"/>
+          <a:chOff x="0" y="0"/>
+          <a:chExt cx="0" cy="0"/>
+        </a:xfrm>
+      </p:grpSpPr>
+      <p:sp>
+        <p:nvSpPr>
+          <p:cNvPr id="3" name="Rectangle 2">
+            <a:extLst>
+              <a:ext uri="{FF2B5EF4-FFF2-40B4-BE49-F238E27FC236}">
+                <a16:creationId xmlns:a16="http://schemas.microsoft.com/office/drawing/2014/main" id="{1D754AA4-8B06-2351-34F1-D0EC57A7292D}"/>
+              </a:ext>
+            </a:extLst>
+          </p:cNvPr>
+          <p:cNvSpPr>
+            <a:spLocks noChangeArrowheads="1"/>
+          </p:cNvSpPr>
+          <p:nvPr/>
+        </p:nvSpPr>
+        <p:spPr bwMode="auto">
+          <a:xfrm>
+            <a:off x="688454" y="470060"/>
+            <a:ext cx="10815091" cy="630942"/>
+          </a:xfrm>
+          <a:prstGeom prst="rect">
+            <a:avLst/>
+          </a:prstGeom>
+          <a:noFill/>
+          <a:ln w="9525">
+            <a:noFill/>
+            <a:miter lim="800000"/>
+            <a:headEnd/>
+            <a:tailEnd/>
+          </a:ln>
+          <a:effectLst/>
+        </p:spPr>
+        <p:txBody>
+          <a:bodyPr wrap="square">
+            <a:spAutoFit/>
+          </a:bodyPr>
+          <a:lstStyle/>
+          <a:p>
+            <a:pPr algn="ctr">
+              <a:defRPr/>
+            </a:pPr>
+            <a:r>
+              <a:rPr lang="en-US" sz="3500" b="1" dirty="0">
+                <a:latin typeface="Avenir"/>
+                <a:cs typeface="Avenir"/>
+              </a:rPr>
+              <a:t>Part 1: The Roles</a:t>
+            </a:r>
+            <a:endParaRPr lang="en-US" sz="3500" b="1" i="1" dirty="0">
+              <a:latin typeface="Avenir"/>
+              <a:cs typeface="Avenir"/>
+            </a:endParaRPr>
+          </a:p>
+        </p:txBody>
+      </p:sp>
+      <p:sp>
+        <p:nvSpPr>
+          <p:cNvPr id="4" name="Rectangle 3">
+            <a:extLst>
+              <a:ext uri="{FF2B5EF4-FFF2-40B4-BE49-F238E27FC236}">
+                <a16:creationId xmlns:a16="http://schemas.microsoft.com/office/drawing/2014/main" id="{165E5ACB-9716-AB28-35A4-BFD2942281EE}"/>
+              </a:ext>
+            </a:extLst>
+          </p:cNvPr>
+          <p:cNvSpPr>
+            <a:spLocks noChangeArrowheads="1"/>
+          </p:cNvSpPr>
+          <p:nvPr/>
+        </p:nvSpPr>
+        <p:spPr bwMode="auto">
+          <a:xfrm>
+            <a:off x="4846830" y="1101002"/>
+            <a:ext cx="6819581" cy="5632311"/>
+          </a:xfrm>
+          <a:prstGeom prst="rect">
+            <a:avLst/>
+          </a:prstGeom>
+          <a:noFill/>
+          <a:ln w="9525">
+            <a:noFill/>
+            <a:miter lim="800000"/>
+            <a:headEnd/>
+            <a:tailEnd/>
+          </a:ln>
+          <a:effectLst/>
+        </p:spPr>
+        <p:txBody>
+          <a:bodyPr wrap="square">
+            <a:spAutoFit/>
+          </a:bodyPr>
+          <a:lstStyle/>
+          <a:p>
+            <a:pPr>
+              <a:defRPr/>
+            </a:pPr>
+            <a:r>
+              <a:rPr lang="en-US" sz="3000" dirty="0">
+                <a:latin typeface="Avenir"/>
+                <a:cs typeface="Avenir"/>
+              </a:rPr>
+              <a:t>In groups, assign the following rolls to each member of the team :</a:t>
+            </a:r>
+          </a:p>
+          <a:p>
+            <a:pPr marL="457200" indent="-457200">
+              <a:buFontTx/>
+              <a:buChar char="-"/>
+              <a:defRPr/>
+            </a:pPr>
+            <a:r>
+              <a:rPr lang="en-US" sz="3000" dirty="0">
+                <a:latin typeface="Avenir"/>
+                <a:cs typeface="Avenir"/>
+              </a:rPr>
+              <a:t>mosquito</a:t>
+            </a:r>
+          </a:p>
+          <a:p>
+            <a:pPr marL="457200" indent="-457200">
+              <a:buFontTx/>
+              <a:buChar char="-"/>
+              <a:defRPr/>
+            </a:pPr>
+            <a:r>
+              <a:rPr lang="en-US" sz="3000" dirty="0">
+                <a:latin typeface="Avenir"/>
+                <a:cs typeface="Avenir"/>
+              </a:rPr>
+              <a:t>zygote</a:t>
+            </a:r>
+          </a:p>
+          <a:p>
+            <a:pPr marL="457200" indent="-457200">
+              <a:buFontTx/>
+              <a:buChar char="-"/>
+              <a:defRPr/>
+            </a:pPr>
+            <a:r>
+              <a:rPr lang="en-US" sz="3000" dirty="0">
+                <a:latin typeface="Avenir"/>
+                <a:cs typeface="Avenir"/>
+              </a:rPr>
+              <a:t>ookinete</a:t>
+            </a:r>
+          </a:p>
+          <a:p>
+            <a:pPr marL="457200" indent="-457200">
+              <a:buFontTx/>
+              <a:buChar char="-"/>
+              <a:defRPr/>
+            </a:pPr>
+            <a:r>
+              <a:rPr lang="en-US" sz="3000" dirty="0">
+                <a:latin typeface="Avenir"/>
+                <a:cs typeface="Avenir"/>
+              </a:rPr>
+              <a:t>oocyst</a:t>
+            </a:r>
+          </a:p>
+          <a:p>
+            <a:pPr marL="457200" indent="-457200">
+              <a:buFontTx/>
+              <a:buChar char="-"/>
+              <a:defRPr/>
+            </a:pPr>
+            <a:r>
+              <a:rPr lang="en-US" sz="3000" dirty="0">
+                <a:latin typeface="Avenir"/>
+                <a:cs typeface="Avenir"/>
+              </a:rPr>
+              <a:t>sporozoites </a:t>
+            </a:r>
+          </a:p>
+          <a:p>
+            <a:pPr marL="457200" indent="-457200">
+              <a:buFontTx/>
+              <a:buChar char="-"/>
+              <a:defRPr/>
+            </a:pPr>
+            <a:r>
+              <a:rPr lang="en-US" sz="3000" dirty="0">
+                <a:latin typeface="Avenir"/>
+                <a:cs typeface="Avenir"/>
+              </a:rPr>
+              <a:t>merozoites</a:t>
+            </a:r>
+          </a:p>
+          <a:p>
+            <a:pPr marL="457200" indent="-457200">
+              <a:buFontTx/>
+              <a:buChar char="-"/>
+              <a:defRPr/>
+            </a:pPr>
+            <a:r>
+              <a:rPr lang="en-US" sz="3000" dirty="0">
+                <a:latin typeface="Avenir"/>
+                <a:cs typeface="Avenir"/>
+              </a:rPr>
+              <a:t>human </a:t>
+            </a:r>
+          </a:p>
+          <a:p>
+            <a:pPr marL="457200" indent="-457200">
+              <a:buFontTx/>
+              <a:buChar char="-"/>
+              <a:defRPr/>
+            </a:pPr>
+            <a:r>
+              <a:rPr lang="en-US" sz="3000" dirty="0">
+                <a:latin typeface="Avenir"/>
+                <a:cs typeface="Avenir"/>
+              </a:rPr>
+              <a:t>gametocytes</a:t>
+            </a:r>
+          </a:p>
+          <a:p>
+            <a:pPr marL="457200" indent="-457200">
+              <a:buFontTx/>
+              <a:buChar char="-"/>
+              <a:defRPr/>
+            </a:pPr>
+            <a:endParaRPr lang="en-US" sz="3000" dirty="0">
+              <a:latin typeface="Avenir"/>
+              <a:cs typeface="Avenir"/>
+            </a:endParaRPr>
+          </a:p>
+          <a:p>
+            <a:pPr marL="457200" indent="-457200">
+              <a:buFontTx/>
+              <a:buChar char="-"/>
+              <a:defRPr/>
+            </a:pPr>
+            <a:endParaRPr lang="en-US" sz="3000" dirty="0">
+              <a:latin typeface="Avenir"/>
+              <a:cs typeface="Avenir"/>
+            </a:endParaRPr>
+          </a:p>
+        </p:txBody>
+      </p:sp>
+      <p:pic>
+        <p:nvPicPr>
+          <p:cNvPr id="10" name="Picture 9">
+            <a:extLst>
+              <a:ext uri="{FF2B5EF4-FFF2-40B4-BE49-F238E27FC236}">
+                <a16:creationId xmlns:a16="http://schemas.microsoft.com/office/drawing/2014/main" id="{585A3DD1-DC3C-8935-C863-84ACEC253621}"/>
+              </a:ext>
+            </a:extLst>
+          </p:cNvPr>
+          <p:cNvPicPr>
+            <a:picLocks noChangeAspect="1"/>
+          </p:cNvPicPr>
+          <p:nvPr/>
+        </p:nvPicPr>
+        <p:blipFill>
+          <a:blip r:embed="rId3"/>
+          <a:stretch>
+            <a:fillRect/>
+          </a:stretch>
+        </p:blipFill>
+        <p:spPr>
+          <a:xfrm>
+            <a:off x="866224" y="1385665"/>
+            <a:ext cx="3753070" cy="3700853"/>
+          </a:xfrm>
+          <a:prstGeom prst="rect">
+            <a:avLst/>
+          </a:prstGeom>
+        </p:spPr>
+      </p:pic>
+      <p:sp>
+        <p:nvSpPr>
+          <p:cNvPr id="2" name="Rectangle 1">
+            <a:extLst>
+              <a:ext uri="{FF2B5EF4-FFF2-40B4-BE49-F238E27FC236}">
+                <a16:creationId xmlns:a16="http://schemas.microsoft.com/office/drawing/2014/main" id="{0423773E-1707-DB86-E9A2-8FE87042D536}"/>
+              </a:ext>
+            </a:extLst>
+          </p:cNvPr>
+          <p:cNvSpPr>
+            <a:spLocks noChangeArrowheads="1"/>
+          </p:cNvSpPr>
+          <p:nvPr/>
+        </p:nvSpPr>
+        <p:spPr bwMode="auto">
+          <a:xfrm>
+            <a:off x="3394451" y="5756998"/>
+            <a:ext cx="8485079" cy="892552"/>
+          </a:xfrm>
+          <a:prstGeom prst="rect">
+            <a:avLst/>
+          </a:prstGeom>
+          <a:noFill/>
+          <a:ln w="9525">
+            <a:noFill/>
+            <a:miter lim="800000"/>
+            <a:headEnd/>
+            <a:tailEnd/>
+          </a:ln>
+          <a:effectLst/>
+        </p:spPr>
+        <p:txBody>
+          <a:bodyPr wrap="square">
+            <a:spAutoFit/>
+          </a:bodyPr>
+          <a:lstStyle/>
+          <a:p>
+            <a:pPr>
+              <a:defRPr/>
+            </a:pPr>
+            <a:r>
+              <a:rPr lang="en-US" sz="2600" b="1" dirty="0">
+                <a:latin typeface="Avenir"/>
+                <a:cs typeface="Avenir"/>
+              </a:rPr>
+              <a:t>Be assigned into groups (1 min) and assign each other’s roles within the group (3 min). </a:t>
+            </a:r>
+          </a:p>
+        </p:txBody>
+      </p:sp>
+      <p:pic>
+        <p:nvPicPr>
+          <p:cNvPr id="5" name="Picture 4">
+            <a:extLst>
+              <a:ext uri="{FF2B5EF4-FFF2-40B4-BE49-F238E27FC236}">
+                <a16:creationId xmlns:a16="http://schemas.microsoft.com/office/drawing/2014/main" id="{A2E362B8-D17E-A894-87F4-F751047A436D}"/>
+              </a:ext>
+            </a:extLst>
+          </p:cNvPr>
+          <p:cNvPicPr>
+            <a:picLocks noChangeAspect="1"/>
+          </p:cNvPicPr>
+          <p:nvPr/>
+        </p:nvPicPr>
+        <p:blipFill>
+          <a:blip r:embed="rId4">
+            <a:extLst>
+              <a:ext uri="{BEBA8EAE-BF5A-486C-A8C5-ECC9F3942E4B}">
+                <a14:imgProps xmlns:a14="http://schemas.microsoft.com/office/drawing/2010/main">
+                  <a14:imgLayer r:embed="rId5">
+                    <a14:imgEffect>
+                      <a14:backgroundRemoval t="9867" b="89867" l="6196" r="91630">
+                        <a14:foregroundMark x1="39022" y1="64000" x2="39022" y2="64000"/>
+                        <a14:foregroundMark x1="10000" y1="55200" x2="10000" y2="55200"/>
+                        <a14:foregroundMark x1="6304" y1="63467" x2="6304" y2="63467"/>
+                        <a14:foregroundMark x1="12935" y1="81067" x2="12935" y2="81067"/>
+                        <a14:foregroundMark x1="12500" y1="78933" x2="12500" y2="78933"/>
+                        <a14:foregroundMark x1="13152" y1="78933" x2="13152" y2="78933"/>
+                        <a14:foregroundMark x1="46413" y1="79467" x2="46413" y2="79467"/>
+                        <a14:foregroundMark x1="36630" y1="39200" x2="36630" y2="39200"/>
+                        <a14:foregroundMark x1="36630" y1="38667" x2="36630" y2="38667"/>
+                        <a14:foregroundMark x1="36630" y1="38400" x2="36630" y2="38400"/>
+                        <a14:foregroundMark x1="36630" y1="37867" x2="36630" y2="37867"/>
+                        <a14:foregroundMark x1="36630" y1="37867" x2="36630" y2="37867"/>
+                        <a14:foregroundMark x1="36630" y1="36800" x2="36630" y2="36800"/>
+                        <a14:foregroundMark x1="30109" y1="29067" x2="30109" y2="29067"/>
+                        <a14:foregroundMark x1="30326" y1="29067" x2="30326" y2="29067"/>
+                        <a14:foregroundMark x1="29891" y1="34667" x2="29891" y2="34667"/>
+                        <a14:foregroundMark x1="30109" y1="34667" x2="30109" y2="34667"/>
+                        <a14:foregroundMark x1="30543" y1="35733" x2="30543" y2="35733"/>
+                        <a14:foregroundMark x1="40326" y1="26400" x2="40326" y2="26400"/>
+                        <a14:foregroundMark x1="40761" y1="26400" x2="40761" y2="26400"/>
+                        <a14:foregroundMark x1="40761" y1="33067" x2="40761" y2="33067"/>
+                        <a14:foregroundMark x1="39891" y1="37333" x2="39891" y2="37333"/>
+                        <a14:foregroundMark x1="38261" y1="38667" x2="38261" y2="38667"/>
+                        <a14:foregroundMark x1="44565" y1="22933" x2="44565" y2="22933"/>
+                        <a14:foregroundMark x1="44783" y1="22933" x2="44783" y2="22933"/>
+                        <a14:foregroundMark x1="49130" y1="15733" x2="49130" y2="15733"/>
+                        <a14:foregroundMark x1="54783" y1="22400" x2="54783" y2="22400"/>
+                        <a14:foregroundMark x1="52935" y1="29600" x2="52935" y2="29600"/>
+                        <a14:foregroundMark x1="38043" y1="29600" x2="38043" y2="29600"/>
+                        <a14:foregroundMark x1="67500" y1="26933" x2="67500" y2="26933"/>
+                        <a14:foregroundMark x1="66739" y1="19733" x2="66739" y2="19733"/>
+                        <a14:foregroundMark x1="88043" y1="16800" x2="88043" y2="16800"/>
+                        <a14:foregroundMark x1="84674" y1="16800" x2="84674" y2="16800"/>
+                        <a14:foregroundMark x1="85326" y1="22933" x2="85326" y2="22933"/>
+                        <a14:foregroundMark x1="90326" y1="24800" x2="90326" y2="24800"/>
+                        <a14:foregroundMark x1="91630" y1="18133" x2="91630" y2="18133"/>
+                        <a14:foregroundMark x1="72174" y1="20267" x2="72174" y2="20267"/>
+                        <a14:foregroundMark x1="72935" y1="25867" x2="72935" y2="25867"/>
+                        <a14:foregroundMark x1="52935" y1="17067" x2="52935" y2="17067"/>
+                        <a14:foregroundMark x1="53696" y1="17067" x2="53696" y2="17067"/>
+                        <a14:foregroundMark x1="38696" y1="24800" x2="38696" y2="24800"/>
+                        <a14:foregroundMark x1="17174" y1="20800" x2="17174" y2="20800"/>
+                        <a14:foregroundMark x1="18152" y1="20800" x2="18152" y2="20800"/>
+                        <a14:foregroundMark x1="18804" y1="17600" x2="18804" y2="17600"/>
+                        <a14:foregroundMark x1="18804" y1="16267" x2="18804" y2="16267"/>
+                        <a14:foregroundMark x1="12717" y1="32000" x2="12717" y2="32000"/>
+                        <a14:foregroundMark x1="12500" y1="13067" x2="12500" y2="13067"/>
+                        <a14:foregroundMark x1="12500" y1="12533" x2="12500" y2="12533"/>
+                        <a14:foregroundMark x1="34457" y1="26400" x2="34457" y2="26400"/>
+                        <a14:foregroundMark x1="49130" y1="22933" x2="49130" y2="22933"/>
+                        <a14:foregroundMark x1="67283" y1="17067" x2="67283" y2="17067"/>
+                        <a14:foregroundMark x1="67283" y1="16800" x2="67283" y2="16800"/>
+                        <a14:foregroundMark x1="67283" y1="16267" x2="67283" y2="16267"/>
+                      </a14:backgroundRemoval>
+                    </a14:imgEffect>
+                  </a14:imgLayer>
+                </a14:imgProps>
+              </a:ext>
+            </a:extLst>
+          </a:blip>
+          <a:stretch>
+            <a:fillRect/>
+          </a:stretch>
+        </p:blipFill>
+        <p:spPr>
+          <a:xfrm>
+            <a:off x="312470" y="5379104"/>
+            <a:ext cx="3037028" cy="1234618"/>
+          </a:xfrm>
+          <a:prstGeom prst="rect">
+            <a:avLst/>
+          </a:prstGeom>
+        </p:spPr>
+      </p:pic>
+    </p:spTree>
+    <p:extLst>
+      <p:ext uri="{BB962C8B-B14F-4D97-AF65-F5344CB8AC3E}">
+        <p14:creationId xmlns:p14="http://schemas.microsoft.com/office/powerpoint/2010/main" val="949240233"/>
+      </p:ext>
+    </p:extLst>
+  </p:cSld>
+  <p:clrMapOvr>
+    <a:masterClrMapping/>
+  </p:clrMapOvr>
+</p:sld>
+</file>
+
+<file path=ppt/slides/slide4.xml><?xml version="1.0" encoding="utf-8"?>
+<p:sld xmlns:a="http://schemas.openxmlformats.org/drawingml/2006/main" xmlns:r="http://schemas.openxmlformats.org/officeDocument/2006/relationships" xmlns:p="http://schemas.openxmlformats.org/presentationml/2006/main">
+  <p:cSld>
+    <p:spTree>
+      <p:nvGrpSpPr>
+        <p:cNvPr id="1" name="">
+          <a:extLst>
+            <a:ext uri="{FF2B5EF4-FFF2-40B4-BE49-F238E27FC236}">
+              <a16:creationId xmlns:a16="http://schemas.microsoft.com/office/drawing/2014/main" id="{721E2143-1FD4-60C9-36A3-3B6B884A1079}"/>
+            </a:ext>
+          </a:extLst>
+        </p:cNvPr>
+        <p:cNvGrpSpPr/>
+        <p:nvPr/>
+      </p:nvGrpSpPr>
+      <p:grpSpPr>
+        <a:xfrm>
+          <a:off x="0" y="0"/>
+          <a:ext cx="0" cy="0"/>
+          <a:chOff x="0" y="0"/>
+          <a:chExt cx="0" cy="0"/>
+        </a:xfrm>
+      </p:grpSpPr>
+      <p:sp>
+        <p:nvSpPr>
+          <p:cNvPr id="3" name="Rectangle 2">
+            <a:extLst>
+              <a:ext uri="{FF2B5EF4-FFF2-40B4-BE49-F238E27FC236}">
+                <a16:creationId xmlns:a16="http://schemas.microsoft.com/office/drawing/2014/main" id="{6925D1E8-CA36-0486-18CA-6A4ECA4F3C8F}"/>
+              </a:ext>
+            </a:extLst>
+          </p:cNvPr>
+          <p:cNvSpPr>
+            <a:spLocks noChangeArrowheads="1"/>
+          </p:cNvSpPr>
+          <p:nvPr/>
+        </p:nvSpPr>
+        <p:spPr bwMode="auto">
+          <a:xfrm>
+            <a:off x="688454" y="470060"/>
+            <a:ext cx="10815091" cy="630942"/>
+          </a:xfrm>
+          <a:prstGeom prst="rect">
+            <a:avLst/>
+          </a:prstGeom>
+          <a:noFill/>
+          <a:ln w="9525">
+            <a:noFill/>
+            <a:miter lim="800000"/>
+            <a:headEnd/>
+            <a:tailEnd/>
+          </a:ln>
+          <a:effectLst/>
+        </p:spPr>
+        <p:txBody>
+          <a:bodyPr wrap="square">
+            <a:spAutoFit/>
+          </a:bodyPr>
+          <a:lstStyle/>
+          <a:p>
+            <a:pPr algn="ctr">
+              <a:defRPr/>
+            </a:pPr>
+            <a:r>
+              <a:rPr lang="en-US" sz="3500" b="1" dirty="0">
+                <a:latin typeface="Avenir"/>
+                <a:cs typeface="Avenir"/>
+              </a:rPr>
+              <a:t>Part 1: The Task</a:t>
+            </a:r>
+            <a:endParaRPr lang="en-US" sz="3500" b="1" i="1" dirty="0">
+              <a:latin typeface="Avenir"/>
+              <a:cs typeface="Avenir"/>
+            </a:endParaRPr>
+          </a:p>
+        </p:txBody>
+      </p:sp>
+      <p:sp>
+        <p:nvSpPr>
+          <p:cNvPr id="4" name="Rectangle 3">
+            <a:extLst>
+              <a:ext uri="{FF2B5EF4-FFF2-40B4-BE49-F238E27FC236}">
+                <a16:creationId xmlns:a16="http://schemas.microsoft.com/office/drawing/2014/main" id="{A9896013-1EED-6CF3-4B96-707BED414834}"/>
+              </a:ext>
+            </a:extLst>
+          </p:cNvPr>
+          <p:cNvSpPr>
+            <a:spLocks noChangeArrowheads="1"/>
+          </p:cNvSpPr>
+          <p:nvPr/>
+        </p:nvSpPr>
+        <p:spPr bwMode="auto">
+          <a:xfrm>
+            <a:off x="4809761" y="1235405"/>
+            <a:ext cx="6819581" cy="4708981"/>
+          </a:xfrm>
+          <a:prstGeom prst="rect">
+            <a:avLst/>
+          </a:prstGeom>
+          <a:noFill/>
+          <a:ln w="9525">
+            <a:noFill/>
+            <a:miter lim="800000"/>
+            <a:headEnd/>
+            <a:tailEnd/>
+          </a:ln>
+          <a:effectLst/>
+        </p:spPr>
+        <p:txBody>
+          <a:bodyPr wrap="square">
+            <a:spAutoFit/>
+          </a:bodyPr>
+          <a:lstStyle/>
+          <a:p>
+            <a:pPr>
+              <a:defRPr/>
+            </a:pPr>
+            <a:r>
+              <a:rPr lang="en-US" sz="3000" dirty="0">
+                <a:latin typeface="Avenir"/>
+                <a:cs typeface="Avenir"/>
+              </a:rPr>
+              <a:t>In these groups, design a plan to demonstrate to the class the entire </a:t>
+            </a:r>
+            <a:r>
+              <a:rPr lang="en-US" sz="3000" i="1" dirty="0">
+                <a:latin typeface="Avenir"/>
+                <a:cs typeface="Avenir"/>
+              </a:rPr>
+              <a:t>Plasmodium </a:t>
+            </a:r>
+            <a:r>
+              <a:rPr lang="en-US" sz="3000" dirty="0">
+                <a:latin typeface="Avenir"/>
+                <a:cs typeface="Avenir"/>
+              </a:rPr>
+              <a:t>life cycle from start to finish. Be sure to note who the definitive host of </a:t>
+            </a:r>
+            <a:r>
+              <a:rPr lang="en-US" sz="3000" i="1" dirty="0">
+                <a:latin typeface="Avenir"/>
+                <a:cs typeface="Avenir"/>
+              </a:rPr>
+              <a:t>Plasmodium </a:t>
+            </a:r>
+            <a:r>
+              <a:rPr lang="en-US" sz="3000" dirty="0">
+                <a:latin typeface="Avenir"/>
+                <a:cs typeface="Avenir"/>
+              </a:rPr>
+              <a:t>is and what part of a human you are referencing. Later, you will present your case for what this life cycle looks like to the whole class as a group.</a:t>
+            </a:r>
+          </a:p>
+          <a:p>
+            <a:pPr marL="457200" indent="-457200">
+              <a:buFontTx/>
+              <a:buChar char="-"/>
+              <a:defRPr/>
+            </a:pPr>
+            <a:endParaRPr lang="en-US" sz="3000" dirty="0">
+              <a:latin typeface="Avenir"/>
+              <a:cs typeface="Avenir"/>
+            </a:endParaRPr>
+          </a:p>
+        </p:txBody>
+      </p:sp>
+      <p:pic>
+        <p:nvPicPr>
+          <p:cNvPr id="10" name="Picture 9">
+            <a:extLst>
+              <a:ext uri="{FF2B5EF4-FFF2-40B4-BE49-F238E27FC236}">
+                <a16:creationId xmlns:a16="http://schemas.microsoft.com/office/drawing/2014/main" id="{BA09583D-E2FC-B78C-1A71-2E3579BBDBDB}"/>
+              </a:ext>
+            </a:extLst>
+          </p:cNvPr>
+          <p:cNvPicPr>
+            <a:picLocks noChangeAspect="1"/>
+          </p:cNvPicPr>
+          <p:nvPr/>
+        </p:nvPicPr>
+        <p:blipFill>
+          <a:blip r:embed="rId3"/>
+          <a:stretch>
+            <a:fillRect/>
+          </a:stretch>
+        </p:blipFill>
+        <p:spPr>
+          <a:xfrm>
+            <a:off x="866224" y="1385665"/>
+            <a:ext cx="3753070" cy="3700853"/>
+          </a:xfrm>
+          <a:prstGeom prst="rect">
+            <a:avLst/>
+          </a:prstGeom>
+        </p:spPr>
+      </p:pic>
+      <p:sp>
+        <p:nvSpPr>
+          <p:cNvPr id="2" name="Rectangle 1">
+            <a:extLst>
+              <a:ext uri="{FF2B5EF4-FFF2-40B4-BE49-F238E27FC236}">
+                <a16:creationId xmlns:a16="http://schemas.microsoft.com/office/drawing/2014/main" id="{1BDE4FA5-150D-501D-00FF-B826B02367A4}"/>
+              </a:ext>
+            </a:extLst>
+          </p:cNvPr>
+          <p:cNvSpPr>
+            <a:spLocks noChangeArrowheads="1"/>
+          </p:cNvSpPr>
+          <p:nvPr/>
+        </p:nvSpPr>
+        <p:spPr bwMode="auto">
+          <a:xfrm>
+            <a:off x="3394451" y="5432458"/>
+            <a:ext cx="8485079" cy="1292662"/>
+          </a:xfrm>
+          <a:prstGeom prst="rect">
+            <a:avLst/>
+          </a:prstGeom>
+          <a:noFill/>
+          <a:ln w="9525">
+            <a:noFill/>
+            <a:miter lim="800000"/>
+            <a:headEnd/>
+            <a:tailEnd/>
+          </a:ln>
+          <a:effectLst/>
+        </p:spPr>
+        <p:txBody>
+          <a:bodyPr wrap="square">
+            <a:spAutoFit/>
+          </a:bodyPr>
+          <a:lstStyle/>
+          <a:p>
+            <a:pPr>
+              <a:defRPr/>
+            </a:pPr>
+            <a:r>
+              <a:rPr lang="en-US" sz="2600" b="1" dirty="0">
+                <a:latin typeface="Avenir"/>
+                <a:cs typeface="Avenir"/>
+              </a:rPr>
+              <a:t>Discuss with your group how the roles work together (7.5 min) and design a way of clearly communicating the life cycle to the entire class (7.5 min)</a:t>
+            </a:r>
+          </a:p>
+        </p:txBody>
+      </p:sp>
+      <p:pic>
+        <p:nvPicPr>
+          <p:cNvPr id="5" name="Picture 4">
+            <a:extLst>
+              <a:ext uri="{FF2B5EF4-FFF2-40B4-BE49-F238E27FC236}">
+                <a16:creationId xmlns:a16="http://schemas.microsoft.com/office/drawing/2014/main" id="{A5034690-9FDF-E7AB-21A2-A2F5D0B11426}"/>
+              </a:ext>
+            </a:extLst>
+          </p:cNvPr>
+          <p:cNvPicPr>
+            <a:picLocks noChangeAspect="1"/>
+          </p:cNvPicPr>
+          <p:nvPr/>
+        </p:nvPicPr>
+        <p:blipFill>
+          <a:blip r:embed="rId4">
+            <a:extLst>
+              <a:ext uri="{BEBA8EAE-BF5A-486C-A8C5-ECC9F3942E4B}">
+                <a14:imgProps xmlns:a14="http://schemas.microsoft.com/office/drawing/2010/main">
+                  <a14:imgLayer r:embed="rId5">
+                    <a14:imgEffect>
+                      <a14:backgroundRemoval t="9867" b="89867" l="6196" r="91630">
+                        <a14:foregroundMark x1="39022" y1="64000" x2="39022" y2="64000"/>
+                        <a14:foregroundMark x1="10000" y1="55200" x2="10000" y2="55200"/>
+                        <a14:foregroundMark x1="6304" y1="63467" x2="6304" y2="63467"/>
+                        <a14:foregroundMark x1="12935" y1="81067" x2="12935" y2="81067"/>
+                        <a14:foregroundMark x1="12500" y1="78933" x2="12500" y2="78933"/>
+                        <a14:foregroundMark x1="13152" y1="78933" x2="13152" y2="78933"/>
+                        <a14:foregroundMark x1="46413" y1="79467" x2="46413" y2="79467"/>
+                        <a14:foregroundMark x1="36630" y1="39200" x2="36630" y2="39200"/>
+                        <a14:foregroundMark x1="36630" y1="38667" x2="36630" y2="38667"/>
+                        <a14:foregroundMark x1="36630" y1="38400" x2="36630" y2="38400"/>
+                        <a14:foregroundMark x1="36630" y1="37867" x2="36630" y2="37867"/>
+                        <a14:foregroundMark x1="36630" y1="37867" x2="36630" y2="37867"/>
+                        <a14:foregroundMark x1="36630" y1="36800" x2="36630" y2="36800"/>
+                        <a14:foregroundMark x1="30109" y1="29067" x2="30109" y2="29067"/>
+                        <a14:foregroundMark x1="30326" y1="29067" x2="30326" y2="29067"/>
+                        <a14:foregroundMark x1="29891" y1="34667" x2="29891" y2="34667"/>
+                        <a14:foregroundMark x1="30109" y1="34667" x2="30109" y2="34667"/>
+                        <a14:foregroundMark x1="30543" y1="35733" x2="30543" y2="35733"/>
+                        <a14:foregroundMark x1="40326" y1="26400" x2="40326" y2="26400"/>
+                        <a14:foregroundMark x1="40761" y1="26400" x2="40761" y2="26400"/>
+                        <a14:foregroundMark x1="40761" y1="33067" x2="40761" y2="33067"/>
+                        <a14:foregroundMark x1="39891" y1="37333" x2="39891" y2="37333"/>
+                        <a14:foregroundMark x1="38261" y1="38667" x2="38261" y2="38667"/>
+                        <a14:foregroundMark x1="44565" y1="22933" x2="44565" y2="22933"/>
+                        <a14:foregroundMark x1="44783" y1="22933" x2="44783" y2="22933"/>
+                        <a14:foregroundMark x1="49130" y1="15733" x2="49130" y2="15733"/>
+                        <a14:foregroundMark x1="54783" y1="22400" x2="54783" y2="22400"/>
+                        <a14:foregroundMark x1="52935" y1="29600" x2="52935" y2="29600"/>
+                        <a14:foregroundMark x1="38043" y1="29600" x2="38043" y2="29600"/>
+                        <a14:foregroundMark x1="67500" y1="26933" x2="67500" y2="26933"/>
+                        <a14:foregroundMark x1="66739" y1="19733" x2="66739" y2="19733"/>
+                        <a14:foregroundMark x1="88043" y1="16800" x2="88043" y2="16800"/>
+                        <a14:foregroundMark x1="84674" y1="16800" x2="84674" y2="16800"/>
+                        <a14:foregroundMark x1="85326" y1="22933" x2="85326" y2="22933"/>
+                        <a14:foregroundMark x1="90326" y1="24800" x2="90326" y2="24800"/>
+                        <a14:foregroundMark x1="91630" y1="18133" x2="91630" y2="18133"/>
+                        <a14:foregroundMark x1="72174" y1="20267" x2="72174" y2="20267"/>
+                        <a14:foregroundMark x1="72935" y1="25867" x2="72935" y2="25867"/>
+                        <a14:foregroundMark x1="52935" y1="17067" x2="52935" y2="17067"/>
+                        <a14:foregroundMark x1="53696" y1="17067" x2="53696" y2="17067"/>
+                        <a14:foregroundMark x1="38696" y1="24800" x2="38696" y2="24800"/>
+                        <a14:foregroundMark x1="17174" y1="20800" x2="17174" y2="20800"/>
+                        <a14:foregroundMark x1="18152" y1="20800" x2="18152" y2="20800"/>
+                        <a14:foregroundMark x1="18804" y1="17600" x2="18804" y2="17600"/>
+                        <a14:foregroundMark x1="18804" y1="16267" x2="18804" y2="16267"/>
+                        <a14:foregroundMark x1="12717" y1="32000" x2="12717" y2="32000"/>
+                        <a14:foregroundMark x1="12500" y1="13067" x2="12500" y2="13067"/>
+                        <a14:foregroundMark x1="12500" y1="12533" x2="12500" y2="12533"/>
+                        <a14:foregroundMark x1="34457" y1="26400" x2="34457" y2="26400"/>
+                        <a14:foregroundMark x1="49130" y1="22933" x2="49130" y2="22933"/>
+                        <a14:foregroundMark x1="67283" y1="17067" x2="67283" y2="17067"/>
+                        <a14:foregroundMark x1="67283" y1="16800" x2="67283" y2="16800"/>
+                        <a14:foregroundMark x1="67283" y1="16267" x2="67283" y2="16267"/>
+                      </a14:backgroundRemoval>
+                    </a14:imgEffect>
+                  </a14:imgLayer>
+                </a14:imgProps>
+              </a:ext>
+            </a:extLst>
+          </a:blip>
+          <a:stretch>
+            <a:fillRect/>
+          </a:stretch>
+        </p:blipFill>
+        <p:spPr>
+          <a:xfrm>
+            <a:off x="312470" y="5379104"/>
+            <a:ext cx="3037028" cy="1234618"/>
+          </a:xfrm>
+          <a:prstGeom prst="rect">
+            <a:avLst/>
+          </a:prstGeom>
+        </p:spPr>
+      </p:pic>
+    </p:spTree>
+    <p:extLst>
+      <p:ext uri="{BB962C8B-B14F-4D97-AF65-F5344CB8AC3E}">
+        <p14:creationId xmlns:p14="http://schemas.microsoft.com/office/powerpoint/2010/main" val="3251544436"/>
+      </p:ext>
+    </p:extLst>
+  </p:cSld>
+  <p:clrMapOvr>
+    <a:masterClrMapping/>
+  </p:clrMapOvr>
+</p:sld>
+</file>
+
+<file path=ppt/slides/slide5.xml><?xml version="1.0" encoding="utf-8"?>
+<p:sld xmlns:a="http://schemas.openxmlformats.org/drawingml/2006/main" xmlns:r="http://schemas.openxmlformats.org/officeDocument/2006/relationships" xmlns:p="http://schemas.openxmlformats.org/presentationml/2006/main">
+  <p:cSld>
+    <p:spTree>
+      <p:nvGrpSpPr>
+        <p:cNvPr id="1" name="">
+          <a:extLst>
+            <a:ext uri="{FF2B5EF4-FFF2-40B4-BE49-F238E27FC236}">
+              <a16:creationId xmlns:a16="http://schemas.microsoft.com/office/drawing/2014/main" id="{F779FEC8-5205-DDC9-7184-6FC7E1DB802B}"/>
+            </a:ext>
+          </a:extLst>
+        </p:cNvPr>
+        <p:cNvGrpSpPr/>
+        <p:nvPr/>
+      </p:nvGrpSpPr>
+      <p:grpSpPr>
+        <a:xfrm>
+          <a:off x="0" y="0"/>
+          <a:ext cx="0" cy="0"/>
+          <a:chOff x="0" y="0"/>
+          <a:chExt cx="0" cy="0"/>
+        </a:xfrm>
+      </p:grpSpPr>
+      <p:sp>
+        <p:nvSpPr>
+          <p:cNvPr id="3" name="Rectangle 2">
+            <a:extLst>
+              <a:ext uri="{FF2B5EF4-FFF2-40B4-BE49-F238E27FC236}">
+                <a16:creationId xmlns:a16="http://schemas.microsoft.com/office/drawing/2014/main" id="{9DF9C34E-4CD8-773E-46D2-D09D16BCF3EF}"/>
+              </a:ext>
+            </a:extLst>
+          </p:cNvPr>
+          <p:cNvSpPr>
+            <a:spLocks noChangeArrowheads="1"/>
+          </p:cNvSpPr>
+          <p:nvPr/>
+        </p:nvSpPr>
+        <p:spPr bwMode="auto">
+          <a:xfrm>
+            <a:off x="688454" y="375465"/>
+            <a:ext cx="10815091" cy="630942"/>
+          </a:xfrm>
+          <a:prstGeom prst="rect">
+            <a:avLst/>
+          </a:prstGeom>
+          <a:noFill/>
+          <a:ln w="9525">
+            <a:noFill/>
+            <a:miter lim="800000"/>
+            <a:headEnd/>
+            <a:tailEnd/>
+          </a:ln>
+          <a:effectLst/>
+        </p:spPr>
+        <p:txBody>
+          <a:bodyPr wrap="square">
+            <a:spAutoFit/>
+          </a:bodyPr>
+          <a:lstStyle/>
+          <a:p>
+            <a:pPr algn="ctr">
+              <a:defRPr/>
+            </a:pPr>
+            <a:r>
+              <a:rPr lang="en-US" sz="3500" b="1" dirty="0">
+                <a:latin typeface="Avenir"/>
+                <a:cs typeface="Avenir"/>
+              </a:rPr>
+              <a:t>Part 2: Devastation</a:t>
+            </a:r>
+            <a:endParaRPr lang="en-US" sz="3500" b="1" i="1" dirty="0">
+              <a:latin typeface="Avenir"/>
+              <a:cs typeface="Avenir"/>
+            </a:endParaRPr>
+          </a:p>
+        </p:txBody>
+      </p:sp>
+      <p:sp>
+        <p:nvSpPr>
+          <p:cNvPr id="4" name="Rectangle 3">
+            <a:extLst>
+              <a:ext uri="{FF2B5EF4-FFF2-40B4-BE49-F238E27FC236}">
+                <a16:creationId xmlns:a16="http://schemas.microsoft.com/office/drawing/2014/main" id="{376CDA1F-99B5-39E4-EA01-6EA19C72DF2D}"/>
+              </a:ext>
+            </a:extLst>
+          </p:cNvPr>
+          <p:cNvSpPr>
+            <a:spLocks noChangeArrowheads="1"/>
+          </p:cNvSpPr>
+          <p:nvPr/>
+        </p:nvSpPr>
+        <p:spPr bwMode="auto">
+          <a:xfrm>
+            <a:off x="5737867" y="1319357"/>
+            <a:ext cx="6141663" cy="4247317"/>
+          </a:xfrm>
+          <a:prstGeom prst="rect">
+            <a:avLst/>
+          </a:prstGeom>
+          <a:noFill/>
+          <a:ln w="9525">
+            <a:noFill/>
+            <a:miter lim="800000"/>
+            <a:headEnd/>
+            <a:tailEnd/>
+          </a:ln>
+          <a:effectLst/>
+        </p:spPr>
+        <p:txBody>
+          <a:bodyPr wrap="square">
+            <a:spAutoFit/>
+          </a:bodyPr>
+          <a:lstStyle/>
+          <a:p>
+            <a:pPr>
+              <a:defRPr/>
+            </a:pPr>
+            <a:r>
+              <a:rPr lang="en-US" sz="3000" dirty="0">
+                <a:latin typeface="Avenir"/>
+                <a:cs typeface="Avenir"/>
+              </a:rPr>
+              <a:t>Now imagine you want your life cycle to impact humans in the deadliest way possible. How might you exploit parts of your life cycle to deliver maximum carnage on your human host? Would you choose to be a </a:t>
+            </a:r>
+            <a:r>
+              <a:rPr lang="en-US" sz="3000" i="1" dirty="0">
+                <a:latin typeface="Avenir"/>
+                <a:cs typeface="Avenir"/>
+              </a:rPr>
+              <a:t>P. falciparum, P. vivax,</a:t>
+            </a:r>
+            <a:r>
+              <a:rPr lang="en-US" sz="3000" dirty="0">
+                <a:latin typeface="Avenir"/>
+                <a:cs typeface="Avenir"/>
+              </a:rPr>
+              <a:t> </a:t>
+            </a:r>
+            <a:r>
+              <a:rPr lang="en-US" sz="3000" i="1" dirty="0">
+                <a:latin typeface="Avenir"/>
+                <a:cs typeface="Avenir"/>
+              </a:rPr>
+              <a:t>P. </a:t>
+            </a:r>
+            <a:r>
+              <a:rPr lang="en-US" sz="3000" i="1" dirty="0" err="1">
+                <a:latin typeface="Avenir"/>
+                <a:cs typeface="Avenir"/>
+              </a:rPr>
+              <a:t>ovale</a:t>
+            </a:r>
+            <a:r>
+              <a:rPr lang="en-US" sz="3000" i="1" dirty="0">
+                <a:latin typeface="Avenir"/>
+                <a:cs typeface="Avenir"/>
+              </a:rPr>
+              <a:t>, </a:t>
+            </a:r>
+            <a:r>
+              <a:rPr lang="en-US" sz="3000" dirty="0">
+                <a:latin typeface="Avenir"/>
+                <a:cs typeface="Avenir"/>
+              </a:rPr>
+              <a:t>or </a:t>
+            </a:r>
+            <a:r>
+              <a:rPr lang="en-US" sz="3000" i="1" dirty="0">
+                <a:latin typeface="Avenir"/>
+                <a:cs typeface="Avenir"/>
+              </a:rPr>
+              <a:t>P. malariae</a:t>
+            </a:r>
+            <a:r>
+              <a:rPr lang="en-US" sz="3000" dirty="0">
+                <a:latin typeface="Avenir"/>
+                <a:cs typeface="Avenir"/>
+              </a:rPr>
+              <a:t>? Why?</a:t>
+            </a:r>
+            <a:r>
+              <a:rPr lang="en-US" sz="3000" i="1" dirty="0">
+                <a:latin typeface="Avenir"/>
+                <a:cs typeface="Avenir"/>
+              </a:rPr>
+              <a:t> </a:t>
+            </a:r>
+            <a:endParaRPr lang="en-US" sz="3000" dirty="0">
+              <a:latin typeface="Avenir"/>
+              <a:cs typeface="Avenir"/>
+            </a:endParaRPr>
+          </a:p>
+        </p:txBody>
+      </p:sp>
+      <p:sp>
+        <p:nvSpPr>
+          <p:cNvPr id="7" name="Rectangle 6">
+            <a:extLst>
+              <a:ext uri="{FF2B5EF4-FFF2-40B4-BE49-F238E27FC236}">
+                <a16:creationId xmlns:a16="http://schemas.microsoft.com/office/drawing/2014/main" id="{3A60D4A0-A555-B460-C0A8-10C2B4201D67}"/>
+              </a:ext>
+            </a:extLst>
+          </p:cNvPr>
+          <p:cNvSpPr>
+            <a:spLocks noChangeArrowheads="1"/>
+          </p:cNvSpPr>
+          <p:nvPr/>
+        </p:nvSpPr>
+        <p:spPr bwMode="auto">
+          <a:xfrm>
+            <a:off x="3394451" y="5750191"/>
+            <a:ext cx="8485079" cy="492443"/>
+          </a:xfrm>
+          <a:prstGeom prst="rect">
+            <a:avLst/>
+          </a:prstGeom>
+          <a:noFill/>
+          <a:ln w="9525">
+            <a:noFill/>
+            <a:miter lim="800000"/>
+            <a:headEnd/>
+            <a:tailEnd/>
+          </a:ln>
+          <a:effectLst/>
+        </p:spPr>
+        <p:txBody>
+          <a:bodyPr wrap="square">
+            <a:spAutoFit/>
+          </a:bodyPr>
+          <a:lstStyle/>
+          <a:p>
+            <a:pPr>
+              <a:defRPr/>
+            </a:pPr>
+            <a:r>
+              <a:rPr lang="en-US" sz="2600" b="1" dirty="0">
+                <a:latin typeface="Avenir"/>
+                <a:cs typeface="Avenir"/>
+              </a:rPr>
+              <a:t>Discuss with your group (5 min) </a:t>
+            </a:r>
+          </a:p>
+        </p:txBody>
+      </p:sp>
+      <p:pic>
+        <p:nvPicPr>
+          <p:cNvPr id="9" name="Picture 8">
+            <a:extLst>
+              <a:ext uri="{FF2B5EF4-FFF2-40B4-BE49-F238E27FC236}">
+                <a16:creationId xmlns:a16="http://schemas.microsoft.com/office/drawing/2014/main" id="{AA25631C-C363-4EFE-6423-6686587460E8}"/>
+              </a:ext>
+            </a:extLst>
+          </p:cNvPr>
+          <p:cNvPicPr>
+            <a:picLocks noChangeAspect="1"/>
+          </p:cNvPicPr>
+          <p:nvPr/>
+        </p:nvPicPr>
+        <p:blipFill>
+          <a:blip r:embed="rId3">
+            <a:extLst>
+              <a:ext uri="{BEBA8EAE-BF5A-486C-A8C5-ECC9F3942E4B}">
+                <a14:imgProps xmlns:a14="http://schemas.microsoft.com/office/drawing/2010/main">
+                  <a14:imgLayer r:embed="rId4">
+                    <a14:imgEffect>
+                      <a14:backgroundRemoval t="9867" b="89867" l="6196" r="91630">
+                        <a14:foregroundMark x1="39022" y1="64000" x2="39022" y2="64000"/>
+                        <a14:foregroundMark x1="10000" y1="55200" x2="10000" y2="55200"/>
+                        <a14:foregroundMark x1="6304" y1="63467" x2="6304" y2="63467"/>
+                        <a14:foregroundMark x1="12935" y1="81067" x2="12935" y2="81067"/>
+                        <a14:foregroundMark x1="12500" y1="78933" x2="12500" y2="78933"/>
+                        <a14:foregroundMark x1="13152" y1="78933" x2="13152" y2="78933"/>
+                        <a14:foregroundMark x1="46413" y1="79467" x2="46413" y2="79467"/>
+                        <a14:foregroundMark x1="36630" y1="39200" x2="36630" y2="39200"/>
+                        <a14:foregroundMark x1="36630" y1="38667" x2="36630" y2="38667"/>
+                        <a14:foregroundMark x1="36630" y1="38400" x2="36630" y2="38400"/>
+                        <a14:foregroundMark x1="36630" y1="37867" x2="36630" y2="37867"/>
+                        <a14:foregroundMark x1="36630" y1="37867" x2="36630" y2="37867"/>
+                        <a14:foregroundMark x1="36630" y1="36800" x2="36630" y2="36800"/>
+                        <a14:foregroundMark x1="30109" y1="29067" x2="30109" y2="29067"/>
+                        <a14:foregroundMark x1="30326" y1="29067" x2="30326" y2="29067"/>
+                        <a14:foregroundMark x1="29891" y1="34667" x2="29891" y2="34667"/>
+                        <a14:foregroundMark x1="30109" y1="34667" x2="30109" y2="34667"/>
+                        <a14:foregroundMark x1="30543" y1="35733" x2="30543" y2="35733"/>
+                        <a14:foregroundMark x1="40326" y1="26400" x2="40326" y2="26400"/>
+                        <a14:foregroundMark x1="40761" y1="26400" x2="40761" y2="26400"/>
+                        <a14:foregroundMark x1="40761" y1="33067" x2="40761" y2="33067"/>
+                        <a14:foregroundMark x1="39891" y1="37333" x2="39891" y2="37333"/>
+                        <a14:foregroundMark x1="38261" y1="38667" x2="38261" y2="38667"/>
+                        <a14:foregroundMark x1="44565" y1="22933" x2="44565" y2="22933"/>
+                        <a14:foregroundMark x1="44783" y1="22933" x2="44783" y2="22933"/>
+                        <a14:foregroundMark x1="49130" y1="15733" x2="49130" y2="15733"/>
+                        <a14:foregroundMark x1="54783" y1="22400" x2="54783" y2="22400"/>
+                        <a14:foregroundMark x1="52935" y1="29600" x2="52935" y2="29600"/>
+                        <a14:foregroundMark x1="38043" y1="29600" x2="38043" y2="29600"/>
+                        <a14:foregroundMark x1="67500" y1="26933" x2="67500" y2="26933"/>
+                        <a14:foregroundMark x1="66739" y1="19733" x2="66739" y2="19733"/>
+                        <a14:foregroundMark x1="88043" y1="16800" x2="88043" y2="16800"/>
+                        <a14:foregroundMark x1="84674" y1="16800" x2="84674" y2="16800"/>
+                        <a14:foregroundMark x1="85326" y1="22933" x2="85326" y2="22933"/>
+                        <a14:foregroundMark x1="90326" y1="24800" x2="90326" y2="24800"/>
+                        <a14:foregroundMark x1="91630" y1="18133" x2="91630" y2="18133"/>
+                        <a14:foregroundMark x1="72174" y1="20267" x2="72174" y2="20267"/>
+                        <a14:foregroundMark x1="72935" y1="25867" x2="72935" y2="25867"/>
+                        <a14:foregroundMark x1="52935" y1="17067" x2="52935" y2="17067"/>
+                        <a14:foregroundMark x1="53696" y1="17067" x2="53696" y2="17067"/>
+                        <a14:foregroundMark x1="38696" y1="24800" x2="38696" y2="24800"/>
+                        <a14:foregroundMark x1="17174" y1="20800" x2="17174" y2="20800"/>
+                        <a14:foregroundMark x1="18152" y1="20800" x2="18152" y2="20800"/>
+                        <a14:foregroundMark x1="18804" y1="17600" x2="18804" y2="17600"/>
+                        <a14:foregroundMark x1="18804" y1="16267" x2="18804" y2="16267"/>
+                        <a14:foregroundMark x1="12717" y1="32000" x2="12717" y2="32000"/>
+                        <a14:foregroundMark x1="12500" y1="13067" x2="12500" y2="13067"/>
+                        <a14:foregroundMark x1="12500" y1="12533" x2="12500" y2="12533"/>
+                        <a14:foregroundMark x1="34457" y1="26400" x2="34457" y2="26400"/>
+                        <a14:foregroundMark x1="49130" y1="22933" x2="49130" y2="22933"/>
+                        <a14:foregroundMark x1="67283" y1="17067" x2="67283" y2="17067"/>
+                        <a14:foregroundMark x1="67283" y1="16800" x2="67283" y2="16800"/>
+                        <a14:foregroundMark x1="67283" y1="16267" x2="67283" y2="16267"/>
+                      </a14:backgroundRemoval>
+                    </a14:imgEffect>
+                  </a14:imgLayer>
+                </a14:imgProps>
+              </a:ext>
+            </a:extLst>
+          </a:blip>
+          <a:stretch>
+            <a:fillRect/>
+          </a:stretch>
+        </p:blipFill>
+        <p:spPr>
+          <a:xfrm>
+            <a:off x="312470" y="5379104"/>
+            <a:ext cx="3037028" cy="1234618"/>
+          </a:xfrm>
+          <a:prstGeom prst="rect">
+            <a:avLst/>
+          </a:prstGeom>
+        </p:spPr>
+      </p:pic>
+      <p:pic>
+        <p:nvPicPr>
+          <p:cNvPr id="8" name="Picture 2" descr="P">
+            <a:extLst>
+              <a:ext uri="{FF2B5EF4-FFF2-40B4-BE49-F238E27FC236}">
+                <a16:creationId xmlns:a16="http://schemas.microsoft.com/office/drawing/2014/main" id="{1642A8F8-6F3F-EBC3-6940-5347527EDEE0}"/>
+              </a:ext>
+            </a:extLst>
+          </p:cNvPr>
+          <p:cNvPicPr>
+            <a:picLocks noChangeAspect="1" noChangeArrowheads="1"/>
+          </p:cNvPicPr>
+          <p:nvPr/>
+        </p:nvPicPr>
+        <p:blipFill>
+          <a:blip r:embed="rId5">
+            <a:extLst>
+              <a:ext uri="{28A0092B-C50C-407E-A947-70E740481C1C}">
+                <a14:useLocalDpi xmlns:a14="http://schemas.microsoft.com/office/drawing/2010/main" val="0"/>
+              </a:ext>
+            </a:extLst>
+          </a:blip>
+          <a:srcRect/>
+          <a:stretch>
+            <a:fillRect/>
+          </a:stretch>
+        </p:blipFill>
+        <p:spPr bwMode="auto">
+          <a:xfrm>
+            <a:off x="479856" y="1319357"/>
+            <a:ext cx="4968887" cy="3646779"/>
+          </a:xfrm>
+          <a:prstGeom prst="rect">
+            <a:avLst/>
+          </a:prstGeom>
+          <a:noFill/>
+          <a:ln>
+            <a:noFill/>
+          </a:ln>
+          <a:extLst>
+            <a:ext uri="{909E8E84-426E-40dd-AFC4-6F175D3DCCD1}">
+              <a14:hiddenFill xmlns:a14="http://schemas.microsoft.com/office/drawing/2010/main" xmlns="">
+                <a:solidFill>
+                  <a:srgbClr val="FFFFFF"/>
+                </a:solidFill>
+              </a14:hiddenFill>
+            </a:ext>
+            <a:ext uri="{91240B29-F687-4f45-9708-019B960494DF}">
+              <a14:hiddenLine xmlns:a14="http://schemas.microsoft.com/office/drawing/2010/main" xmlns="" w="9525">
+                <a:solidFill>
+                  <a:srgbClr val="000000"/>
+                </a:solidFill>
+                <a:miter lim="800000"/>
+                <a:headEnd/>
+                <a:tailEnd/>
+              </a14:hiddenLine>
+            </a:ext>
+          </a:extLst>
+        </p:spPr>
+      </p:pic>
+    </p:spTree>
+    <p:extLst>
+      <p:ext uri="{BB962C8B-B14F-4D97-AF65-F5344CB8AC3E}">
+        <p14:creationId xmlns:p14="http://schemas.microsoft.com/office/powerpoint/2010/main" val="3982640783"/>
+      </p:ext>
+    </p:extLst>
+  </p:cSld>
+  <p:clrMapOvr>
+    <a:masterClrMapping/>
+  </p:clrMapOvr>
+  <p:timing>
+    <p:tnLst>
+      <p:par>
+        <p:cTn id="1" dur="indefinite" restart="never" nodeType="tmRoot">
+          <p:childTnLst>
+            <p:seq concurrent="1" nextAc="seek">
+              <p:cTn id="2" dur="indefinite" nodeType="mainSeq">
+                <p:childTnLst>
+                  <p:par>
+                    <p:cTn id="3" fill="hold">
+                      <p:stCondLst>
+                        <p:cond delay="indefinite"/>
+                      </p:stCondLst>
+                      <p:childTnLst>
+                        <p:par>
+                          <p:cTn id="4" fill="hold">
+                            <p:stCondLst>
+                              <p:cond delay="0"/>
+                            </p:stCondLst>
+                            <p:childTnLst>
+                              <p:par>
+                                <p:cTn id="5" presetID="1" presetClass="entr" presetSubtype="0" fill="hold" grpId="0" nodeType="clickEffect">
+                                  <p:stCondLst>
+                                    <p:cond delay="0"/>
+                                  </p:stCondLst>
+                                  <p:childTnLst>
+                                    <p:set>
+                                      <p:cBhvr>
+                                        <p:cTn id="6" dur="1" fill="hold">
+                                          <p:stCondLst>
+                                            <p:cond delay="0"/>
+                                          </p:stCondLst>
+                                        </p:cTn>
+                                        <p:tgtEl>
+                                          <p:spTgt spid="4">
+                                            <p:txEl>
+                                              <p:pRg st="0" end="0"/>
+                                            </p:txEl>
+                                          </p:spTgt>
+                                        </p:tgtEl>
+                                        <p:attrNameLst>
+                                          <p:attrName>style.visibility</p:attrName>
+                                        </p:attrNameLst>
+                                      </p:cBhvr>
+                                      <p:to>
+                                        <p:strVal val="visible"/>
+                                      </p:to>
+                                    </p:set>
+                                  </p:childTnLst>
+                                </p:cTn>
+                              </p:par>
+                            </p:childTnLst>
+                          </p:cTn>
+                        </p:par>
+                      </p:childTnLst>
+                    </p:cTn>
+                  </p:par>
+                </p:childTnLst>
+              </p:cTn>
+              <p:prevCondLst>
+                <p:cond evt="onPrev" delay="0">
+                  <p:tgtEl>
+                    <p:sldTgt/>
+                  </p:tgtEl>
+                </p:cond>
+              </p:prevCondLst>
+              <p:nextCondLst>
+                <p:cond evt="onNext" delay="0">
+                  <p:tgtEl>
+                    <p:sldTgt/>
+                  </p:tgtEl>
+                </p:cond>
+              </p:nextCondLst>
+            </p:seq>
+          </p:childTnLst>
+        </p:cTn>
+      </p:par>
+    </p:tnLst>
+    <p:bldLst>
+      <p:bldP spid="4" grpId="0" uiExpand="1" build="p" bldLvl="5"/>
+    </p:bldLst>
+  </p:timing>
+</p:sld>
+</file>
+
+<file path=ppt/slides/slide6.xml><?xml version="1.0" encoding="utf-8"?>
+<p:sld xmlns:a="http://schemas.openxmlformats.org/drawingml/2006/main" xmlns:r="http://schemas.openxmlformats.org/officeDocument/2006/relationships" xmlns:p="http://schemas.openxmlformats.org/presentationml/2006/main">
+  <p:cSld>
+    <p:spTree>
+      <p:nvGrpSpPr>
+        <p:cNvPr id="1" name="">
+          <a:extLst>
+            <a:ext uri="{FF2B5EF4-FFF2-40B4-BE49-F238E27FC236}">
+              <a16:creationId xmlns:a16="http://schemas.microsoft.com/office/drawing/2014/main" id="{59343F66-A705-CF44-6443-E5767538B744}"/>
+            </a:ext>
+          </a:extLst>
+        </p:cNvPr>
+        <p:cNvGrpSpPr/>
+        <p:nvPr/>
+      </p:nvGrpSpPr>
+      <p:grpSpPr>
+        <a:xfrm>
+          <a:off x="0" y="0"/>
+          <a:ext cx="0" cy="0"/>
+          <a:chOff x="0" y="0"/>
+          <a:chExt cx="0" cy="0"/>
+        </a:xfrm>
+      </p:grpSpPr>
+      <p:sp>
+        <p:nvSpPr>
+          <p:cNvPr id="3" name="Rectangle 2">
+            <a:extLst>
+              <a:ext uri="{FF2B5EF4-FFF2-40B4-BE49-F238E27FC236}">
+                <a16:creationId xmlns:a16="http://schemas.microsoft.com/office/drawing/2014/main" id="{91FFA4AD-33B4-A405-6A14-961BB3A30AC1}"/>
+              </a:ext>
+            </a:extLst>
+          </p:cNvPr>
+          <p:cNvSpPr>
+            <a:spLocks noChangeArrowheads="1"/>
+          </p:cNvSpPr>
+          <p:nvPr/>
+        </p:nvSpPr>
+        <p:spPr bwMode="auto">
+          <a:xfrm>
+            <a:off x="688454" y="470060"/>
+            <a:ext cx="10815091" cy="630942"/>
+          </a:xfrm>
+          <a:prstGeom prst="rect">
+            <a:avLst/>
+          </a:prstGeom>
+          <a:noFill/>
+          <a:ln w="9525">
+            <a:noFill/>
+            <a:miter lim="800000"/>
+            <a:headEnd/>
+            <a:tailEnd/>
+          </a:ln>
+          <a:effectLst/>
+        </p:spPr>
+        <p:txBody>
+          <a:bodyPr wrap="square">
+            <a:spAutoFit/>
+          </a:bodyPr>
+          <a:lstStyle/>
+          <a:p>
+            <a:pPr algn="ctr">
+              <a:defRPr/>
+            </a:pPr>
+            <a:r>
+              <a:rPr lang="en-US" sz="3500" b="1" dirty="0">
+                <a:latin typeface="Avenir"/>
+                <a:cs typeface="Avenir"/>
+              </a:rPr>
+              <a:t>Part 3: Life Cycle </a:t>
+            </a:r>
+            <a:endParaRPr lang="en-US" sz="3500" b="1" i="1" dirty="0">
+              <a:latin typeface="Avenir"/>
+              <a:cs typeface="Avenir"/>
+            </a:endParaRPr>
+          </a:p>
+        </p:txBody>
+      </p:sp>
+      <p:sp>
+        <p:nvSpPr>
+          <p:cNvPr id="4" name="Rectangle 3">
+            <a:extLst>
+              <a:ext uri="{FF2B5EF4-FFF2-40B4-BE49-F238E27FC236}">
+                <a16:creationId xmlns:a16="http://schemas.microsoft.com/office/drawing/2014/main" id="{FA95E0E1-3CBD-E95E-A629-F5CCC774214B}"/>
+              </a:ext>
+            </a:extLst>
+          </p:cNvPr>
+          <p:cNvSpPr>
+            <a:spLocks noChangeArrowheads="1"/>
+          </p:cNvSpPr>
+          <p:nvPr/>
+        </p:nvSpPr>
+        <p:spPr bwMode="auto">
+          <a:xfrm>
+            <a:off x="4871544" y="1808892"/>
+            <a:ext cx="6819581" cy="3323987"/>
+          </a:xfrm>
+          <a:prstGeom prst="rect">
+            <a:avLst/>
+          </a:prstGeom>
+          <a:noFill/>
+          <a:ln w="9525">
+            <a:noFill/>
+            <a:miter lim="800000"/>
+            <a:headEnd/>
+            <a:tailEnd/>
+          </a:ln>
+          <a:effectLst/>
+        </p:spPr>
+        <p:txBody>
+          <a:bodyPr wrap="square">
+            <a:spAutoFit/>
+          </a:bodyPr>
+          <a:lstStyle/>
+          <a:p>
+            <a:pPr>
+              <a:defRPr/>
+            </a:pPr>
+            <a:r>
+              <a:rPr lang="en-US" sz="3000" dirty="0">
+                <a:latin typeface="Avenir"/>
+                <a:cs typeface="Avenir"/>
+              </a:rPr>
+              <a:t>Now that your plan is fully solidified, we will take turns as groups presenting your life cycle plan to the class. Make sure you fully explain all that is happening as you move through each step. </a:t>
+            </a:r>
+          </a:p>
+          <a:p>
+            <a:pPr marL="457200" indent="-457200">
+              <a:buFontTx/>
+              <a:buChar char="-"/>
+              <a:defRPr/>
+            </a:pPr>
+            <a:endParaRPr lang="en-US" sz="3000" dirty="0">
+              <a:latin typeface="Avenir"/>
+              <a:cs typeface="Avenir"/>
+            </a:endParaRPr>
+          </a:p>
+        </p:txBody>
+      </p:sp>
+      <p:pic>
+        <p:nvPicPr>
+          <p:cNvPr id="10" name="Picture 9">
+            <a:extLst>
+              <a:ext uri="{FF2B5EF4-FFF2-40B4-BE49-F238E27FC236}">
+                <a16:creationId xmlns:a16="http://schemas.microsoft.com/office/drawing/2014/main" id="{9A4059D9-3ABC-C91F-3FD3-E91ADB43DEAD}"/>
+              </a:ext>
+            </a:extLst>
+          </p:cNvPr>
+          <p:cNvPicPr>
+            <a:picLocks noChangeAspect="1"/>
+          </p:cNvPicPr>
+          <p:nvPr/>
+        </p:nvPicPr>
+        <p:blipFill>
+          <a:blip r:embed="rId3"/>
+          <a:stretch>
+            <a:fillRect/>
+          </a:stretch>
+        </p:blipFill>
+        <p:spPr>
+          <a:xfrm>
+            <a:off x="866224" y="1385665"/>
+            <a:ext cx="3753070" cy="3700853"/>
+          </a:xfrm>
+          <a:prstGeom prst="rect">
+            <a:avLst/>
+          </a:prstGeom>
+        </p:spPr>
+      </p:pic>
+      <p:sp>
+        <p:nvSpPr>
+          <p:cNvPr id="2" name="Rectangle 1">
+            <a:extLst>
+              <a:ext uri="{FF2B5EF4-FFF2-40B4-BE49-F238E27FC236}">
+                <a16:creationId xmlns:a16="http://schemas.microsoft.com/office/drawing/2014/main" id="{28541D6B-96F4-182C-6642-86D4472A50A0}"/>
+              </a:ext>
+            </a:extLst>
+          </p:cNvPr>
+          <p:cNvSpPr>
+            <a:spLocks noChangeArrowheads="1"/>
+          </p:cNvSpPr>
+          <p:nvPr/>
+        </p:nvSpPr>
+        <p:spPr bwMode="auto">
+          <a:xfrm>
+            <a:off x="3394451" y="5321060"/>
+            <a:ext cx="8485079" cy="492443"/>
+          </a:xfrm>
+          <a:prstGeom prst="rect">
+            <a:avLst/>
+          </a:prstGeom>
+          <a:noFill/>
+          <a:ln w="9525">
+            <a:noFill/>
+            <a:miter lim="800000"/>
+            <a:headEnd/>
+            <a:tailEnd/>
+          </a:ln>
+          <a:effectLst/>
+        </p:spPr>
+        <p:txBody>
+          <a:bodyPr wrap="square">
+            <a:spAutoFit/>
+          </a:bodyPr>
+          <a:lstStyle/>
+          <a:p>
+            <a:pPr>
+              <a:defRPr/>
+            </a:pPr>
+            <a:r>
+              <a:rPr lang="en-US" sz="2600" b="1" dirty="0">
+                <a:latin typeface="Avenir"/>
+                <a:cs typeface="Avenir"/>
+              </a:rPr>
+              <a:t>Present your life cycle to the class (5 min max per team)</a:t>
+            </a:r>
+          </a:p>
+        </p:txBody>
+      </p:sp>
+      <p:pic>
+        <p:nvPicPr>
+          <p:cNvPr id="5" name="Picture 4">
+            <a:extLst>
+              <a:ext uri="{FF2B5EF4-FFF2-40B4-BE49-F238E27FC236}">
+                <a16:creationId xmlns:a16="http://schemas.microsoft.com/office/drawing/2014/main" id="{9DA18F1E-FE0D-1E3B-D0B3-450DC8FD72CC}"/>
+              </a:ext>
+            </a:extLst>
+          </p:cNvPr>
+          <p:cNvPicPr>
+            <a:picLocks noChangeAspect="1"/>
+          </p:cNvPicPr>
+          <p:nvPr/>
+        </p:nvPicPr>
+        <p:blipFill>
+          <a:blip r:embed="rId4">
+            <a:extLst>
+              <a:ext uri="{BEBA8EAE-BF5A-486C-A8C5-ECC9F3942E4B}">
+                <a14:imgProps xmlns:a14="http://schemas.microsoft.com/office/drawing/2010/main">
+                  <a14:imgLayer r:embed="rId5">
+                    <a14:imgEffect>
+                      <a14:backgroundRemoval t="9867" b="89867" l="6196" r="91630">
+                        <a14:foregroundMark x1="39022" y1="64000" x2="39022" y2="64000"/>
+                        <a14:foregroundMark x1="10000" y1="55200" x2="10000" y2="55200"/>
+                        <a14:foregroundMark x1="6304" y1="63467" x2="6304" y2="63467"/>
+                        <a14:foregroundMark x1="12935" y1="81067" x2="12935" y2="81067"/>
+                        <a14:foregroundMark x1="12500" y1="78933" x2="12500" y2="78933"/>
+                        <a14:foregroundMark x1="13152" y1="78933" x2="13152" y2="78933"/>
+                        <a14:foregroundMark x1="46413" y1="79467" x2="46413" y2="79467"/>
+                        <a14:foregroundMark x1="36630" y1="39200" x2="36630" y2="39200"/>
+                        <a14:foregroundMark x1="36630" y1="38667" x2="36630" y2="38667"/>
+                        <a14:foregroundMark x1="36630" y1="38400" x2="36630" y2="38400"/>
+                        <a14:foregroundMark x1="36630" y1="37867" x2="36630" y2="37867"/>
+                        <a14:foregroundMark x1="36630" y1="37867" x2="36630" y2="37867"/>
+                        <a14:foregroundMark x1="36630" y1="36800" x2="36630" y2="36800"/>
+                        <a14:foregroundMark x1="30109" y1="29067" x2="30109" y2="29067"/>
+                        <a14:foregroundMark x1="30326" y1="29067" x2="30326" y2="29067"/>
+                        <a14:foregroundMark x1="29891" y1="34667" x2="29891" y2="34667"/>
+                        <a14:foregroundMark x1="30109" y1="34667" x2="30109" y2="34667"/>
+                        <a14:foregroundMark x1="30543" y1="35733" x2="30543" y2="35733"/>
+                        <a14:foregroundMark x1="40326" y1="26400" x2="40326" y2="26400"/>
+                        <a14:foregroundMark x1="40761" y1="26400" x2="40761" y2="26400"/>
+                        <a14:foregroundMark x1="40761" y1="33067" x2="40761" y2="33067"/>
+                        <a14:foregroundMark x1="39891" y1="37333" x2="39891" y2="37333"/>
+                        <a14:foregroundMark x1="38261" y1="38667" x2="38261" y2="38667"/>
+                        <a14:foregroundMark x1="44565" y1="22933" x2="44565" y2="22933"/>
+                        <a14:foregroundMark x1="44783" y1="22933" x2="44783" y2="22933"/>
+                        <a14:foregroundMark x1="49130" y1="15733" x2="49130" y2="15733"/>
+                        <a14:foregroundMark x1="54783" y1="22400" x2="54783" y2="22400"/>
+                        <a14:foregroundMark x1="52935" y1="29600" x2="52935" y2="29600"/>
+                        <a14:foregroundMark x1="38043" y1="29600" x2="38043" y2="29600"/>
+                        <a14:foregroundMark x1="67500" y1="26933" x2="67500" y2="26933"/>
+                        <a14:foregroundMark x1="66739" y1="19733" x2="66739" y2="19733"/>
+                        <a14:foregroundMark x1="88043" y1="16800" x2="88043" y2="16800"/>
+                        <a14:foregroundMark x1="84674" y1="16800" x2="84674" y2="16800"/>
+                        <a14:foregroundMark x1="85326" y1="22933" x2="85326" y2="22933"/>
+                        <a14:foregroundMark x1="90326" y1="24800" x2="90326" y2="24800"/>
+                        <a14:foregroundMark x1="91630" y1="18133" x2="91630" y2="18133"/>
+                        <a14:foregroundMark x1="72174" y1="20267" x2="72174" y2="20267"/>
+                        <a14:foregroundMark x1="72935" y1="25867" x2="72935" y2="25867"/>
+                        <a14:foregroundMark x1="52935" y1="17067" x2="52935" y2="17067"/>
+                        <a14:foregroundMark x1="53696" y1="17067" x2="53696" y2="17067"/>
+                        <a14:foregroundMark x1="38696" y1="24800" x2="38696" y2="24800"/>
+                        <a14:foregroundMark x1="17174" y1="20800" x2="17174" y2="20800"/>
+                        <a14:foregroundMark x1="18152" y1="20800" x2="18152" y2="20800"/>
+                        <a14:foregroundMark x1="18804" y1="17600" x2="18804" y2="17600"/>
+                        <a14:foregroundMark x1="18804" y1="16267" x2="18804" y2="16267"/>
+                        <a14:foregroundMark x1="12717" y1="32000" x2="12717" y2="32000"/>
+                        <a14:foregroundMark x1="12500" y1="13067" x2="12500" y2="13067"/>
+                        <a14:foregroundMark x1="12500" y1="12533" x2="12500" y2="12533"/>
+                        <a14:foregroundMark x1="34457" y1="26400" x2="34457" y2="26400"/>
+                        <a14:foregroundMark x1="49130" y1="22933" x2="49130" y2="22933"/>
+                        <a14:foregroundMark x1="67283" y1="17067" x2="67283" y2="17067"/>
+                        <a14:foregroundMark x1="67283" y1="16800" x2="67283" y2="16800"/>
+                        <a14:foregroundMark x1="67283" y1="16267" x2="67283" y2="16267"/>
+                      </a14:backgroundRemoval>
+                    </a14:imgEffect>
+                  </a14:imgLayer>
+                </a14:imgProps>
+              </a:ext>
+            </a:extLst>
+          </a:blip>
+          <a:stretch>
+            <a:fillRect/>
+          </a:stretch>
+        </p:blipFill>
+        <p:spPr>
+          <a:xfrm>
+            <a:off x="312470" y="5379104"/>
+            <a:ext cx="3037028" cy="1234618"/>
+          </a:xfrm>
+          <a:prstGeom prst="rect">
+            <a:avLst/>
+          </a:prstGeom>
+        </p:spPr>
+      </p:pic>
+    </p:spTree>
+    <p:extLst>
+      <p:ext uri="{BB962C8B-B14F-4D97-AF65-F5344CB8AC3E}">
+        <p14:creationId xmlns:p14="http://schemas.microsoft.com/office/powerpoint/2010/main" val="972951264"/>
+      </p:ext>
+    </p:extLst>
+  </p:cSld>
+  <p:clrMapOvr>
+    <a:masterClrMapping/>
+  </p:clrMapOvr>
+</p:sld>
+</file>
+
+<file path=ppt/slides/slide7.xml><?xml version="1.0" encoding="utf-8"?>
 <p:sld xmlns:a="http://schemas.openxmlformats.org/drawingml/2006/main" xmlns:r="http://schemas.openxmlformats.org/officeDocument/2006/relationships" xmlns:p="http://schemas.openxmlformats.org/presentationml/2006/main">
   <p:cSld>
     <p:spTree>
@@ -4824,7 +7609,7 @@
 </p:sld>
 </file>
 
-<file path=ppt/slides/slide3.xml><?xml version="1.0" encoding="utf-8"?>
+<file path=ppt/slides/slide8.xml><?xml version="1.0" encoding="utf-8"?>
 <p:sld xmlns:a="http://schemas.openxmlformats.org/drawingml/2006/main" xmlns:r="http://schemas.openxmlformats.org/officeDocument/2006/relationships" xmlns:p="http://schemas.openxmlformats.org/presentationml/2006/main">
   <p:cSld>
     <p:spTree>
@@ -5193,14 +7978,14 @@
           </a:ln>
           <a:extLst>
             <a:ext uri="{909E8E84-426E-40dd-AFC4-6F175D3DCCD1}">
-              <a14:hiddenFill xmlns:a14="http://schemas.microsoft.com/office/drawing/2010/main" xmlns="">
+              <a14:hiddenFill xmlns="" xmlns:a14="http://schemas.microsoft.com/office/drawing/2010/main">
                 <a:solidFill>
                   <a:srgbClr val="FFFFFF"/>
                 </a:solidFill>
               </a14:hiddenFill>
             </a:ext>
             <a:ext uri="{91240B29-F687-4f45-9708-019B960494DF}">
-              <a14:hiddenLine xmlns:a14="http://schemas.microsoft.com/office/drawing/2010/main" xmlns="" w="9525">
+              <a14:hiddenLine xmlns="" xmlns:a14="http://schemas.microsoft.com/office/drawing/2010/main" w="9525">
                 <a:solidFill>
                   <a:srgbClr val="000000"/>
                 </a:solidFill>
@@ -5307,7 +8092,7 @@
 </p:sld>
 </file>
 
-<file path=ppt/slides/slide4.xml><?xml version="1.0" encoding="utf-8"?>
+<file path=ppt/slides/slide9.xml><?xml version="1.0" encoding="utf-8"?>
 <p:sld xmlns:a="http://schemas.openxmlformats.org/drawingml/2006/main" xmlns:r="http://schemas.openxmlformats.org/officeDocument/2006/relationships" xmlns:p="http://schemas.openxmlformats.org/presentationml/2006/main">
   <p:cSld>
     <p:spTree>
@@ -5411,339 +8196,6 @@
     <p:extLst>
       <p:ext uri="{BB962C8B-B14F-4D97-AF65-F5344CB8AC3E}">
         <p14:creationId xmlns:p14="http://schemas.microsoft.com/office/powerpoint/2010/main" val="1922457156"/>
-      </p:ext>
-    </p:extLst>
-  </p:cSld>
-  <p:clrMapOvr>
-    <a:masterClrMapping/>
-  </p:clrMapOvr>
-</p:sld>
-</file>
-
-<file path=ppt/slides/slide5.xml><?xml version="1.0" encoding="utf-8"?>
-<p:sld xmlns:a="http://schemas.openxmlformats.org/drawingml/2006/main" xmlns:r="http://schemas.openxmlformats.org/officeDocument/2006/relationships" xmlns:p="http://schemas.openxmlformats.org/presentationml/2006/main">
-  <p:cSld>
-    <p:spTree>
-      <p:nvGrpSpPr>
-        <p:cNvPr id="1" name=""/>
-        <p:cNvGrpSpPr/>
-        <p:nvPr/>
-      </p:nvGrpSpPr>
-      <p:grpSpPr>
-        <a:xfrm>
-          <a:off x="0" y="0"/>
-          <a:ext cx="0" cy="0"/>
-          <a:chOff x="0" y="0"/>
-          <a:chExt cx="0" cy="0"/>
-        </a:xfrm>
-      </p:grpSpPr>
-      <p:sp>
-        <p:nvSpPr>
-          <p:cNvPr id="3" name="Rectangle 2"/>
-          <p:cNvSpPr>
-            <a:spLocks noChangeArrowheads="1"/>
-          </p:cNvSpPr>
-          <p:nvPr/>
-        </p:nvSpPr>
-        <p:spPr bwMode="auto">
-          <a:xfrm>
-            <a:off x="1290725" y="2132881"/>
-            <a:ext cx="9610544" cy="1938992"/>
-          </a:xfrm>
-          <a:prstGeom prst="rect">
-            <a:avLst/>
-          </a:prstGeom>
-          <a:noFill/>
-          <a:ln w="9525">
-            <a:noFill/>
-            <a:miter lim="800000"/>
-            <a:headEnd/>
-            <a:tailEnd/>
-          </a:ln>
-          <a:effectLst/>
-        </p:spPr>
-        <p:txBody>
-          <a:bodyPr wrap="square">
-            <a:spAutoFit/>
-          </a:bodyPr>
-          <a:lstStyle/>
-          <a:p>
-            <a:pPr>
-              <a:defRPr/>
-            </a:pPr>
-            <a:r>
-              <a:rPr lang="en-US" sz="4000" b="1" dirty="0">
-                <a:latin typeface="Avenir"/>
-                <a:cs typeface="Avenir"/>
-              </a:rPr>
-              <a:t>Q3. Name all the possible approaches to malaria control that you can think of, no matter how off-beat.</a:t>
-            </a:r>
-          </a:p>
-        </p:txBody>
-      </p:sp>
-      <p:pic>
-        <p:nvPicPr>
-          <p:cNvPr id="2" name="Picture 1">
-            <a:extLst>
-              <a:ext uri="{FF2B5EF4-FFF2-40B4-BE49-F238E27FC236}">
-                <a16:creationId xmlns:a16="http://schemas.microsoft.com/office/drawing/2014/main" id="{9FACBA41-11B5-F54D-A1B8-5709EE3A2B76}"/>
-              </a:ext>
-            </a:extLst>
-          </p:cNvPr>
-          <p:cNvPicPr>
-            <a:picLocks noChangeAspect="1"/>
-          </p:cNvPicPr>
-          <p:nvPr/>
-        </p:nvPicPr>
-        <p:blipFill>
-          <a:blip r:embed="rId3"/>
-          <a:stretch>
-            <a:fillRect/>
-          </a:stretch>
-        </p:blipFill>
-        <p:spPr>
-          <a:xfrm>
-            <a:off x="4423137" y="4526619"/>
-            <a:ext cx="3345721" cy="541574"/>
-          </a:xfrm>
-          <a:prstGeom prst="rect">
-            <a:avLst/>
-          </a:prstGeom>
-        </p:spPr>
-      </p:pic>
-    </p:spTree>
-    <p:extLst>
-      <p:ext uri="{BB962C8B-B14F-4D97-AF65-F5344CB8AC3E}">
-        <p14:creationId xmlns:p14="http://schemas.microsoft.com/office/powerpoint/2010/main" val="2235385179"/>
-      </p:ext>
-    </p:extLst>
-  </p:cSld>
-  <p:clrMapOvr>
-    <a:masterClrMapping/>
-  </p:clrMapOvr>
-</p:sld>
-</file>
-
-<file path=ppt/slides/slide6.xml><?xml version="1.0" encoding="utf-8"?>
-<p:sld xmlns:a="http://schemas.openxmlformats.org/drawingml/2006/main" xmlns:r="http://schemas.openxmlformats.org/officeDocument/2006/relationships" xmlns:p="http://schemas.openxmlformats.org/presentationml/2006/main">
-  <p:cSld>
-    <p:spTree>
-      <p:nvGrpSpPr>
-        <p:cNvPr id="1" name=""/>
-        <p:cNvGrpSpPr/>
-        <p:nvPr/>
-      </p:nvGrpSpPr>
-      <p:grpSpPr>
-        <a:xfrm>
-          <a:off x="0" y="0"/>
-          <a:ext cx="0" cy="0"/>
-          <a:chOff x="0" y="0"/>
-          <a:chExt cx="0" cy="0"/>
-        </a:xfrm>
-      </p:grpSpPr>
-      <p:sp>
-        <p:nvSpPr>
-          <p:cNvPr id="2" name="Title 1">
-            <a:extLst>
-              <a:ext uri="{FF2B5EF4-FFF2-40B4-BE49-F238E27FC236}">
-                <a16:creationId xmlns:a16="http://schemas.microsoft.com/office/drawing/2014/main" id="{F26535DE-EFFA-4743-9340-27C8F7D02E15}"/>
-              </a:ext>
-            </a:extLst>
-          </p:cNvPr>
-          <p:cNvSpPr>
-            <a:spLocks noGrp="1"/>
-          </p:cNvSpPr>
-          <p:nvPr>
-            <p:ph type="ctrTitle"/>
-          </p:nvPr>
-        </p:nvSpPr>
-        <p:spPr/>
-        <p:txBody>
-          <a:bodyPr/>
-          <a:lstStyle/>
-          <a:p>
-            <a:endParaRPr lang="en-US"/>
-          </a:p>
-        </p:txBody>
-      </p:sp>
-      <p:sp>
-        <p:nvSpPr>
-          <p:cNvPr id="3" name="Subtitle 2">
-            <a:extLst>
-              <a:ext uri="{FF2B5EF4-FFF2-40B4-BE49-F238E27FC236}">
-                <a16:creationId xmlns:a16="http://schemas.microsoft.com/office/drawing/2014/main" id="{9737E0AA-F0EF-2345-B4E0-3ADC4009057C}"/>
-              </a:ext>
-            </a:extLst>
-          </p:cNvPr>
-          <p:cNvSpPr>
-            <a:spLocks noGrp="1"/>
-          </p:cNvSpPr>
-          <p:nvPr>
-            <p:ph type="subTitle" idx="1"/>
-          </p:nvPr>
-        </p:nvSpPr>
-        <p:spPr/>
-        <p:txBody>
-          <a:bodyPr/>
-          <a:lstStyle/>
-          <a:p>
-            <a:endParaRPr lang="en-US"/>
-          </a:p>
-        </p:txBody>
-      </p:sp>
-      <p:pic>
-        <p:nvPicPr>
-          <p:cNvPr id="5" name="slide.url=https://www.polleverywhere.com/free_text_polls/vsf2KQkyvrM1PaFnc4kyp">
-            <a:extLst>
-              <a:ext uri="{FF2B5EF4-FFF2-40B4-BE49-F238E27FC236}">
-                <a16:creationId xmlns:a16="http://schemas.microsoft.com/office/drawing/2014/main" id="{19A4FBBD-9D12-D945-8345-AF9553165F66}"/>
-              </a:ext>
-            </a:extLst>
-          </p:cNvPr>
-          <p:cNvPicPr>
-            <a:picLocks/>
-          </p:cNvPicPr>
-          <p:nvPr/>
-        </p:nvPicPr>
-        <p:blipFill>
-          <a:blip r:embed="rId3"/>
-          <a:stretch>
-            <a:fillRect/>
-          </a:stretch>
-        </p:blipFill>
-        <p:spPr>
-          <a:xfrm>
-            <a:off x="63500" y="63500"/>
-            <a:ext cx="12065000" cy="6731000"/>
-          </a:xfrm>
-          <a:prstGeom prst="rect">
-            <a:avLst/>
-          </a:prstGeom>
-        </p:spPr>
-      </p:pic>
-    </p:spTree>
-    <p:extLst>
-      <p:ext uri="{BB962C8B-B14F-4D97-AF65-F5344CB8AC3E}">
-        <p14:creationId xmlns:p14="http://schemas.microsoft.com/office/powerpoint/2010/main" val="1148876153"/>
-      </p:ext>
-    </p:extLst>
-  </p:cSld>
-  <p:clrMapOvr>
-    <a:masterClrMapping/>
-  </p:clrMapOvr>
-</p:sld>
-</file>
-
-<file path=ppt/slides/slide7.xml><?xml version="1.0" encoding="utf-8"?>
-<p:sld xmlns:a="http://schemas.openxmlformats.org/drawingml/2006/main" xmlns:r="http://schemas.openxmlformats.org/officeDocument/2006/relationships" xmlns:p="http://schemas.openxmlformats.org/presentationml/2006/main">
-  <p:cSld>
-    <p:bg>
-      <p:bgPr>
-        <a:solidFill>
-          <a:schemeClr val="tx1"/>
-        </a:solidFill>
-        <a:effectLst/>
-      </p:bgPr>
-    </p:bg>
-    <p:spTree>
-      <p:nvGrpSpPr>
-        <p:cNvPr id="1" name=""/>
-        <p:cNvGrpSpPr/>
-        <p:nvPr/>
-      </p:nvGrpSpPr>
-      <p:grpSpPr>
-        <a:xfrm>
-          <a:off x="0" y="0"/>
-          <a:ext cx="0" cy="0"/>
-          <a:chOff x="0" y="0"/>
-          <a:chExt cx="0" cy="0"/>
-        </a:xfrm>
-      </p:grpSpPr>
-      <p:sp>
-        <p:nvSpPr>
-          <p:cNvPr id="2" name="Rectangle 2"/>
-          <p:cNvSpPr>
-            <a:spLocks noChangeArrowheads="1"/>
-          </p:cNvSpPr>
-          <p:nvPr/>
-        </p:nvSpPr>
-        <p:spPr bwMode="auto">
-          <a:xfrm>
-            <a:off x="352524" y="2644170"/>
-            <a:ext cx="10896600" cy="1569660"/>
-          </a:xfrm>
-          <a:prstGeom prst="rect">
-            <a:avLst/>
-          </a:prstGeom>
-          <a:noFill/>
-          <a:ln w="9525">
-            <a:noFill/>
-            <a:miter lim="800000"/>
-            <a:headEnd/>
-            <a:tailEnd/>
-          </a:ln>
-          <a:effectLst/>
-        </p:spPr>
-        <p:txBody>
-          <a:bodyPr wrap="square">
-            <a:spAutoFit/>
-          </a:bodyPr>
-          <a:lstStyle/>
-          <a:p>
-            <a:pPr>
-              <a:defRPr/>
-            </a:pPr>
-            <a:r>
-              <a:rPr lang="en-US" sz="4800" b="1" dirty="0">
-                <a:solidFill>
-                  <a:schemeClr val="bg1">
-                    <a:lumMod val="65000"/>
-                  </a:schemeClr>
-                </a:solidFill>
-                <a:latin typeface="Avenir Book" panose="02000503020000020003" pitchFamily="2" charset="0"/>
-                <a:cs typeface="Avenir"/>
-              </a:rPr>
-              <a:t>Practical session 22</a:t>
-            </a:r>
-            <a:r>
-              <a:rPr lang="en-US" sz="4800" dirty="0">
-                <a:solidFill>
-                  <a:schemeClr val="bg1">
-                    <a:lumMod val="65000"/>
-                  </a:schemeClr>
-                </a:solidFill>
-                <a:latin typeface="Avenir Book" panose="02000503020000020003" pitchFamily="2" charset="0"/>
-                <a:cs typeface="Avenir"/>
-              </a:rPr>
-              <a:t>: </a:t>
-            </a:r>
-            <a:r>
-              <a:rPr lang="en-US" sz="4800" dirty="0">
-                <a:solidFill>
-                  <a:srgbClr val="FFFFFF"/>
-                </a:solidFill>
-                <a:latin typeface="Avenir Book" panose="02000503020000020003" pitchFamily="2" charset="0"/>
-                <a:cs typeface="Avenir"/>
-              </a:rPr>
-              <a:t>The apicomplexan </a:t>
-            </a:r>
-            <a:r>
-              <a:rPr lang="en-US" sz="4800" i="1" dirty="0">
-                <a:solidFill>
-                  <a:srgbClr val="FFFFFF"/>
-                </a:solidFill>
-                <a:latin typeface="Avenir Book" panose="02000503020000020003" pitchFamily="2" charset="0"/>
-                <a:cs typeface="Avenir"/>
-              </a:rPr>
-              <a:t>Plasmodium</a:t>
-            </a:r>
-          </a:p>
-        </p:txBody>
-      </p:sp>
-    </p:spTree>
-    <p:extLst>
-      <p:ext uri="{BB962C8B-B14F-4D97-AF65-F5344CB8AC3E}">
-        <p14:creationId xmlns:p14="http://schemas.microsoft.com/office/powerpoint/2010/main" val="2371518768"/>
       </p:ext>
     </p:extLst>
   </p:cSld>

</xml_diff>

<commit_message>
updated lecture 22 pptx
</commit_message>
<xml_diff>
--- a/docs/lectures/in-class_activities/class_22.pptx
+++ b/docs/lectures/in-class_activities/class_22.pptx
@@ -12,8 +12,8 @@
     <p:sldId id="1594" r:id="rId3"/>
     <p:sldId id="1595" r:id="rId4"/>
     <p:sldId id="1596" r:id="rId5"/>
-    <p:sldId id="1597" r:id="rId6"/>
-    <p:sldId id="1598" r:id="rId7"/>
+    <p:sldId id="1598" r:id="rId6"/>
+    <p:sldId id="1597" r:id="rId7"/>
     <p:sldId id="723" r:id="rId8"/>
     <p:sldId id="1590" r:id="rId9"/>
     <p:sldId id="1591" r:id="rId10"/>
@@ -208,7 +208,7 @@
           <a:p>
             <a:fld id="{6AC7DB66-C6D6-B24E-B345-FA3772C924EA}" type="datetimeFigureOut">
               <a:rPr lang="en-US" smtClean="0"/>
-              <a:t>11/18/25</a:t>
+              <a:t>11/19/25</a:t>
             </a:fld>
             <a:endParaRPr lang="en-US"/>
           </a:p>
@@ -1152,7 +1152,7 @@
         <p:cNvPr id="1" name="">
           <a:extLst>
             <a:ext uri="{FF2B5EF4-FFF2-40B4-BE49-F238E27FC236}">
-              <a16:creationId xmlns:a16="http://schemas.microsoft.com/office/drawing/2014/main" id="{03917AE8-F338-E0C9-0E18-228CA0654BD7}"/>
+              <a16:creationId xmlns:a16="http://schemas.microsoft.com/office/drawing/2014/main" id="{1AF94943-0A6B-2333-1918-756B9EC9734B}"/>
             </a:ext>
           </a:extLst>
         </p:cNvPr>
@@ -1172,7 +1172,7 @@
           <p:cNvPr id="2" name="Slide Image Placeholder 1">
             <a:extLst>
               <a:ext uri="{FF2B5EF4-FFF2-40B4-BE49-F238E27FC236}">
-                <a16:creationId xmlns:a16="http://schemas.microsoft.com/office/drawing/2014/main" id="{00E86FE6-BAC5-3501-459A-83AE558E3922}"/>
+                <a16:creationId xmlns:a16="http://schemas.microsoft.com/office/drawing/2014/main" id="{2C1A22EE-09FA-DB7C-3B8E-CC8E30252BBB}"/>
               </a:ext>
             </a:extLst>
           </p:cNvPr>
@@ -1190,7 +1190,7 @@
           <p:cNvPr id="3" name="Notes Placeholder 2">
             <a:extLst>
               <a:ext uri="{FF2B5EF4-FFF2-40B4-BE49-F238E27FC236}">
-                <a16:creationId xmlns:a16="http://schemas.microsoft.com/office/drawing/2014/main" id="{670E8B48-8DC2-D975-5B9C-C72DA12F1F91}"/>
+                <a16:creationId xmlns:a16="http://schemas.microsoft.com/office/drawing/2014/main" id="{6B4DCF34-79D1-859D-5441-71A6B274702E}"/>
               </a:ext>
             </a:extLst>
           </p:cNvPr>
@@ -1215,7 +1215,7 @@
           <p:cNvPr id="4" name="Slide Number Placeholder 3">
             <a:extLst>
               <a:ext uri="{FF2B5EF4-FFF2-40B4-BE49-F238E27FC236}">
-                <a16:creationId xmlns:a16="http://schemas.microsoft.com/office/drawing/2014/main" id="{29029035-4079-374D-0D7B-75FCFE87AE79}"/>
+                <a16:creationId xmlns:a16="http://schemas.microsoft.com/office/drawing/2014/main" id="{ED0873B5-CAE9-270D-F7D2-F555F6449780}"/>
               </a:ext>
             </a:extLst>
           </p:cNvPr>
@@ -1242,7 +1242,7 @@
     </p:spTree>
     <p:extLst>
       <p:ext uri="{BB962C8B-B14F-4D97-AF65-F5344CB8AC3E}">
-        <p14:creationId xmlns:p14="http://schemas.microsoft.com/office/powerpoint/2010/main" val="1069863724"/>
+        <p14:creationId xmlns:p14="http://schemas.microsoft.com/office/powerpoint/2010/main" val="3475602434"/>
       </p:ext>
     </p:extLst>
   </p:cSld>
@@ -1260,7 +1260,7 @@
         <p:cNvPr id="1" name="">
           <a:extLst>
             <a:ext uri="{FF2B5EF4-FFF2-40B4-BE49-F238E27FC236}">
-              <a16:creationId xmlns:a16="http://schemas.microsoft.com/office/drawing/2014/main" id="{1AF94943-0A6B-2333-1918-756B9EC9734B}"/>
+              <a16:creationId xmlns:a16="http://schemas.microsoft.com/office/drawing/2014/main" id="{03917AE8-F338-E0C9-0E18-228CA0654BD7}"/>
             </a:ext>
           </a:extLst>
         </p:cNvPr>
@@ -1280,7 +1280,7 @@
           <p:cNvPr id="2" name="Slide Image Placeholder 1">
             <a:extLst>
               <a:ext uri="{FF2B5EF4-FFF2-40B4-BE49-F238E27FC236}">
-                <a16:creationId xmlns:a16="http://schemas.microsoft.com/office/drawing/2014/main" id="{2C1A22EE-09FA-DB7C-3B8E-CC8E30252BBB}"/>
+                <a16:creationId xmlns:a16="http://schemas.microsoft.com/office/drawing/2014/main" id="{00E86FE6-BAC5-3501-459A-83AE558E3922}"/>
               </a:ext>
             </a:extLst>
           </p:cNvPr>
@@ -1298,7 +1298,7 @@
           <p:cNvPr id="3" name="Notes Placeholder 2">
             <a:extLst>
               <a:ext uri="{FF2B5EF4-FFF2-40B4-BE49-F238E27FC236}">
-                <a16:creationId xmlns:a16="http://schemas.microsoft.com/office/drawing/2014/main" id="{6B4DCF34-79D1-859D-5441-71A6B274702E}"/>
+                <a16:creationId xmlns:a16="http://schemas.microsoft.com/office/drawing/2014/main" id="{670E8B48-8DC2-D975-5B9C-C72DA12F1F91}"/>
               </a:ext>
             </a:extLst>
           </p:cNvPr>
@@ -1323,7 +1323,7 @@
           <p:cNvPr id="4" name="Slide Number Placeholder 3">
             <a:extLst>
               <a:ext uri="{FF2B5EF4-FFF2-40B4-BE49-F238E27FC236}">
-                <a16:creationId xmlns:a16="http://schemas.microsoft.com/office/drawing/2014/main" id="{ED0873B5-CAE9-270D-F7D2-F555F6449780}"/>
+                <a16:creationId xmlns:a16="http://schemas.microsoft.com/office/drawing/2014/main" id="{29029035-4079-374D-0D7B-75FCFE87AE79}"/>
               </a:ext>
             </a:extLst>
           </p:cNvPr>
@@ -1350,7 +1350,7 @@
     </p:spTree>
     <p:extLst>
       <p:ext uri="{BB962C8B-B14F-4D97-AF65-F5344CB8AC3E}">
-        <p14:creationId xmlns:p14="http://schemas.microsoft.com/office/powerpoint/2010/main" val="3475602434"/>
+        <p14:creationId xmlns:p14="http://schemas.microsoft.com/office/powerpoint/2010/main" val="1069863724"/>
       </p:ext>
     </p:extLst>
   </p:cSld>
@@ -1782,7 +1782,7 @@
           <a:p>
             <a:fld id="{21DDE3A9-9D48-7D40-AF95-520AE186EA5D}" type="datetimeFigureOut">
               <a:rPr lang="en-US" smtClean="0"/>
-              <a:t>11/18/25</a:t>
+              <a:t>11/19/25</a:t>
             </a:fld>
             <a:endParaRPr lang="en-US"/>
           </a:p>
@@ -1980,7 +1980,7 @@
           <a:p>
             <a:fld id="{21DDE3A9-9D48-7D40-AF95-520AE186EA5D}" type="datetimeFigureOut">
               <a:rPr lang="en-US" smtClean="0"/>
-              <a:t>11/18/25</a:t>
+              <a:t>11/19/25</a:t>
             </a:fld>
             <a:endParaRPr lang="en-US"/>
           </a:p>
@@ -2188,7 +2188,7 @@
           <a:p>
             <a:fld id="{21DDE3A9-9D48-7D40-AF95-520AE186EA5D}" type="datetimeFigureOut">
               <a:rPr lang="en-US" smtClean="0"/>
-              <a:t>11/18/25</a:t>
+              <a:t>11/19/25</a:t>
             </a:fld>
             <a:endParaRPr lang="en-US"/>
           </a:p>
@@ -2386,7 +2386,7 @@
           <a:p>
             <a:fld id="{21DDE3A9-9D48-7D40-AF95-520AE186EA5D}" type="datetimeFigureOut">
               <a:rPr lang="en-US" smtClean="0"/>
-              <a:t>11/18/25</a:t>
+              <a:t>11/19/25</a:t>
             </a:fld>
             <a:endParaRPr lang="en-US"/>
           </a:p>
@@ -2661,7 +2661,7 @@
           <a:p>
             <a:fld id="{21DDE3A9-9D48-7D40-AF95-520AE186EA5D}" type="datetimeFigureOut">
               <a:rPr lang="en-US" smtClean="0"/>
-              <a:t>11/18/25</a:t>
+              <a:t>11/19/25</a:t>
             </a:fld>
             <a:endParaRPr lang="en-US"/>
           </a:p>
@@ -2926,7 +2926,7 @@
           <a:p>
             <a:fld id="{21DDE3A9-9D48-7D40-AF95-520AE186EA5D}" type="datetimeFigureOut">
               <a:rPr lang="en-US" smtClean="0"/>
-              <a:t>11/18/25</a:t>
+              <a:t>11/19/25</a:t>
             </a:fld>
             <a:endParaRPr lang="en-US"/>
           </a:p>
@@ -3338,7 +3338,7 @@
           <a:p>
             <a:fld id="{21DDE3A9-9D48-7D40-AF95-520AE186EA5D}" type="datetimeFigureOut">
               <a:rPr lang="en-US" smtClean="0"/>
-              <a:t>11/18/25</a:t>
+              <a:t>11/19/25</a:t>
             </a:fld>
             <a:endParaRPr lang="en-US"/>
           </a:p>
@@ -3479,7 +3479,7 @@
           <a:p>
             <a:fld id="{21DDE3A9-9D48-7D40-AF95-520AE186EA5D}" type="datetimeFigureOut">
               <a:rPr lang="en-US" smtClean="0"/>
-              <a:t>11/18/25</a:t>
+              <a:t>11/19/25</a:t>
             </a:fld>
             <a:endParaRPr lang="en-US"/>
           </a:p>
@@ -3592,7 +3592,7 @@
           <a:p>
             <a:fld id="{21DDE3A9-9D48-7D40-AF95-520AE186EA5D}" type="datetimeFigureOut">
               <a:rPr lang="en-US" smtClean="0"/>
-              <a:t>11/18/25</a:t>
+              <a:t>11/19/25</a:t>
             </a:fld>
             <a:endParaRPr lang="en-US"/>
           </a:p>
@@ -3903,7 +3903,7 @@
           <a:p>
             <a:fld id="{21DDE3A9-9D48-7D40-AF95-520AE186EA5D}" type="datetimeFigureOut">
               <a:rPr lang="en-US" smtClean="0"/>
-              <a:t>11/18/25</a:t>
+              <a:t>11/19/25</a:t>
             </a:fld>
             <a:endParaRPr lang="en-US"/>
           </a:p>
@@ -4191,7 +4191,7 @@
           <a:p>
             <a:fld id="{21DDE3A9-9D48-7D40-AF95-520AE186EA5D}" type="datetimeFigureOut">
               <a:rPr lang="en-US" smtClean="0"/>
-              <a:t>11/18/25</a:t>
+              <a:t>11/19/25</a:t>
             </a:fld>
             <a:endParaRPr lang="en-US"/>
           </a:p>
@@ -4432,7 +4432,7 @@
           <a:p>
             <a:fld id="{21DDE3A9-9D48-7D40-AF95-520AE186EA5D}" type="datetimeFigureOut">
               <a:rPr lang="en-US" smtClean="0"/>
-              <a:t>11/18/25</a:t>
+              <a:t>11/19/25</a:t>
             </a:fld>
             <a:endParaRPr lang="en-US"/>
           </a:p>
@@ -5658,7 +5658,7 @@
         <p:spPr bwMode="auto">
           <a:xfrm>
             <a:off x="4846830" y="1101002"/>
-            <a:ext cx="6819581" cy="5632311"/>
+            <a:ext cx="6819581" cy="5016758"/>
           </a:xfrm>
           <a:prstGeom prst="rect">
             <a:avLst/>
@@ -5696,7 +5696,7 @@
               <a:defRPr/>
             </a:pPr>
             <a:r>
-              <a:rPr lang="en-US" sz="3000" dirty="0">
+              <a:rPr lang="en-US" sz="2000" dirty="0">
                 <a:latin typeface="Avenir"/>
                 <a:cs typeface="Avenir"/>
               </a:rPr>
@@ -5710,7 +5710,7 @@
               <a:defRPr/>
             </a:pPr>
             <a:r>
-              <a:rPr lang="en-US" sz="3000" dirty="0">
+              <a:rPr lang="en-US" sz="2000" dirty="0">
                 <a:latin typeface="Avenir"/>
                 <a:cs typeface="Avenir"/>
               </a:rPr>
@@ -5724,7 +5724,7 @@
               <a:defRPr/>
             </a:pPr>
             <a:r>
-              <a:rPr lang="en-US" sz="3000" dirty="0">
+              <a:rPr lang="en-US" sz="2000" dirty="0">
                 <a:latin typeface="Avenir"/>
                 <a:cs typeface="Avenir"/>
               </a:rPr>
@@ -5738,7 +5738,7 @@
               <a:defRPr/>
             </a:pPr>
             <a:r>
-              <a:rPr lang="en-US" sz="3000" dirty="0">
+              <a:rPr lang="en-US" sz="2000" dirty="0">
                 <a:latin typeface="Avenir"/>
                 <a:cs typeface="Avenir"/>
               </a:rPr>
@@ -5752,7 +5752,7 @@
               <a:defRPr/>
             </a:pPr>
             <a:r>
-              <a:rPr lang="en-US" sz="3000" dirty="0">
+              <a:rPr lang="en-US" sz="2000" dirty="0">
                 <a:latin typeface="Avenir"/>
                 <a:cs typeface="Avenir"/>
               </a:rPr>
@@ -5766,7 +5766,7 @@
               <a:defRPr/>
             </a:pPr>
             <a:r>
-              <a:rPr lang="en-US" sz="3000" dirty="0">
+              <a:rPr lang="en-US" sz="2000" dirty="0">
                 <a:latin typeface="Avenir"/>
                 <a:cs typeface="Avenir"/>
               </a:rPr>
@@ -5780,7 +5780,7 @@
               <a:defRPr/>
             </a:pPr>
             <a:r>
-              <a:rPr lang="en-US" sz="3000" dirty="0">
+              <a:rPr lang="en-US" sz="2000" dirty="0">
                 <a:latin typeface="Avenir"/>
                 <a:cs typeface="Avenir"/>
               </a:rPr>
@@ -5794,12 +5794,46 @@
               <a:defRPr/>
             </a:pPr>
             <a:r>
-              <a:rPr lang="en-US" sz="3000" dirty="0">
+              <a:rPr lang="en-US" sz="2000" dirty="0">
                 <a:latin typeface="Avenir"/>
                 <a:cs typeface="Avenir"/>
               </a:rPr>
               <a:t>gametocytes</a:t>
             </a:r>
+          </a:p>
+          <a:p>
+            <a:pPr marL="457200" indent="-457200">
+              <a:buFontTx/>
+              <a:buChar char="-"/>
+              <a:defRPr/>
+            </a:pPr>
+            <a:r>
+              <a:rPr lang="en-US" sz="2000" i="1" dirty="0">
+                <a:latin typeface="Avenir"/>
+                <a:cs typeface="Avenir"/>
+              </a:rPr>
+              <a:t>Plasmodium </a:t>
+            </a:r>
+            <a:r>
+              <a:rPr lang="en-US" sz="2000" dirty="0">
+                <a:latin typeface="Avenir"/>
+                <a:cs typeface="Avenir"/>
+              </a:rPr>
+              <a:t>parasite</a:t>
+            </a:r>
+            <a:endParaRPr lang="en-US" sz="2000" i="1" dirty="0">
+              <a:latin typeface="Avenir"/>
+              <a:cs typeface="Avenir"/>
+            </a:endParaRPr>
+          </a:p>
+          <a:p>
+            <a:pPr>
+              <a:defRPr/>
+            </a:pPr>
+            <a:endParaRPr lang="en-US" sz="2000" dirty="0">
+              <a:latin typeface="Avenir"/>
+              <a:cs typeface="Avenir"/>
+            </a:endParaRPr>
           </a:p>
           <a:p>
             <a:pPr marL="457200" indent="-457200">
@@ -6377,6 +6411,333 @@
         <p:cNvPr id="1" name="">
           <a:extLst>
             <a:ext uri="{FF2B5EF4-FFF2-40B4-BE49-F238E27FC236}">
+              <a16:creationId xmlns:a16="http://schemas.microsoft.com/office/drawing/2014/main" id="{59343F66-A705-CF44-6443-E5767538B744}"/>
+            </a:ext>
+          </a:extLst>
+        </p:cNvPr>
+        <p:cNvGrpSpPr/>
+        <p:nvPr/>
+      </p:nvGrpSpPr>
+      <p:grpSpPr>
+        <a:xfrm>
+          <a:off x="0" y="0"/>
+          <a:ext cx="0" cy="0"/>
+          <a:chOff x="0" y="0"/>
+          <a:chExt cx="0" cy="0"/>
+        </a:xfrm>
+      </p:grpSpPr>
+      <p:sp>
+        <p:nvSpPr>
+          <p:cNvPr id="3" name="Rectangle 2">
+            <a:extLst>
+              <a:ext uri="{FF2B5EF4-FFF2-40B4-BE49-F238E27FC236}">
+                <a16:creationId xmlns:a16="http://schemas.microsoft.com/office/drawing/2014/main" id="{91FFA4AD-33B4-A405-6A14-961BB3A30AC1}"/>
+              </a:ext>
+            </a:extLst>
+          </p:cNvPr>
+          <p:cNvSpPr>
+            <a:spLocks noChangeArrowheads="1"/>
+          </p:cNvSpPr>
+          <p:nvPr/>
+        </p:nvSpPr>
+        <p:spPr bwMode="auto">
+          <a:xfrm>
+            <a:off x="688454" y="470060"/>
+            <a:ext cx="10815091" cy="630942"/>
+          </a:xfrm>
+          <a:prstGeom prst="rect">
+            <a:avLst/>
+          </a:prstGeom>
+          <a:noFill/>
+          <a:ln w="9525">
+            <a:noFill/>
+            <a:miter lim="800000"/>
+            <a:headEnd/>
+            <a:tailEnd/>
+          </a:ln>
+          <a:effectLst/>
+        </p:spPr>
+        <p:txBody>
+          <a:bodyPr wrap="square">
+            <a:spAutoFit/>
+          </a:bodyPr>
+          <a:lstStyle/>
+          <a:p>
+            <a:pPr algn="ctr">
+              <a:defRPr/>
+            </a:pPr>
+            <a:r>
+              <a:rPr lang="en-US" sz="3500" b="1" dirty="0">
+                <a:latin typeface="Avenir"/>
+                <a:cs typeface="Avenir"/>
+              </a:rPr>
+              <a:t>Part 3: Life Cycle </a:t>
+            </a:r>
+            <a:endParaRPr lang="en-US" sz="3500" b="1" i="1" dirty="0">
+              <a:latin typeface="Avenir"/>
+              <a:cs typeface="Avenir"/>
+            </a:endParaRPr>
+          </a:p>
+        </p:txBody>
+      </p:sp>
+      <p:sp>
+        <p:nvSpPr>
+          <p:cNvPr id="4" name="Rectangle 3">
+            <a:extLst>
+              <a:ext uri="{FF2B5EF4-FFF2-40B4-BE49-F238E27FC236}">
+                <a16:creationId xmlns:a16="http://schemas.microsoft.com/office/drawing/2014/main" id="{FA95E0E1-3CBD-E95E-A629-F5CCC774214B}"/>
+              </a:ext>
+            </a:extLst>
+          </p:cNvPr>
+          <p:cNvSpPr>
+            <a:spLocks noChangeArrowheads="1"/>
+          </p:cNvSpPr>
+          <p:nvPr/>
+        </p:nvSpPr>
+        <p:spPr bwMode="auto">
+          <a:xfrm>
+            <a:off x="4871544" y="1808892"/>
+            <a:ext cx="6819581" cy="3323987"/>
+          </a:xfrm>
+          <a:prstGeom prst="rect">
+            <a:avLst/>
+          </a:prstGeom>
+          <a:noFill/>
+          <a:ln w="9525">
+            <a:noFill/>
+            <a:miter lim="800000"/>
+            <a:headEnd/>
+            <a:tailEnd/>
+          </a:ln>
+          <a:effectLst/>
+        </p:spPr>
+        <p:txBody>
+          <a:bodyPr wrap="square">
+            <a:spAutoFit/>
+          </a:bodyPr>
+          <a:lstStyle/>
+          <a:p>
+            <a:pPr>
+              <a:defRPr/>
+            </a:pPr>
+            <a:r>
+              <a:rPr lang="en-US" sz="3000" dirty="0">
+                <a:latin typeface="Avenir"/>
+                <a:cs typeface="Avenir"/>
+              </a:rPr>
+              <a:t>Now that your plan is fully solidified, we will take turns as groups presenting your life cycle plan to the class. Make sure you fully explain all that is happening as you move through each step. </a:t>
+            </a:r>
+          </a:p>
+          <a:p>
+            <a:pPr marL="457200" indent="-457200">
+              <a:buFontTx/>
+              <a:buChar char="-"/>
+              <a:defRPr/>
+            </a:pPr>
+            <a:endParaRPr lang="en-US" sz="3000" dirty="0">
+              <a:latin typeface="Avenir"/>
+              <a:cs typeface="Avenir"/>
+            </a:endParaRPr>
+          </a:p>
+        </p:txBody>
+      </p:sp>
+      <p:pic>
+        <p:nvPicPr>
+          <p:cNvPr id="10" name="Picture 9">
+            <a:extLst>
+              <a:ext uri="{FF2B5EF4-FFF2-40B4-BE49-F238E27FC236}">
+                <a16:creationId xmlns:a16="http://schemas.microsoft.com/office/drawing/2014/main" id="{9A4059D9-3ABC-C91F-3FD3-E91ADB43DEAD}"/>
+              </a:ext>
+            </a:extLst>
+          </p:cNvPr>
+          <p:cNvPicPr>
+            <a:picLocks noChangeAspect="1"/>
+          </p:cNvPicPr>
+          <p:nvPr/>
+        </p:nvPicPr>
+        <p:blipFill>
+          <a:blip r:embed="rId3"/>
+          <a:stretch>
+            <a:fillRect/>
+          </a:stretch>
+        </p:blipFill>
+        <p:spPr>
+          <a:xfrm>
+            <a:off x="866224" y="1385665"/>
+            <a:ext cx="3753070" cy="3700853"/>
+          </a:xfrm>
+          <a:prstGeom prst="rect">
+            <a:avLst/>
+          </a:prstGeom>
+        </p:spPr>
+      </p:pic>
+      <p:sp>
+        <p:nvSpPr>
+          <p:cNvPr id="2" name="Rectangle 1">
+            <a:extLst>
+              <a:ext uri="{FF2B5EF4-FFF2-40B4-BE49-F238E27FC236}">
+                <a16:creationId xmlns:a16="http://schemas.microsoft.com/office/drawing/2014/main" id="{28541D6B-96F4-182C-6642-86D4472A50A0}"/>
+              </a:ext>
+            </a:extLst>
+          </p:cNvPr>
+          <p:cNvSpPr>
+            <a:spLocks noChangeArrowheads="1"/>
+          </p:cNvSpPr>
+          <p:nvPr/>
+        </p:nvSpPr>
+        <p:spPr bwMode="auto">
+          <a:xfrm>
+            <a:off x="3394451" y="5321060"/>
+            <a:ext cx="8485079" cy="492443"/>
+          </a:xfrm>
+          <a:prstGeom prst="rect">
+            <a:avLst/>
+          </a:prstGeom>
+          <a:noFill/>
+          <a:ln w="9525">
+            <a:noFill/>
+            <a:miter lim="800000"/>
+            <a:headEnd/>
+            <a:tailEnd/>
+          </a:ln>
+          <a:effectLst/>
+        </p:spPr>
+        <p:txBody>
+          <a:bodyPr wrap="square">
+            <a:spAutoFit/>
+          </a:bodyPr>
+          <a:lstStyle/>
+          <a:p>
+            <a:pPr>
+              <a:defRPr/>
+            </a:pPr>
+            <a:r>
+              <a:rPr lang="en-US" sz="2600" b="1" dirty="0">
+                <a:latin typeface="Avenir"/>
+                <a:cs typeface="Avenir"/>
+              </a:rPr>
+              <a:t>Present your life cycle to the class (10 min)</a:t>
+            </a:r>
+          </a:p>
+        </p:txBody>
+      </p:sp>
+      <p:pic>
+        <p:nvPicPr>
+          <p:cNvPr id="5" name="Picture 4">
+            <a:extLst>
+              <a:ext uri="{FF2B5EF4-FFF2-40B4-BE49-F238E27FC236}">
+                <a16:creationId xmlns:a16="http://schemas.microsoft.com/office/drawing/2014/main" id="{9DA18F1E-FE0D-1E3B-D0B3-450DC8FD72CC}"/>
+              </a:ext>
+            </a:extLst>
+          </p:cNvPr>
+          <p:cNvPicPr>
+            <a:picLocks noChangeAspect="1"/>
+          </p:cNvPicPr>
+          <p:nvPr/>
+        </p:nvPicPr>
+        <p:blipFill>
+          <a:blip r:embed="rId4">
+            <a:extLst>
+              <a:ext uri="{BEBA8EAE-BF5A-486C-A8C5-ECC9F3942E4B}">
+                <a14:imgProps xmlns:a14="http://schemas.microsoft.com/office/drawing/2010/main">
+                  <a14:imgLayer r:embed="rId5">
+                    <a14:imgEffect>
+                      <a14:backgroundRemoval t="9867" b="89867" l="6196" r="91630">
+                        <a14:foregroundMark x1="39022" y1="64000" x2="39022" y2="64000"/>
+                        <a14:foregroundMark x1="10000" y1="55200" x2="10000" y2="55200"/>
+                        <a14:foregroundMark x1="6304" y1="63467" x2="6304" y2="63467"/>
+                        <a14:foregroundMark x1="12935" y1="81067" x2="12935" y2="81067"/>
+                        <a14:foregroundMark x1="12500" y1="78933" x2="12500" y2="78933"/>
+                        <a14:foregroundMark x1="13152" y1="78933" x2="13152" y2="78933"/>
+                        <a14:foregroundMark x1="46413" y1="79467" x2="46413" y2="79467"/>
+                        <a14:foregroundMark x1="36630" y1="39200" x2="36630" y2="39200"/>
+                        <a14:foregroundMark x1="36630" y1="38667" x2="36630" y2="38667"/>
+                        <a14:foregroundMark x1="36630" y1="38400" x2="36630" y2="38400"/>
+                        <a14:foregroundMark x1="36630" y1="37867" x2="36630" y2="37867"/>
+                        <a14:foregroundMark x1="36630" y1="37867" x2="36630" y2="37867"/>
+                        <a14:foregroundMark x1="36630" y1="36800" x2="36630" y2="36800"/>
+                        <a14:foregroundMark x1="30109" y1="29067" x2="30109" y2="29067"/>
+                        <a14:foregroundMark x1="30326" y1="29067" x2="30326" y2="29067"/>
+                        <a14:foregroundMark x1="29891" y1="34667" x2="29891" y2="34667"/>
+                        <a14:foregroundMark x1="30109" y1="34667" x2="30109" y2="34667"/>
+                        <a14:foregroundMark x1="30543" y1="35733" x2="30543" y2="35733"/>
+                        <a14:foregroundMark x1="40326" y1="26400" x2="40326" y2="26400"/>
+                        <a14:foregroundMark x1="40761" y1="26400" x2="40761" y2="26400"/>
+                        <a14:foregroundMark x1="40761" y1="33067" x2="40761" y2="33067"/>
+                        <a14:foregroundMark x1="39891" y1="37333" x2="39891" y2="37333"/>
+                        <a14:foregroundMark x1="38261" y1="38667" x2="38261" y2="38667"/>
+                        <a14:foregroundMark x1="44565" y1="22933" x2="44565" y2="22933"/>
+                        <a14:foregroundMark x1="44783" y1="22933" x2="44783" y2="22933"/>
+                        <a14:foregroundMark x1="49130" y1="15733" x2="49130" y2="15733"/>
+                        <a14:foregroundMark x1="54783" y1="22400" x2="54783" y2="22400"/>
+                        <a14:foregroundMark x1="52935" y1="29600" x2="52935" y2="29600"/>
+                        <a14:foregroundMark x1="38043" y1="29600" x2="38043" y2="29600"/>
+                        <a14:foregroundMark x1="67500" y1="26933" x2="67500" y2="26933"/>
+                        <a14:foregroundMark x1="66739" y1="19733" x2="66739" y2="19733"/>
+                        <a14:foregroundMark x1="88043" y1="16800" x2="88043" y2="16800"/>
+                        <a14:foregroundMark x1="84674" y1="16800" x2="84674" y2="16800"/>
+                        <a14:foregroundMark x1="85326" y1="22933" x2="85326" y2="22933"/>
+                        <a14:foregroundMark x1="90326" y1="24800" x2="90326" y2="24800"/>
+                        <a14:foregroundMark x1="91630" y1="18133" x2="91630" y2="18133"/>
+                        <a14:foregroundMark x1="72174" y1="20267" x2="72174" y2="20267"/>
+                        <a14:foregroundMark x1="72935" y1="25867" x2="72935" y2="25867"/>
+                        <a14:foregroundMark x1="52935" y1="17067" x2="52935" y2="17067"/>
+                        <a14:foregroundMark x1="53696" y1="17067" x2="53696" y2="17067"/>
+                        <a14:foregroundMark x1="38696" y1="24800" x2="38696" y2="24800"/>
+                        <a14:foregroundMark x1="17174" y1="20800" x2="17174" y2="20800"/>
+                        <a14:foregroundMark x1="18152" y1="20800" x2="18152" y2="20800"/>
+                        <a14:foregroundMark x1="18804" y1="17600" x2="18804" y2="17600"/>
+                        <a14:foregroundMark x1="18804" y1="16267" x2="18804" y2="16267"/>
+                        <a14:foregroundMark x1="12717" y1="32000" x2="12717" y2="32000"/>
+                        <a14:foregroundMark x1="12500" y1="13067" x2="12500" y2="13067"/>
+                        <a14:foregroundMark x1="12500" y1="12533" x2="12500" y2="12533"/>
+                        <a14:foregroundMark x1="34457" y1="26400" x2="34457" y2="26400"/>
+                        <a14:foregroundMark x1="49130" y1="22933" x2="49130" y2="22933"/>
+                        <a14:foregroundMark x1="67283" y1="17067" x2="67283" y2="17067"/>
+                        <a14:foregroundMark x1="67283" y1="16800" x2="67283" y2="16800"/>
+                        <a14:foregroundMark x1="67283" y1="16267" x2="67283" y2="16267"/>
+                      </a14:backgroundRemoval>
+                    </a14:imgEffect>
+                  </a14:imgLayer>
+                </a14:imgProps>
+              </a:ext>
+            </a:extLst>
+          </a:blip>
+          <a:stretch>
+            <a:fillRect/>
+          </a:stretch>
+        </p:blipFill>
+        <p:spPr>
+          <a:xfrm>
+            <a:off x="312470" y="5379104"/>
+            <a:ext cx="3037028" cy="1234618"/>
+          </a:xfrm>
+          <a:prstGeom prst="rect">
+            <a:avLst/>
+          </a:prstGeom>
+        </p:spPr>
+      </p:pic>
+    </p:spTree>
+    <p:extLst>
+      <p:ext uri="{BB962C8B-B14F-4D97-AF65-F5344CB8AC3E}">
+        <p14:creationId xmlns:p14="http://schemas.microsoft.com/office/powerpoint/2010/main" val="972951264"/>
+      </p:ext>
+    </p:extLst>
+  </p:cSld>
+  <p:clrMapOvr>
+    <a:masterClrMapping/>
+  </p:clrMapOvr>
+</p:sld>
+</file>
+
+<file path=ppt/slides/slide6.xml><?xml version="1.0" encoding="utf-8"?>
+<p:sld xmlns:a="http://schemas.openxmlformats.org/drawingml/2006/main" xmlns:r="http://schemas.openxmlformats.org/officeDocument/2006/relationships" xmlns:p="http://schemas.openxmlformats.org/presentationml/2006/main">
+  <p:cSld>
+    <p:spTree>
+      <p:nvGrpSpPr>
+        <p:cNvPr id="1" name="">
+          <a:extLst>
+            <a:ext uri="{FF2B5EF4-FFF2-40B4-BE49-F238E27FC236}">
               <a16:creationId xmlns:a16="http://schemas.microsoft.com/office/drawing/2014/main" id="{F779FEC8-5205-DDC9-7184-6FC7E1DB802B}"/>
             </a:ext>
           </a:extLst>
@@ -6579,8 +6940,8 @@
         </p:nvSpPr>
         <p:spPr bwMode="auto">
           <a:xfrm>
-            <a:off x="3394451" y="5750191"/>
-            <a:ext cx="8485079" cy="492443"/>
+            <a:off x="3394451" y="5879624"/>
+            <a:ext cx="8797549" cy="492443"/>
           </a:xfrm>
           <a:prstGeom prst="rect">
             <a:avLst/>
@@ -6608,7 +6969,7 @@
                 <a:latin typeface="Avenir"/>
                 <a:cs typeface="Avenir"/>
               </a:rPr>
-              <a:t>Discuss with your group (5 min) </a:t>
+              <a:t>Discuss with your group (2 min), and with the class (3 min)  </a:t>
             </a:r>
           </a:p>
         </p:txBody>
@@ -6750,14 +7111,14 @@
           </a:ln>
           <a:extLst>
             <a:ext uri="{909E8E84-426E-40dd-AFC4-6F175D3DCCD1}">
-              <a14:hiddenFill xmlns:a14="http://schemas.microsoft.com/office/drawing/2010/main" xmlns="">
+              <a14:hiddenFill xmlns="" xmlns:a14="http://schemas.microsoft.com/office/drawing/2010/main">
                 <a:solidFill>
                   <a:srgbClr val="FFFFFF"/>
                 </a:solidFill>
               </a14:hiddenFill>
             </a:ext>
             <a:ext uri="{91240B29-F687-4f45-9708-019B960494DF}">
-              <a14:hiddenLine xmlns:a14="http://schemas.microsoft.com/office/drawing/2010/main" xmlns="" w="9525">
+              <a14:hiddenLine xmlns="" xmlns:a14="http://schemas.microsoft.com/office/drawing/2010/main" w="9525">
                 <a:solidFill>
                   <a:srgbClr val="000000"/>
                 </a:solidFill>
@@ -6861,333 +7222,6 @@
       <p:bldP spid="4" grpId="0" uiExpand="1" build="p" bldLvl="5"/>
     </p:bldLst>
   </p:timing>
-</p:sld>
-</file>
-
-<file path=ppt/slides/slide6.xml><?xml version="1.0" encoding="utf-8"?>
-<p:sld xmlns:a="http://schemas.openxmlformats.org/drawingml/2006/main" xmlns:r="http://schemas.openxmlformats.org/officeDocument/2006/relationships" xmlns:p="http://schemas.openxmlformats.org/presentationml/2006/main">
-  <p:cSld>
-    <p:spTree>
-      <p:nvGrpSpPr>
-        <p:cNvPr id="1" name="">
-          <a:extLst>
-            <a:ext uri="{FF2B5EF4-FFF2-40B4-BE49-F238E27FC236}">
-              <a16:creationId xmlns:a16="http://schemas.microsoft.com/office/drawing/2014/main" id="{59343F66-A705-CF44-6443-E5767538B744}"/>
-            </a:ext>
-          </a:extLst>
-        </p:cNvPr>
-        <p:cNvGrpSpPr/>
-        <p:nvPr/>
-      </p:nvGrpSpPr>
-      <p:grpSpPr>
-        <a:xfrm>
-          <a:off x="0" y="0"/>
-          <a:ext cx="0" cy="0"/>
-          <a:chOff x="0" y="0"/>
-          <a:chExt cx="0" cy="0"/>
-        </a:xfrm>
-      </p:grpSpPr>
-      <p:sp>
-        <p:nvSpPr>
-          <p:cNvPr id="3" name="Rectangle 2">
-            <a:extLst>
-              <a:ext uri="{FF2B5EF4-FFF2-40B4-BE49-F238E27FC236}">
-                <a16:creationId xmlns:a16="http://schemas.microsoft.com/office/drawing/2014/main" id="{91FFA4AD-33B4-A405-6A14-961BB3A30AC1}"/>
-              </a:ext>
-            </a:extLst>
-          </p:cNvPr>
-          <p:cNvSpPr>
-            <a:spLocks noChangeArrowheads="1"/>
-          </p:cNvSpPr>
-          <p:nvPr/>
-        </p:nvSpPr>
-        <p:spPr bwMode="auto">
-          <a:xfrm>
-            <a:off x="688454" y="470060"/>
-            <a:ext cx="10815091" cy="630942"/>
-          </a:xfrm>
-          <a:prstGeom prst="rect">
-            <a:avLst/>
-          </a:prstGeom>
-          <a:noFill/>
-          <a:ln w="9525">
-            <a:noFill/>
-            <a:miter lim="800000"/>
-            <a:headEnd/>
-            <a:tailEnd/>
-          </a:ln>
-          <a:effectLst/>
-        </p:spPr>
-        <p:txBody>
-          <a:bodyPr wrap="square">
-            <a:spAutoFit/>
-          </a:bodyPr>
-          <a:lstStyle/>
-          <a:p>
-            <a:pPr algn="ctr">
-              <a:defRPr/>
-            </a:pPr>
-            <a:r>
-              <a:rPr lang="en-US" sz="3500" b="1" dirty="0">
-                <a:latin typeface="Avenir"/>
-                <a:cs typeface="Avenir"/>
-              </a:rPr>
-              <a:t>Part 3: Life Cycle </a:t>
-            </a:r>
-            <a:endParaRPr lang="en-US" sz="3500" b="1" i="1" dirty="0">
-              <a:latin typeface="Avenir"/>
-              <a:cs typeface="Avenir"/>
-            </a:endParaRPr>
-          </a:p>
-        </p:txBody>
-      </p:sp>
-      <p:sp>
-        <p:nvSpPr>
-          <p:cNvPr id="4" name="Rectangle 3">
-            <a:extLst>
-              <a:ext uri="{FF2B5EF4-FFF2-40B4-BE49-F238E27FC236}">
-                <a16:creationId xmlns:a16="http://schemas.microsoft.com/office/drawing/2014/main" id="{FA95E0E1-3CBD-E95E-A629-F5CCC774214B}"/>
-              </a:ext>
-            </a:extLst>
-          </p:cNvPr>
-          <p:cNvSpPr>
-            <a:spLocks noChangeArrowheads="1"/>
-          </p:cNvSpPr>
-          <p:nvPr/>
-        </p:nvSpPr>
-        <p:spPr bwMode="auto">
-          <a:xfrm>
-            <a:off x="4871544" y="1808892"/>
-            <a:ext cx="6819581" cy="3323987"/>
-          </a:xfrm>
-          <a:prstGeom prst="rect">
-            <a:avLst/>
-          </a:prstGeom>
-          <a:noFill/>
-          <a:ln w="9525">
-            <a:noFill/>
-            <a:miter lim="800000"/>
-            <a:headEnd/>
-            <a:tailEnd/>
-          </a:ln>
-          <a:effectLst/>
-        </p:spPr>
-        <p:txBody>
-          <a:bodyPr wrap="square">
-            <a:spAutoFit/>
-          </a:bodyPr>
-          <a:lstStyle/>
-          <a:p>
-            <a:pPr>
-              <a:defRPr/>
-            </a:pPr>
-            <a:r>
-              <a:rPr lang="en-US" sz="3000" dirty="0">
-                <a:latin typeface="Avenir"/>
-                <a:cs typeface="Avenir"/>
-              </a:rPr>
-              <a:t>Now that your plan is fully solidified, we will take turns as groups presenting your life cycle plan to the class. Make sure you fully explain all that is happening as you move through each step. </a:t>
-            </a:r>
-          </a:p>
-          <a:p>
-            <a:pPr marL="457200" indent="-457200">
-              <a:buFontTx/>
-              <a:buChar char="-"/>
-              <a:defRPr/>
-            </a:pPr>
-            <a:endParaRPr lang="en-US" sz="3000" dirty="0">
-              <a:latin typeface="Avenir"/>
-              <a:cs typeface="Avenir"/>
-            </a:endParaRPr>
-          </a:p>
-        </p:txBody>
-      </p:sp>
-      <p:pic>
-        <p:nvPicPr>
-          <p:cNvPr id="10" name="Picture 9">
-            <a:extLst>
-              <a:ext uri="{FF2B5EF4-FFF2-40B4-BE49-F238E27FC236}">
-                <a16:creationId xmlns:a16="http://schemas.microsoft.com/office/drawing/2014/main" id="{9A4059D9-3ABC-C91F-3FD3-E91ADB43DEAD}"/>
-              </a:ext>
-            </a:extLst>
-          </p:cNvPr>
-          <p:cNvPicPr>
-            <a:picLocks noChangeAspect="1"/>
-          </p:cNvPicPr>
-          <p:nvPr/>
-        </p:nvPicPr>
-        <p:blipFill>
-          <a:blip r:embed="rId3"/>
-          <a:stretch>
-            <a:fillRect/>
-          </a:stretch>
-        </p:blipFill>
-        <p:spPr>
-          <a:xfrm>
-            <a:off x="866224" y="1385665"/>
-            <a:ext cx="3753070" cy="3700853"/>
-          </a:xfrm>
-          <a:prstGeom prst="rect">
-            <a:avLst/>
-          </a:prstGeom>
-        </p:spPr>
-      </p:pic>
-      <p:sp>
-        <p:nvSpPr>
-          <p:cNvPr id="2" name="Rectangle 1">
-            <a:extLst>
-              <a:ext uri="{FF2B5EF4-FFF2-40B4-BE49-F238E27FC236}">
-                <a16:creationId xmlns:a16="http://schemas.microsoft.com/office/drawing/2014/main" id="{28541D6B-96F4-182C-6642-86D4472A50A0}"/>
-              </a:ext>
-            </a:extLst>
-          </p:cNvPr>
-          <p:cNvSpPr>
-            <a:spLocks noChangeArrowheads="1"/>
-          </p:cNvSpPr>
-          <p:nvPr/>
-        </p:nvSpPr>
-        <p:spPr bwMode="auto">
-          <a:xfrm>
-            <a:off x="3394451" y="5321060"/>
-            <a:ext cx="8485079" cy="492443"/>
-          </a:xfrm>
-          <a:prstGeom prst="rect">
-            <a:avLst/>
-          </a:prstGeom>
-          <a:noFill/>
-          <a:ln w="9525">
-            <a:noFill/>
-            <a:miter lim="800000"/>
-            <a:headEnd/>
-            <a:tailEnd/>
-          </a:ln>
-          <a:effectLst/>
-        </p:spPr>
-        <p:txBody>
-          <a:bodyPr wrap="square">
-            <a:spAutoFit/>
-          </a:bodyPr>
-          <a:lstStyle/>
-          <a:p>
-            <a:pPr>
-              <a:defRPr/>
-            </a:pPr>
-            <a:r>
-              <a:rPr lang="en-US" sz="2600" b="1" dirty="0">
-                <a:latin typeface="Avenir"/>
-                <a:cs typeface="Avenir"/>
-              </a:rPr>
-              <a:t>Present your life cycle to the class (5 min max per team)</a:t>
-            </a:r>
-          </a:p>
-        </p:txBody>
-      </p:sp>
-      <p:pic>
-        <p:nvPicPr>
-          <p:cNvPr id="5" name="Picture 4">
-            <a:extLst>
-              <a:ext uri="{FF2B5EF4-FFF2-40B4-BE49-F238E27FC236}">
-                <a16:creationId xmlns:a16="http://schemas.microsoft.com/office/drawing/2014/main" id="{9DA18F1E-FE0D-1E3B-D0B3-450DC8FD72CC}"/>
-              </a:ext>
-            </a:extLst>
-          </p:cNvPr>
-          <p:cNvPicPr>
-            <a:picLocks noChangeAspect="1"/>
-          </p:cNvPicPr>
-          <p:nvPr/>
-        </p:nvPicPr>
-        <p:blipFill>
-          <a:blip r:embed="rId4">
-            <a:extLst>
-              <a:ext uri="{BEBA8EAE-BF5A-486C-A8C5-ECC9F3942E4B}">
-                <a14:imgProps xmlns:a14="http://schemas.microsoft.com/office/drawing/2010/main">
-                  <a14:imgLayer r:embed="rId5">
-                    <a14:imgEffect>
-                      <a14:backgroundRemoval t="9867" b="89867" l="6196" r="91630">
-                        <a14:foregroundMark x1="39022" y1="64000" x2="39022" y2="64000"/>
-                        <a14:foregroundMark x1="10000" y1="55200" x2="10000" y2="55200"/>
-                        <a14:foregroundMark x1="6304" y1="63467" x2="6304" y2="63467"/>
-                        <a14:foregroundMark x1="12935" y1="81067" x2="12935" y2="81067"/>
-                        <a14:foregroundMark x1="12500" y1="78933" x2="12500" y2="78933"/>
-                        <a14:foregroundMark x1="13152" y1="78933" x2="13152" y2="78933"/>
-                        <a14:foregroundMark x1="46413" y1="79467" x2="46413" y2="79467"/>
-                        <a14:foregroundMark x1="36630" y1="39200" x2="36630" y2="39200"/>
-                        <a14:foregroundMark x1="36630" y1="38667" x2="36630" y2="38667"/>
-                        <a14:foregroundMark x1="36630" y1="38400" x2="36630" y2="38400"/>
-                        <a14:foregroundMark x1="36630" y1="37867" x2="36630" y2="37867"/>
-                        <a14:foregroundMark x1="36630" y1="37867" x2="36630" y2="37867"/>
-                        <a14:foregroundMark x1="36630" y1="36800" x2="36630" y2="36800"/>
-                        <a14:foregroundMark x1="30109" y1="29067" x2="30109" y2="29067"/>
-                        <a14:foregroundMark x1="30326" y1="29067" x2="30326" y2="29067"/>
-                        <a14:foregroundMark x1="29891" y1="34667" x2="29891" y2="34667"/>
-                        <a14:foregroundMark x1="30109" y1="34667" x2="30109" y2="34667"/>
-                        <a14:foregroundMark x1="30543" y1="35733" x2="30543" y2="35733"/>
-                        <a14:foregroundMark x1="40326" y1="26400" x2="40326" y2="26400"/>
-                        <a14:foregroundMark x1="40761" y1="26400" x2="40761" y2="26400"/>
-                        <a14:foregroundMark x1="40761" y1="33067" x2="40761" y2="33067"/>
-                        <a14:foregroundMark x1="39891" y1="37333" x2="39891" y2="37333"/>
-                        <a14:foregroundMark x1="38261" y1="38667" x2="38261" y2="38667"/>
-                        <a14:foregroundMark x1="44565" y1="22933" x2="44565" y2="22933"/>
-                        <a14:foregroundMark x1="44783" y1="22933" x2="44783" y2="22933"/>
-                        <a14:foregroundMark x1="49130" y1="15733" x2="49130" y2="15733"/>
-                        <a14:foregroundMark x1="54783" y1="22400" x2="54783" y2="22400"/>
-                        <a14:foregroundMark x1="52935" y1="29600" x2="52935" y2="29600"/>
-                        <a14:foregroundMark x1="38043" y1="29600" x2="38043" y2="29600"/>
-                        <a14:foregroundMark x1="67500" y1="26933" x2="67500" y2="26933"/>
-                        <a14:foregroundMark x1="66739" y1="19733" x2="66739" y2="19733"/>
-                        <a14:foregroundMark x1="88043" y1="16800" x2="88043" y2="16800"/>
-                        <a14:foregroundMark x1="84674" y1="16800" x2="84674" y2="16800"/>
-                        <a14:foregroundMark x1="85326" y1="22933" x2="85326" y2="22933"/>
-                        <a14:foregroundMark x1="90326" y1="24800" x2="90326" y2="24800"/>
-                        <a14:foregroundMark x1="91630" y1="18133" x2="91630" y2="18133"/>
-                        <a14:foregroundMark x1="72174" y1="20267" x2="72174" y2="20267"/>
-                        <a14:foregroundMark x1="72935" y1="25867" x2="72935" y2="25867"/>
-                        <a14:foregroundMark x1="52935" y1="17067" x2="52935" y2="17067"/>
-                        <a14:foregroundMark x1="53696" y1="17067" x2="53696" y2="17067"/>
-                        <a14:foregroundMark x1="38696" y1="24800" x2="38696" y2="24800"/>
-                        <a14:foregroundMark x1="17174" y1="20800" x2="17174" y2="20800"/>
-                        <a14:foregroundMark x1="18152" y1="20800" x2="18152" y2="20800"/>
-                        <a14:foregroundMark x1="18804" y1="17600" x2="18804" y2="17600"/>
-                        <a14:foregroundMark x1="18804" y1="16267" x2="18804" y2="16267"/>
-                        <a14:foregroundMark x1="12717" y1="32000" x2="12717" y2="32000"/>
-                        <a14:foregroundMark x1="12500" y1="13067" x2="12500" y2="13067"/>
-                        <a14:foregroundMark x1="12500" y1="12533" x2="12500" y2="12533"/>
-                        <a14:foregroundMark x1="34457" y1="26400" x2="34457" y2="26400"/>
-                        <a14:foregroundMark x1="49130" y1="22933" x2="49130" y2="22933"/>
-                        <a14:foregroundMark x1="67283" y1="17067" x2="67283" y2="17067"/>
-                        <a14:foregroundMark x1="67283" y1="16800" x2="67283" y2="16800"/>
-                        <a14:foregroundMark x1="67283" y1="16267" x2="67283" y2="16267"/>
-                      </a14:backgroundRemoval>
-                    </a14:imgEffect>
-                  </a14:imgLayer>
-                </a14:imgProps>
-              </a:ext>
-            </a:extLst>
-          </a:blip>
-          <a:stretch>
-            <a:fillRect/>
-          </a:stretch>
-        </p:blipFill>
-        <p:spPr>
-          <a:xfrm>
-            <a:off x="312470" y="5379104"/>
-            <a:ext cx="3037028" cy="1234618"/>
-          </a:xfrm>
-          <a:prstGeom prst="rect">
-            <a:avLst/>
-          </a:prstGeom>
-        </p:spPr>
-      </p:pic>
-    </p:spTree>
-    <p:extLst>
-      <p:ext uri="{BB962C8B-B14F-4D97-AF65-F5344CB8AC3E}">
-        <p14:creationId xmlns:p14="http://schemas.microsoft.com/office/powerpoint/2010/main" val="972951264"/>
-      </p:ext>
-    </p:extLst>
-  </p:cSld>
-  <p:clrMapOvr>
-    <a:masterClrMapping/>
-  </p:clrMapOvr>
 </p:sld>
 </file>
 
@@ -7978,14 +8012,14 @@
           </a:ln>
           <a:extLst>
             <a:ext uri="{909E8E84-426E-40dd-AFC4-6F175D3DCCD1}">
-              <a14:hiddenFill xmlns="" xmlns:a14="http://schemas.microsoft.com/office/drawing/2010/main">
+              <a14:hiddenFill xmlns:a14="http://schemas.microsoft.com/office/drawing/2010/main" xmlns="">
                 <a:solidFill>
                   <a:srgbClr val="FFFFFF"/>
                 </a:solidFill>
               </a14:hiddenFill>
             </a:ext>
             <a:ext uri="{91240B29-F687-4f45-9708-019B960494DF}">
-              <a14:hiddenLine xmlns="" xmlns:a14="http://schemas.microsoft.com/office/drawing/2010/main" w="9525">
+              <a14:hiddenLine xmlns:a14="http://schemas.microsoft.com/office/drawing/2010/main" xmlns="" w="9525">
                 <a:solidFill>
                   <a:srgbClr val="000000"/>
                 </a:solidFill>

</xml_diff>

<commit_message>
connor updated pptx for class 22
</commit_message>
<xml_diff>
--- a/docs/lectures/in-class_activities/class_22.pptx
+++ b/docs/lectures/in-class_activities/class_22.pptx
@@ -13,7 +13,7 @@
     <p:sldId id="1595" r:id="rId4"/>
     <p:sldId id="1596" r:id="rId5"/>
     <p:sldId id="1598" r:id="rId6"/>
-    <p:sldId id="1597" r:id="rId7"/>
+    <p:sldId id="1599" r:id="rId7"/>
     <p:sldId id="723" r:id="rId8"/>
     <p:sldId id="1590" r:id="rId9"/>
     <p:sldId id="1591" r:id="rId10"/>
@@ -1260,7 +1260,7 @@
         <p:cNvPr id="1" name="">
           <a:extLst>
             <a:ext uri="{FF2B5EF4-FFF2-40B4-BE49-F238E27FC236}">
-              <a16:creationId xmlns:a16="http://schemas.microsoft.com/office/drawing/2014/main" id="{03917AE8-F338-E0C9-0E18-228CA0654BD7}"/>
+              <a16:creationId xmlns:a16="http://schemas.microsoft.com/office/drawing/2014/main" id="{4A579E0C-2FF6-BB46-A47E-A751BECA5647}"/>
             </a:ext>
           </a:extLst>
         </p:cNvPr>
@@ -1280,7 +1280,7 @@
           <p:cNvPr id="2" name="Slide Image Placeholder 1">
             <a:extLst>
               <a:ext uri="{FF2B5EF4-FFF2-40B4-BE49-F238E27FC236}">
-                <a16:creationId xmlns:a16="http://schemas.microsoft.com/office/drawing/2014/main" id="{00E86FE6-BAC5-3501-459A-83AE558E3922}"/>
+                <a16:creationId xmlns:a16="http://schemas.microsoft.com/office/drawing/2014/main" id="{DD314810-5FDE-E461-CF48-4B49F84AD4B1}"/>
               </a:ext>
             </a:extLst>
           </p:cNvPr>
@@ -1298,7 +1298,7 @@
           <p:cNvPr id="3" name="Notes Placeholder 2">
             <a:extLst>
               <a:ext uri="{FF2B5EF4-FFF2-40B4-BE49-F238E27FC236}">
-                <a16:creationId xmlns:a16="http://schemas.microsoft.com/office/drawing/2014/main" id="{670E8B48-8DC2-D975-5B9C-C72DA12F1F91}"/>
+                <a16:creationId xmlns:a16="http://schemas.microsoft.com/office/drawing/2014/main" id="{822AAC63-79D6-F596-7BBA-E868CD0522D5}"/>
               </a:ext>
             </a:extLst>
           </p:cNvPr>
@@ -1323,7 +1323,7 @@
           <p:cNvPr id="4" name="Slide Number Placeholder 3">
             <a:extLst>
               <a:ext uri="{FF2B5EF4-FFF2-40B4-BE49-F238E27FC236}">
-                <a16:creationId xmlns:a16="http://schemas.microsoft.com/office/drawing/2014/main" id="{29029035-4079-374D-0D7B-75FCFE87AE79}"/>
+                <a16:creationId xmlns:a16="http://schemas.microsoft.com/office/drawing/2014/main" id="{17AF7365-3076-50C2-18FC-D8D89252D010}"/>
               </a:ext>
             </a:extLst>
           </p:cNvPr>
@@ -1350,7 +1350,7 @@
     </p:spTree>
     <p:extLst>
       <p:ext uri="{BB962C8B-B14F-4D97-AF65-F5344CB8AC3E}">
-        <p14:creationId xmlns:p14="http://schemas.microsoft.com/office/powerpoint/2010/main" val="1069863724"/>
+        <p14:creationId xmlns:p14="http://schemas.microsoft.com/office/powerpoint/2010/main" val="3459697112"/>
       </p:ext>
     </p:extLst>
   </p:cSld>
@@ -5632,7 +5632,7 @@
                 <a:latin typeface="Avenir"/>
                 <a:cs typeface="Avenir"/>
               </a:rPr>
-              <a:t>Part 1: The Roles</a:t>
+              <a:t>The Roles</a:t>
             </a:r>
             <a:endParaRPr lang="en-US" sz="3500" b="1" i="1" dirty="0">
               <a:latin typeface="Avenir"/>
@@ -5784,7 +5784,7 @@
                 <a:latin typeface="Avenir"/>
                 <a:cs typeface="Avenir"/>
               </a:rPr>
-              <a:t>human </a:t>
+              <a:t>human liver </a:t>
             </a:r>
           </a:p>
           <a:p>
@@ -5798,7 +5798,7 @@
                 <a:latin typeface="Avenir"/>
                 <a:cs typeface="Avenir"/>
               </a:rPr>
-              <a:t>gametocytes</a:t>
+              <a:t>human erythrocytes</a:t>
             </a:r>
           </a:p>
           <a:p>
@@ -5808,18 +5808,11 @@
               <a:defRPr/>
             </a:pPr>
             <a:r>
-              <a:rPr lang="en-US" sz="2000" i="1" dirty="0">
-                <a:latin typeface="Avenir"/>
-                <a:cs typeface="Avenir"/>
-              </a:rPr>
-              <a:t>Plasmodium </a:t>
-            </a:r>
-            <a:r>
               <a:rPr lang="en-US" sz="2000" dirty="0">
                 <a:latin typeface="Avenir"/>
                 <a:cs typeface="Avenir"/>
               </a:rPr>
-              <a:t>parasite</a:t>
+              <a:t>gametocytes</a:t>
             </a:r>
             <a:endParaRPr lang="en-US" sz="2000" i="1" dirty="0">
               <a:latin typeface="Avenir"/>
@@ -6116,7 +6109,7 @@
                 <a:latin typeface="Avenir"/>
                 <a:cs typeface="Avenir"/>
               </a:rPr>
-              <a:t>Part 1: The Task</a:t>
+              <a:t>The Task</a:t>
             </a:r>
             <a:endParaRPr lang="en-US" sz="3500" b="1" i="1" dirty="0">
               <a:latin typeface="Avenir"/>
@@ -6142,7 +6135,7 @@
         <p:spPr bwMode="auto">
           <a:xfrm>
             <a:off x="4809761" y="1235405"/>
-            <a:ext cx="6819581" cy="4708981"/>
+            <a:ext cx="6819581" cy="3785652"/>
           </a:xfrm>
           <a:prstGeom prst="rect">
             <a:avLst/>
@@ -6198,19 +6191,8 @@
                 <a:latin typeface="Avenir"/>
                 <a:cs typeface="Avenir"/>
               </a:rPr>
-              <a:t>is and what part of a human you are referencing. Later, you will present your case for what this life cycle looks like to the whole class as a group.</a:t>
-            </a:r>
-          </a:p>
-          <a:p>
-            <a:pPr marL="457200" indent="-457200">
-              <a:buFontTx/>
-              <a:buChar char="-"/>
-              <a:defRPr/>
-            </a:pPr>
-            <a:endParaRPr lang="en-US" sz="3000" dirty="0">
-              <a:latin typeface="Avenir"/>
-              <a:cs typeface="Avenir"/>
-            </a:endParaRPr>
+              <a:t>is and what part of a human you are referencing. How will you express what the parasite is doing during your role?</a:t>
+            </a:r>
           </a:p>
         </p:txBody>
       </p:sp>
@@ -6471,7 +6453,7 @@
                 <a:latin typeface="Avenir"/>
                 <a:cs typeface="Avenir"/>
               </a:rPr>
-              <a:t>Part 3: Life Cycle </a:t>
+              <a:t>The Life Cycle </a:t>
             </a:r>
             <a:endParaRPr lang="en-US" sz="3500" b="1" i="1" dirty="0">
               <a:latin typeface="Avenir"/>
@@ -6733,12 +6715,20 @@
 <file path=ppt/slides/slide6.xml><?xml version="1.0" encoding="utf-8"?>
 <p:sld xmlns:a="http://schemas.openxmlformats.org/drawingml/2006/main" xmlns:r="http://schemas.openxmlformats.org/officeDocument/2006/relationships" xmlns:p="http://schemas.openxmlformats.org/presentationml/2006/main">
   <p:cSld>
+    <p:bg>
+      <p:bgPr>
+        <a:solidFill>
+          <a:schemeClr val="tx1"/>
+        </a:solidFill>
+        <a:effectLst/>
+      </p:bgPr>
+    </p:bg>
     <p:spTree>
       <p:nvGrpSpPr>
         <p:cNvPr id="1" name="">
           <a:extLst>
             <a:ext uri="{FF2B5EF4-FFF2-40B4-BE49-F238E27FC236}">
-              <a16:creationId xmlns:a16="http://schemas.microsoft.com/office/drawing/2014/main" id="{F779FEC8-5205-DDC9-7184-6FC7E1DB802B}"/>
+              <a16:creationId xmlns:a16="http://schemas.microsoft.com/office/drawing/2014/main" id="{071E6F21-CA5C-59A3-F66E-EB7FDA09AF09}"/>
             </a:ext>
           </a:extLst>
         </p:cNvPr>
@@ -6755,10 +6745,10 @@
       </p:grpSpPr>
       <p:sp>
         <p:nvSpPr>
-          <p:cNvPr id="3" name="Rectangle 2">
-            <a:extLst>
-              <a:ext uri="{FF2B5EF4-FFF2-40B4-BE49-F238E27FC236}">
-                <a16:creationId xmlns:a16="http://schemas.microsoft.com/office/drawing/2014/main" id="{9DF9C34E-4CD8-773E-46D2-D09D16BCF3EF}"/>
+          <p:cNvPr id="2" name="Rectangle 2">
+            <a:extLst>
+              <a:ext uri="{FF2B5EF4-FFF2-40B4-BE49-F238E27FC236}">
+                <a16:creationId xmlns:a16="http://schemas.microsoft.com/office/drawing/2014/main" id="{FC3C5743-AD32-DABA-BD3F-61717FA25615}"/>
               </a:ext>
             </a:extLst>
           </p:cNvPr>
@@ -6769,8 +6759,8 @@
         </p:nvSpPr>
         <p:spPr bwMode="auto">
           <a:xfrm>
-            <a:off x="688454" y="375465"/>
-            <a:ext cx="10815091" cy="630942"/>
+            <a:off x="352524" y="2644170"/>
+            <a:ext cx="10896600" cy="830997"/>
           </a:xfrm>
           <a:prstGeom prst="rect">
             <a:avLst/>
@@ -6790,438 +6780,41 @@
           </a:bodyPr>
           <a:lstStyle/>
           <a:p>
-            <a:pPr algn="ctr">
-              <a:defRPr/>
-            </a:pPr>
-            <a:r>
-              <a:rPr lang="en-US" sz="3500" b="1" dirty="0">
-                <a:latin typeface="Avenir"/>
-                <a:cs typeface="Avenir"/>
-              </a:rPr>
-              <a:t>Part 2: Devastation</a:t>
-            </a:r>
-            <a:endParaRPr lang="en-US" sz="3500" b="1" i="1" dirty="0">
-              <a:latin typeface="Avenir"/>
-              <a:cs typeface="Avenir"/>
-            </a:endParaRPr>
-          </a:p>
-        </p:txBody>
-      </p:sp>
-      <p:sp>
-        <p:nvSpPr>
-          <p:cNvPr id="4" name="Rectangle 3">
-            <a:extLst>
-              <a:ext uri="{FF2B5EF4-FFF2-40B4-BE49-F238E27FC236}">
-                <a16:creationId xmlns:a16="http://schemas.microsoft.com/office/drawing/2014/main" id="{376CDA1F-99B5-39E4-EA01-6EA19C72DF2D}"/>
-              </a:ext>
-            </a:extLst>
-          </p:cNvPr>
-          <p:cNvSpPr>
-            <a:spLocks noChangeArrowheads="1"/>
-          </p:cNvSpPr>
-          <p:nvPr/>
-        </p:nvSpPr>
-        <p:spPr bwMode="auto">
-          <a:xfrm>
-            <a:off x="5737867" y="1319357"/>
-            <a:ext cx="6141663" cy="4247317"/>
-          </a:xfrm>
-          <a:prstGeom prst="rect">
-            <a:avLst/>
-          </a:prstGeom>
-          <a:noFill/>
-          <a:ln w="9525">
-            <a:noFill/>
-            <a:miter lim="800000"/>
-            <a:headEnd/>
-            <a:tailEnd/>
-          </a:ln>
-          <a:effectLst/>
-        </p:spPr>
-        <p:txBody>
-          <a:bodyPr wrap="square">
-            <a:spAutoFit/>
-          </a:bodyPr>
-          <a:lstStyle/>
-          <a:p>
             <a:pPr>
               <a:defRPr/>
             </a:pPr>
             <a:r>
-              <a:rPr lang="en-US" sz="3000" dirty="0">
-                <a:latin typeface="Avenir"/>
+              <a:rPr lang="en-US" sz="4800" b="1" dirty="0">
+                <a:solidFill>
+                  <a:schemeClr val="bg1">
+                    <a:lumMod val="65000"/>
+                  </a:schemeClr>
+                </a:solidFill>
+                <a:latin typeface="Avenir Book" panose="02000503020000020003" pitchFamily="2" charset="0"/>
                 <a:cs typeface="Avenir"/>
               </a:rPr>
-              <a:t>Now imagine you want your life cycle to impact humans in the deadliest way possible. How might you exploit parts of your life cycle to deliver maximum carnage on your human host? Would you choose to be a </a:t>
-            </a:r>
-            <a:r>
-              <a:rPr lang="en-US" sz="3000" i="1" dirty="0">
-                <a:latin typeface="Avenir"/>
-                <a:cs typeface="Avenir"/>
-              </a:rPr>
-              <a:t>P. falciparum, P. vivax,</a:t>
-            </a:r>
-            <a:r>
-              <a:rPr lang="en-US" sz="3000" dirty="0">
-                <a:latin typeface="Avenir"/>
-                <a:cs typeface="Avenir"/>
-              </a:rPr>
-              <a:t> </a:t>
-            </a:r>
-            <a:r>
-              <a:rPr lang="en-US" sz="3000" i="1" dirty="0">
-                <a:latin typeface="Avenir"/>
-                <a:cs typeface="Avenir"/>
-              </a:rPr>
-              <a:t>P. </a:t>
-            </a:r>
-            <a:r>
-              <a:rPr lang="en-US" sz="3000" i="1" dirty="0" err="1">
-                <a:latin typeface="Avenir"/>
-                <a:cs typeface="Avenir"/>
-              </a:rPr>
-              <a:t>ovale</a:t>
-            </a:r>
-            <a:r>
-              <a:rPr lang="en-US" sz="3000" i="1" dirty="0">
-                <a:latin typeface="Avenir"/>
-                <a:cs typeface="Avenir"/>
-              </a:rPr>
-              <a:t>, </a:t>
-            </a:r>
-            <a:r>
-              <a:rPr lang="en-US" sz="3000" dirty="0">
-                <a:latin typeface="Avenir"/>
-                <a:cs typeface="Avenir"/>
-              </a:rPr>
-              <a:t>or </a:t>
-            </a:r>
-            <a:r>
-              <a:rPr lang="en-US" sz="3000" i="1" dirty="0">
-                <a:latin typeface="Avenir"/>
-                <a:cs typeface="Avenir"/>
-              </a:rPr>
-              <a:t>P. malariae</a:t>
-            </a:r>
-            <a:r>
-              <a:rPr lang="en-US" sz="3000" dirty="0">
-                <a:latin typeface="Avenir"/>
-                <a:cs typeface="Avenir"/>
-              </a:rPr>
-              <a:t>? Why?</a:t>
-            </a:r>
-            <a:r>
-              <a:rPr lang="en-US" sz="3000" i="1" dirty="0">
-                <a:latin typeface="Avenir"/>
-                <a:cs typeface="Avenir"/>
-              </a:rPr>
-              <a:t> </a:t>
-            </a:r>
-            <a:endParaRPr lang="en-US" sz="3000" dirty="0">
-              <a:latin typeface="Avenir"/>
+              <a:t>Additional Questions</a:t>
+            </a:r>
+            <a:endParaRPr lang="en-US" sz="4800" i="1" dirty="0">
+              <a:solidFill>
+                <a:srgbClr val="FFFFFF"/>
+              </a:solidFill>
+              <a:latin typeface="Avenir Book" panose="02000503020000020003" pitchFamily="2" charset="0"/>
               <a:cs typeface="Avenir"/>
             </a:endParaRPr>
           </a:p>
         </p:txBody>
       </p:sp>
-      <p:sp>
-        <p:nvSpPr>
-          <p:cNvPr id="7" name="Rectangle 6">
-            <a:extLst>
-              <a:ext uri="{FF2B5EF4-FFF2-40B4-BE49-F238E27FC236}">
-                <a16:creationId xmlns:a16="http://schemas.microsoft.com/office/drawing/2014/main" id="{3A60D4A0-A555-B460-C0A8-10C2B4201D67}"/>
-              </a:ext>
-            </a:extLst>
-          </p:cNvPr>
-          <p:cNvSpPr>
-            <a:spLocks noChangeArrowheads="1"/>
-          </p:cNvSpPr>
-          <p:nvPr/>
-        </p:nvSpPr>
-        <p:spPr bwMode="auto">
-          <a:xfrm>
-            <a:off x="3394451" y="5879624"/>
-            <a:ext cx="8797549" cy="492443"/>
-          </a:xfrm>
-          <a:prstGeom prst="rect">
-            <a:avLst/>
-          </a:prstGeom>
-          <a:noFill/>
-          <a:ln w="9525">
-            <a:noFill/>
-            <a:miter lim="800000"/>
-            <a:headEnd/>
-            <a:tailEnd/>
-          </a:ln>
-          <a:effectLst/>
-        </p:spPr>
-        <p:txBody>
-          <a:bodyPr wrap="square">
-            <a:spAutoFit/>
-          </a:bodyPr>
-          <a:lstStyle/>
-          <a:p>
-            <a:pPr>
-              <a:defRPr/>
-            </a:pPr>
-            <a:r>
-              <a:rPr lang="en-US" sz="2600" b="1" dirty="0">
-                <a:latin typeface="Avenir"/>
-                <a:cs typeface="Avenir"/>
-              </a:rPr>
-              <a:t>Discuss with your group (2 min), and with the class (3 min)  </a:t>
-            </a:r>
-          </a:p>
-        </p:txBody>
-      </p:sp>
-      <p:pic>
-        <p:nvPicPr>
-          <p:cNvPr id="9" name="Picture 8">
-            <a:extLst>
-              <a:ext uri="{FF2B5EF4-FFF2-40B4-BE49-F238E27FC236}">
-                <a16:creationId xmlns:a16="http://schemas.microsoft.com/office/drawing/2014/main" id="{AA25631C-C363-4EFE-6423-6686587460E8}"/>
-              </a:ext>
-            </a:extLst>
-          </p:cNvPr>
-          <p:cNvPicPr>
-            <a:picLocks noChangeAspect="1"/>
-          </p:cNvPicPr>
-          <p:nvPr/>
-        </p:nvPicPr>
-        <p:blipFill>
-          <a:blip r:embed="rId3">
-            <a:extLst>
-              <a:ext uri="{BEBA8EAE-BF5A-486C-A8C5-ECC9F3942E4B}">
-                <a14:imgProps xmlns:a14="http://schemas.microsoft.com/office/drawing/2010/main">
-                  <a14:imgLayer r:embed="rId4">
-                    <a14:imgEffect>
-                      <a14:backgroundRemoval t="9867" b="89867" l="6196" r="91630">
-                        <a14:foregroundMark x1="39022" y1="64000" x2="39022" y2="64000"/>
-                        <a14:foregroundMark x1="10000" y1="55200" x2="10000" y2="55200"/>
-                        <a14:foregroundMark x1="6304" y1="63467" x2="6304" y2="63467"/>
-                        <a14:foregroundMark x1="12935" y1="81067" x2="12935" y2="81067"/>
-                        <a14:foregroundMark x1="12500" y1="78933" x2="12500" y2="78933"/>
-                        <a14:foregroundMark x1="13152" y1="78933" x2="13152" y2="78933"/>
-                        <a14:foregroundMark x1="46413" y1="79467" x2="46413" y2="79467"/>
-                        <a14:foregroundMark x1="36630" y1="39200" x2="36630" y2="39200"/>
-                        <a14:foregroundMark x1="36630" y1="38667" x2="36630" y2="38667"/>
-                        <a14:foregroundMark x1="36630" y1="38400" x2="36630" y2="38400"/>
-                        <a14:foregroundMark x1="36630" y1="37867" x2="36630" y2="37867"/>
-                        <a14:foregroundMark x1="36630" y1="37867" x2="36630" y2="37867"/>
-                        <a14:foregroundMark x1="36630" y1="36800" x2="36630" y2="36800"/>
-                        <a14:foregroundMark x1="30109" y1="29067" x2="30109" y2="29067"/>
-                        <a14:foregroundMark x1="30326" y1="29067" x2="30326" y2="29067"/>
-                        <a14:foregroundMark x1="29891" y1="34667" x2="29891" y2="34667"/>
-                        <a14:foregroundMark x1="30109" y1="34667" x2="30109" y2="34667"/>
-                        <a14:foregroundMark x1="30543" y1="35733" x2="30543" y2="35733"/>
-                        <a14:foregroundMark x1="40326" y1="26400" x2="40326" y2="26400"/>
-                        <a14:foregroundMark x1="40761" y1="26400" x2="40761" y2="26400"/>
-                        <a14:foregroundMark x1="40761" y1="33067" x2="40761" y2="33067"/>
-                        <a14:foregroundMark x1="39891" y1="37333" x2="39891" y2="37333"/>
-                        <a14:foregroundMark x1="38261" y1="38667" x2="38261" y2="38667"/>
-                        <a14:foregroundMark x1="44565" y1="22933" x2="44565" y2="22933"/>
-                        <a14:foregroundMark x1="44783" y1="22933" x2="44783" y2="22933"/>
-                        <a14:foregroundMark x1="49130" y1="15733" x2="49130" y2="15733"/>
-                        <a14:foregroundMark x1="54783" y1="22400" x2="54783" y2="22400"/>
-                        <a14:foregroundMark x1="52935" y1="29600" x2="52935" y2="29600"/>
-                        <a14:foregroundMark x1="38043" y1="29600" x2="38043" y2="29600"/>
-                        <a14:foregroundMark x1="67500" y1="26933" x2="67500" y2="26933"/>
-                        <a14:foregroundMark x1="66739" y1="19733" x2="66739" y2="19733"/>
-                        <a14:foregroundMark x1="88043" y1="16800" x2="88043" y2="16800"/>
-                        <a14:foregroundMark x1="84674" y1="16800" x2="84674" y2="16800"/>
-                        <a14:foregroundMark x1="85326" y1="22933" x2="85326" y2="22933"/>
-                        <a14:foregroundMark x1="90326" y1="24800" x2="90326" y2="24800"/>
-                        <a14:foregroundMark x1="91630" y1="18133" x2="91630" y2="18133"/>
-                        <a14:foregroundMark x1="72174" y1="20267" x2="72174" y2="20267"/>
-                        <a14:foregroundMark x1="72935" y1="25867" x2="72935" y2="25867"/>
-                        <a14:foregroundMark x1="52935" y1="17067" x2="52935" y2="17067"/>
-                        <a14:foregroundMark x1="53696" y1="17067" x2="53696" y2="17067"/>
-                        <a14:foregroundMark x1="38696" y1="24800" x2="38696" y2="24800"/>
-                        <a14:foregroundMark x1="17174" y1="20800" x2="17174" y2="20800"/>
-                        <a14:foregroundMark x1="18152" y1="20800" x2="18152" y2="20800"/>
-                        <a14:foregroundMark x1="18804" y1="17600" x2="18804" y2="17600"/>
-                        <a14:foregroundMark x1="18804" y1="16267" x2="18804" y2="16267"/>
-                        <a14:foregroundMark x1="12717" y1="32000" x2="12717" y2="32000"/>
-                        <a14:foregroundMark x1="12500" y1="13067" x2="12500" y2="13067"/>
-                        <a14:foregroundMark x1="12500" y1="12533" x2="12500" y2="12533"/>
-                        <a14:foregroundMark x1="34457" y1="26400" x2="34457" y2="26400"/>
-                        <a14:foregroundMark x1="49130" y1="22933" x2="49130" y2="22933"/>
-                        <a14:foregroundMark x1="67283" y1="17067" x2="67283" y2="17067"/>
-                        <a14:foregroundMark x1="67283" y1="16800" x2="67283" y2="16800"/>
-                        <a14:foregroundMark x1="67283" y1="16267" x2="67283" y2="16267"/>
-                      </a14:backgroundRemoval>
-                    </a14:imgEffect>
-                  </a14:imgLayer>
-                </a14:imgProps>
-              </a:ext>
-            </a:extLst>
-          </a:blip>
-          <a:stretch>
-            <a:fillRect/>
-          </a:stretch>
-        </p:blipFill>
-        <p:spPr>
-          <a:xfrm>
-            <a:off x="312470" y="5379104"/>
-            <a:ext cx="3037028" cy="1234618"/>
-          </a:xfrm>
-          <a:prstGeom prst="rect">
-            <a:avLst/>
-          </a:prstGeom>
-        </p:spPr>
-      </p:pic>
-      <p:pic>
-        <p:nvPicPr>
-          <p:cNvPr id="8" name="Picture 2" descr="P">
-            <a:extLst>
-              <a:ext uri="{FF2B5EF4-FFF2-40B4-BE49-F238E27FC236}">
-                <a16:creationId xmlns:a16="http://schemas.microsoft.com/office/drawing/2014/main" id="{1642A8F8-6F3F-EBC3-6940-5347527EDEE0}"/>
-              </a:ext>
-            </a:extLst>
-          </p:cNvPr>
-          <p:cNvPicPr>
-            <a:picLocks noChangeAspect="1" noChangeArrowheads="1"/>
-          </p:cNvPicPr>
-          <p:nvPr/>
-        </p:nvPicPr>
-        <p:blipFill>
-          <a:blip r:embed="rId5">
-            <a:extLst>
-              <a:ext uri="{28A0092B-C50C-407E-A947-70E740481C1C}">
-                <a14:useLocalDpi xmlns:a14="http://schemas.microsoft.com/office/drawing/2010/main" val="0"/>
-              </a:ext>
-            </a:extLst>
-          </a:blip>
-          <a:srcRect/>
-          <a:stretch>
-            <a:fillRect/>
-          </a:stretch>
-        </p:blipFill>
-        <p:spPr bwMode="auto">
-          <a:xfrm>
-            <a:off x="479856" y="1319357"/>
-            <a:ext cx="4968887" cy="3646779"/>
-          </a:xfrm>
-          <a:prstGeom prst="rect">
-            <a:avLst/>
-          </a:prstGeom>
-          <a:noFill/>
-          <a:ln>
-            <a:noFill/>
-          </a:ln>
-          <a:extLst>
-            <a:ext uri="{909E8E84-426E-40dd-AFC4-6F175D3DCCD1}">
-              <a14:hiddenFill xmlns="" xmlns:a14="http://schemas.microsoft.com/office/drawing/2010/main">
-                <a:solidFill>
-                  <a:srgbClr val="FFFFFF"/>
-                </a:solidFill>
-              </a14:hiddenFill>
-            </a:ext>
-            <a:ext uri="{91240B29-F687-4f45-9708-019B960494DF}">
-              <a14:hiddenLine xmlns="" xmlns:a14="http://schemas.microsoft.com/office/drawing/2010/main" w="9525">
-                <a:solidFill>
-                  <a:srgbClr val="000000"/>
-                </a:solidFill>
-                <a:miter lim="800000"/>
-                <a:headEnd/>
-                <a:tailEnd/>
-              </a14:hiddenLine>
-            </a:ext>
-          </a:extLst>
-        </p:spPr>
-      </p:pic>
     </p:spTree>
     <p:extLst>
       <p:ext uri="{BB962C8B-B14F-4D97-AF65-F5344CB8AC3E}">
-        <p14:creationId xmlns:p14="http://schemas.microsoft.com/office/powerpoint/2010/main" val="3982640783"/>
+        <p14:creationId xmlns:p14="http://schemas.microsoft.com/office/powerpoint/2010/main" val="3859364905"/>
       </p:ext>
     </p:extLst>
   </p:cSld>
   <p:clrMapOvr>
     <a:masterClrMapping/>
   </p:clrMapOvr>
-  <p:timing>
-    <p:tnLst>
-      <p:par>
-        <p:cTn id="1" dur="indefinite" restart="never" nodeType="tmRoot">
-          <p:childTnLst>
-            <p:seq concurrent="1" nextAc="seek">
-              <p:cTn id="2" dur="indefinite" nodeType="mainSeq">
-                <p:childTnLst>
-                  <p:par>
-                    <p:cTn id="3" fill="hold">
-                      <p:stCondLst>
-                        <p:cond delay="indefinite"/>
-                      </p:stCondLst>
-                      <p:childTnLst>
-                        <p:par>
-                          <p:cTn id="4" fill="hold">
-                            <p:stCondLst>
-                              <p:cond delay="0"/>
-                            </p:stCondLst>
-                            <p:childTnLst>
-                              <p:par>
-                                <p:cTn id="5" presetID="1" presetClass="entr" presetSubtype="0" fill="hold" grpId="0" nodeType="clickEffect">
-                                  <p:stCondLst>
-                                    <p:cond delay="0"/>
-                                  </p:stCondLst>
-                                  <p:childTnLst>
-                                    <p:set>
-                                      <p:cBhvr>
-                                        <p:cTn id="6" dur="1" fill="hold">
-                                          <p:stCondLst>
-                                            <p:cond delay="0"/>
-                                          </p:stCondLst>
-                                        </p:cTn>
-                                        <p:tgtEl>
-                                          <p:spTgt spid="4">
-                                            <p:txEl>
-                                              <p:pRg st="0" end="0"/>
-                                            </p:txEl>
-                                          </p:spTgt>
-                                        </p:tgtEl>
-                                        <p:attrNameLst>
-                                          <p:attrName>style.visibility</p:attrName>
-                                        </p:attrNameLst>
-                                      </p:cBhvr>
-                                      <p:to>
-                                        <p:strVal val="visible"/>
-                                      </p:to>
-                                    </p:set>
-                                  </p:childTnLst>
-                                </p:cTn>
-                              </p:par>
-                            </p:childTnLst>
-                          </p:cTn>
-                        </p:par>
-                      </p:childTnLst>
-                    </p:cTn>
-                  </p:par>
-                </p:childTnLst>
-              </p:cTn>
-              <p:prevCondLst>
-                <p:cond evt="onPrev" delay="0">
-                  <p:tgtEl>
-                    <p:sldTgt/>
-                  </p:tgtEl>
-                </p:cond>
-              </p:prevCondLst>
-              <p:nextCondLst>
-                <p:cond evt="onNext" delay="0">
-                  <p:tgtEl>
-                    <p:sldTgt/>
-                  </p:tgtEl>
-                </p:cond>
-              </p:nextCondLst>
-            </p:seq>
-          </p:childTnLst>
-        </p:cTn>
-      </p:par>
-    </p:tnLst>
-    <p:bldLst>
-      <p:bldP spid="4" grpId="0" uiExpand="1" build="p" bldLvl="5"/>
-    </p:bldLst>
-  </p:timing>
 </p:sld>
 </file>
 
@@ -8012,14 +7605,14 @@
           </a:ln>
           <a:extLst>
             <a:ext uri="{909E8E84-426E-40dd-AFC4-6F175D3DCCD1}">
-              <a14:hiddenFill xmlns:a14="http://schemas.microsoft.com/office/drawing/2010/main" xmlns="">
+              <a14:hiddenFill xmlns="" xmlns:a14="http://schemas.microsoft.com/office/drawing/2010/main">
                 <a:solidFill>
                   <a:srgbClr val="FFFFFF"/>
                 </a:solidFill>
               </a14:hiddenFill>
             </a:ext>
             <a:ext uri="{91240B29-F687-4f45-9708-019B960494DF}">
-              <a14:hiddenLine xmlns:a14="http://schemas.microsoft.com/office/drawing/2010/main" xmlns="" w="9525">
+              <a14:hiddenLine xmlns="" xmlns:a14="http://schemas.microsoft.com/office/drawing/2010/main" w="9525">
                 <a:solidFill>
                   <a:srgbClr val="000000"/>
                 </a:solidFill>

</xml_diff>

<commit_message>
updating ppts and agenda for class 23
</commit_message>
<xml_diff>
--- a/docs/lectures/in-class_activities/class_22.pptx
+++ b/docs/lectures/in-class_activities/class_22.pptx
@@ -208,7 +208,7 @@
           <a:p>
             <a:fld id="{6AC7DB66-C6D6-B24E-B345-FA3772C924EA}" type="datetimeFigureOut">
               <a:rPr lang="en-US" smtClean="0"/>
-              <a:t>11/21/25</a:t>
+              <a:t>11/24/25</a:t>
             </a:fld>
             <a:endParaRPr lang="en-US"/>
           </a:p>
@@ -1782,7 +1782,7 @@
           <a:p>
             <a:fld id="{21DDE3A9-9D48-7D40-AF95-520AE186EA5D}" type="datetimeFigureOut">
               <a:rPr lang="en-US" smtClean="0"/>
-              <a:t>11/21/25</a:t>
+              <a:t>11/24/25</a:t>
             </a:fld>
             <a:endParaRPr lang="en-US"/>
           </a:p>
@@ -1980,7 +1980,7 @@
           <a:p>
             <a:fld id="{21DDE3A9-9D48-7D40-AF95-520AE186EA5D}" type="datetimeFigureOut">
               <a:rPr lang="en-US" smtClean="0"/>
-              <a:t>11/21/25</a:t>
+              <a:t>11/24/25</a:t>
             </a:fld>
             <a:endParaRPr lang="en-US"/>
           </a:p>
@@ -2188,7 +2188,7 @@
           <a:p>
             <a:fld id="{21DDE3A9-9D48-7D40-AF95-520AE186EA5D}" type="datetimeFigureOut">
               <a:rPr lang="en-US" smtClean="0"/>
-              <a:t>11/21/25</a:t>
+              <a:t>11/24/25</a:t>
             </a:fld>
             <a:endParaRPr lang="en-US"/>
           </a:p>
@@ -2386,7 +2386,7 @@
           <a:p>
             <a:fld id="{21DDE3A9-9D48-7D40-AF95-520AE186EA5D}" type="datetimeFigureOut">
               <a:rPr lang="en-US" smtClean="0"/>
-              <a:t>11/21/25</a:t>
+              <a:t>11/24/25</a:t>
             </a:fld>
             <a:endParaRPr lang="en-US"/>
           </a:p>
@@ -2661,7 +2661,7 @@
           <a:p>
             <a:fld id="{21DDE3A9-9D48-7D40-AF95-520AE186EA5D}" type="datetimeFigureOut">
               <a:rPr lang="en-US" smtClean="0"/>
-              <a:t>11/21/25</a:t>
+              <a:t>11/24/25</a:t>
             </a:fld>
             <a:endParaRPr lang="en-US"/>
           </a:p>
@@ -2926,7 +2926,7 @@
           <a:p>
             <a:fld id="{21DDE3A9-9D48-7D40-AF95-520AE186EA5D}" type="datetimeFigureOut">
               <a:rPr lang="en-US" smtClean="0"/>
-              <a:t>11/21/25</a:t>
+              <a:t>11/24/25</a:t>
             </a:fld>
             <a:endParaRPr lang="en-US"/>
           </a:p>
@@ -3338,7 +3338,7 @@
           <a:p>
             <a:fld id="{21DDE3A9-9D48-7D40-AF95-520AE186EA5D}" type="datetimeFigureOut">
               <a:rPr lang="en-US" smtClean="0"/>
-              <a:t>11/21/25</a:t>
+              <a:t>11/24/25</a:t>
             </a:fld>
             <a:endParaRPr lang="en-US"/>
           </a:p>
@@ -3479,7 +3479,7 @@
           <a:p>
             <a:fld id="{21DDE3A9-9D48-7D40-AF95-520AE186EA5D}" type="datetimeFigureOut">
               <a:rPr lang="en-US" smtClean="0"/>
-              <a:t>11/21/25</a:t>
+              <a:t>11/24/25</a:t>
             </a:fld>
             <a:endParaRPr lang="en-US"/>
           </a:p>
@@ -3592,7 +3592,7 @@
           <a:p>
             <a:fld id="{21DDE3A9-9D48-7D40-AF95-520AE186EA5D}" type="datetimeFigureOut">
               <a:rPr lang="en-US" smtClean="0"/>
-              <a:t>11/21/25</a:t>
+              <a:t>11/24/25</a:t>
             </a:fld>
             <a:endParaRPr lang="en-US"/>
           </a:p>
@@ -3903,7 +3903,7 @@
           <a:p>
             <a:fld id="{21DDE3A9-9D48-7D40-AF95-520AE186EA5D}" type="datetimeFigureOut">
               <a:rPr lang="en-US" smtClean="0"/>
-              <a:t>11/21/25</a:t>
+              <a:t>11/24/25</a:t>
             </a:fld>
             <a:endParaRPr lang="en-US"/>
           </a:p>
@@ -4191,7 +4191,7 @@
           <a:p>
             <a:fld id="{21DDE3A9-9D48-7D40-AF95-520AE186EA5D}" type="datetimeFigureOut">
               <a:rPr lang="en-US" smtClean="0"/>
-              <a:t>11/21/25</a:t>
+              <a:t>11/24/25</a:t>
             </a:fld>
             <a:endParaRPr lang="en-US"/>
           </a:p>
@@ -4432,7 +4432,7 @@
           <a:p>
             <a:fld id="{21DDE3A9-9D48-7D40-AF95-520AE186EA5D}" type="datetimeFigureOut">
               <a:rPr lang="en-US" smtClean="0"/>
-              <a:t>11/21/25</a:t>
+              <a:t>11/24/25</a:t>
             </a:fld>
             <a:endParaRPr lang="en-US"/>
           </a:p>
@@ -4901,7 +4901,7 @@
                 <a:latin typeface="Avenir Book" panose="02000503020000020003" pitchFamily="2" charset="0"/>
                 <a:cs typeface="Avenir"/>
               </a:rPr>
-              <a:t>Practical session 22</a:t>
+              <a:t>Class 22</a:t>
             </a:r>
             <a:r>
               <a:rPr lang="en-US" sz="4800" dirty="0">
@@ -5225,7 +5225,7 @@
               <a:defRPr/>
             </a:pPr>
             <a:r>
-              <a:rPr lang="en-US" sz="4800" b="1" dirty="0">
+              <a:rPr lang="en-US" sz="4800" b="1">
                 <a:solidFill>
                   <a:schemeClr val="bg1">
                     <a:lumMod val="65000"/>
@@ -5234,7 +5234,7 @@
                 <a:latin typeface="Avenir Book" panose="02000503020000020003" pitchFamily="2" charset="0"/>
                 <a:cs typeface="Avenir"/>
               </a:rPr>
-              <a:t>Practical session 22</a:t>
+              <a:t>Class 22</a:t>
             </a:r>
             <a:r>
               <a:rPr lang="en-US" sz="4800" dirty="0">
@@ -7615,14 +7615,14 @@
           </a:ln>
           <a:extLst>
             <a:ext uri="{909E8E84-426E-40dd-AFC4-6F175D3DCCD1}">
-              <a14:hiddenFill xmlns:a14="http://schemas.microsoft.com/office/drawing/2010/main" xmlns="">
+              <a14:hiddenFill xmlns="" xmlns:a14="http://schemas.microsoft.com/office/drawing/2010/main">
                 <a:solidFill>
                   <a:srgbClr val="FFFFFF"/>
                 </a:solidFill>
               </a14:hiddenFill>
             </a:ext>
             <a:ext uri="{91240B29-F687-4f45-9708-019B960494DF}">
-              <a14:hiddenLine xmlns:a14="http://schemas.microsoft.com/office/drawing/2010/main" xmlns="" w="9525">
+              <a14:hiddenLine xmlns="" xmlns:a14="http://schemas.microsoft.com/office/drawing/2010/main" w="9525">
                 <a:solidFill>
                   <a:srgbClr val="000000"/>
                 </a:solidFill>

</xml_diff>